<commit_message>
Website update — 2026-10-16
</commit_message>
<xml_diff>
--- a/history-and-foundations-of-artificial-intelligence/presentation/T5 AI Winters and Cycles of Progress.pptx
+++ b/history-and-foundations-of-artificial-intelligence/presentation/T5 AI Winters and Cycles of Progress.pptx
@@ -1,29 +1,2917 @@
 
 <file path=ppt/presentation.xml><?xml version="1.0" encoding="utf-8"?>
-<p:presentation xmlns:p="http://schemas.openxmlformats.org/presentationml/2006/main" xmlns:a="http://schemas.openxmlformats.org/drawingml/2006/main" xmlns:r="http://schemas.openxmlformats.org/officeDocument/2006/relationships" saveSubsetFonts="1">
+<p:presentation xmlns:a="http://schemas.openxmlformats.org/drawingml/2006/main" xmlns:r="http://schemas.openxmlformats.org/officeDocument/2006/relationships" xmlns:p="http://schemas.openxmlformats.org/presentationml/2006/main" saveSubsetFonts="1">
   <p:sldMasterIdLst>
     <p:sldMasterId id="2147483648" r:id="rId1"/>
   </p:sldMasterIdLst>
   <p:notesMasterIdLst>
-    <p:notesMasterId r:id="rId2"/>
+    <p:notesMasterId r:id="rId10"/>
   </p:notesMasterIdLst>
   <p:sldIdLst>
-    <p:sldId id="256" r:id="rId3"/>
-    <p:sldId id="257" r:id="rId4"/>
-    <p:sldId id="258" r:id="rId5"/>
-    <p:sldId id="259" r:id="rId6"/>
-    <p:sldId id="260" r:id="rId7"/>
-    <p:sldId id="261" r:id="rId8"/>
-    <p:sldId id="262" r:id="rId9"/>
-    <p:sldId id="263" r:id="rId10"/>
+    <p:sldId id="256" r:id="rId2"/>
+    <p:sldId id="257" r:id="rId3"/>
+    <p:sldId id="258" r:id="rId4"/>
+    <p:sldId id="259" r:id="rId5"/>
+    <p:sldId id="260" r:id="rId6"/>
+    <p:sldId id="261" r:id="rId7"/>
+    <p:sldId id="262" r:id="rId8"/>
+    <p:sldId id="263" r:id="rId9"/>
   </p:sldIdLst>
-  <p:sldSz cx="12192000" cy="6858000" type="custom"/>
+  <p:sldSz cx="12192000" cy="6858000"/>
   <p:notesSz cx="6858000" cy="9144000"/>
+  <p:defaultTextStyle>
+    <a:defPPr>
+      <a:defRPr lang="en-US"/>
+    </a:defPPr>
+    <a:lvl1pPr marL="0" algn="l" defTabSz="914400" rtl="0" eaLnBrk="1" latinLnBrk="0" hangingPunct="1">
+      <a:defRPr sz="1800" kern="1200">
+        <a:solidFill>
+          <a:schemeClr val="tx1"/>
+        </a:solidFill>
+        <a:latin typeface="+mn-lt"/>
+        <a:ea typeface="+mn-ea"/>
+        <a:cs typeface="+mn-cs"/>
+      </a:defRPr>
+    </a:lvl1pPr>
+    <a:lvl2pPr marL="457200" algn="l" defTabSz="914400" rtl="0" eaLnBrk="1" latinLnBrk="0" hangingPunct="1">
+      <a:defRPr sz="1800" kern="1200">
+        <a:solidFill>
+          <a:schemeClr val="tx1"/>
+        </a:solidFill>
+        <a:latin typeface="+mn-lt"/>
+        <a:ea typeface="+mn-ea"/>
+        <a:cs typeface="+mn-cs"/>
+      </a:defRPr>
+    </a:lvl2pPr>
+    <a:lvl3pPr marL="914400" algn="l" defTabSz="914400" rtl="0" eaLnBrk="1" latinLnBrk="0" hangingPunct="1">
+      <a:defRPr sz="1800" kern="1200">
+        <a:solidFill>
+          <a:schemeClr val="tx1"/>
+        </a:solidFill>
+        <a:latin typeface="+mn-lt"/>
+        <a:ea typeface="+mn-ea"/>
+        <a:cs typeface="+mn-cs"/>
+      </a:defRPr>
+    </a:lvl3pPr>
+    <a:lvl4pPr marL="1371600" algn="l" defTabSz="914400" rtl="0" eaLnBrk="1" latinLnBrk="0" hangingPunct="1">
+      <a:defRPr sz="1800" kern="1200">
+        <a:solidFill>
+          <a:schemeClr val="tx1"/>
+        </a:solidFill>
+        <a:latin typeface="+mn-lt"/>
+        <a:ea typeface="+mn-ea"/>
+        <a:cs typeface="+mn-cs"/>
+      </a:defRPr>
+    </a:lvl4pPr>
+    <a:lvl5pPr marL="1828800" algn="l" defTabSz="914400" rtl="0" eaLnBrk="1" latinLnBrk="0" hangingPunct="1">
+      <a:defRPr sz="1800" kern="1200">
+        <a:solidFill>
+          <a:schemeClr val="tx1"/>
+        </a:solidFill>
+        <a:latin typeface="+mn-lt"/>
+        <a:ea typeface="+mn-ea"/>
+        <a:cs typeface="+mn-cs"/>
+      </a:defRPr>
+    </a:lvl5pPr>
+    <a:lvl6pPr marL="2286000" algn="l" defTabSz="914400" rtl="0" eaLnBrk="1" latinLnBrk="0" hangingPunct="1">
+      <a:defRPr sz="1800" kern="1200">
+        <a:solidFill>
+          <a:schemeClr val="tx1"/>
+        </a:solidFill>
+        <a:latin typeface="+mn-lt"/>
+        <a:ea typeface="+mn-ea"/>
+        <a:cs typeface="+mn-cs"/>
+      </a:defRPr>
+    </a:lvl6pPr>
+    <a:lvl7pPr marL="2743200" algn="l" defTabSz="914400" rtl="0" eaLnBrk="1" latinLnBrk="0" hangingPunct="1">
+      <a:defRPr sz="1800" kern="1200">
+        <a:solidFill>
+          <a:schemeClr val="tx1"/>
+        </a:solidFill>
+        <a:latin typeface="+mn-lt"/>
+        <a:ea typeface="+mn-ea"/>
+        <a:cs typeface="+mn-cs"/>
+      </a:defRPr>
+    </a:lvl7pPr>
+    <a:lvl8pPr marL="3200400" algn="l" defTabSz="914400" rtl="0" eaLnBrk="1" latinLnBrk="0" hangingPunct="1">
+      <a:defRPr sz="1800" kern="1200">
+        <a:solidFill>
+          <a:schemeClr val="tx1"/>
+        </a:solidFill>
+        <a:latin typeface="+mn-lt"/>
+        <a:ea typeface="+mn-ea"/>
+        <a:cs typeface="+mn-cs"/>
+      </a:defRPr>
+    </a:lvl8pPr>
+    <a:lvl9pPr marL="3657600" algn="l" defTabSz="914400" rtl="0" eaLnBrk="1" latinLnBrk="0" hangingPunct="1">
+      <a:defRPr sz="1800" kern="1200">
+        <a:solidFill>
+          <a:schemeClr val="tx1"/>
+        </a:solidFill>
+        <a:latin typeface="+mn-lt"/>
+        <a:ea typeface="+mn-ea"/>
+        <a:cs typeface="+mn-cs"/>
+      </a:defRPr>
+    </a:lvl9pPr>
+  </p:defaultTextStyle>
 </p:presentation>
 </file>
 
+<file path=ppt/changesInfos/changesInfo1.xml><?xml version="1.0" encoding="utf-8"?>
+<pc:chgInfo xmlns:a="http://schemas.openxmlformats.org/drawingml/2006/main" xmlns:r="http://schemas.openxmlformats.org/officeDocument/2006/relationships" xmlns:ac="http://schemas.microsoft.com/office/drawing/2013/main/command" xmlns:pc="http://schemas.microsoft.com/office/powerpoint/2013/main/command">
+  <pc:docChgLst>
+    <pc:chgData name="Ronald Eaglin" userId="c6b87d18-4edc-427f-8929-d997ad231435" providerId="ADAL" clId="{F7EFB3B1-56A6-4C16-B59D-F434F55AC407}"/>
+    <pc:docChg chg="custSel modSld">
+      <pc:chgData name="Ronald Eaglin" userId="c6b87d18-4edc-427f-8929-d997ad231435" providerId="ADAL" clId="{F7EFB3B1-56A6-4C16-B59D-F434F55AC407}" dt="2026-10-16T18:19:49.504" v="1" actId="26606"/>
+      <pc:docMkLst>
+        <pc:docMk/>
+      </pc:docMkLst>
+      <pc:sldChg chg="addSp modSp mod setBg">
+        <pc:chgData name="Ronald Eaglin" userId="c6b87d18-4edc-427f-8929-d997ad231435" providerId="ADAL" clId="{F7EFB3B1-56A6-4C16-B59D-F434F55AC407}" dt="2026-10-16T18:19:43.017" v="0" actId="26606"/>
+        <pc:sldMkLst>
+          <pc:docMk/>
+          <pc:sldMk cId="0" sldId="256"/>
+        </pc:sldMkLst>
+        <pc:spChg chg="mod">
+          <ac:chgData name="Ronald Eaglin" userId="c6b87d18-4edc-427f-8929-d997ad231435" providerId="ADAL" clId="{F7EFB3B1-56A6-4C16-B59D-F434F55AC407}" dt="2026-10-16T18:19:43.017" v="0" actId="26606"/>
+          <ac:spMkLst>
+            <pc:docMk/>
+            <pc:sldMk cId="0" sldId="256"/>
+            <ac:spMk id="2" creationId="{00000000-0000-0000-0000-000000000000}"/>
+          </ac:spMkLst>
+        </pc:spChg>
+        <pc:spChg chg="mod">
+          <ac:chgData name="Ronald Eaglin" userId="c6b87d18-4edc-427f-8929-d997ad231435" providerId="ADAL" clId="{F7EFB3B1-56A6-4C16-B59D-F434F55AC407}" dt="2026-10-16T18:19:43.017" v="0" actId="26606"/>
+          <ac:spMkLst>
+            <pc:docMk/>
+            <pc:sldMk cId="0" sldId="256"/>
+            <ac:spMk id="3" creationId="{00000000-0000-0000-0000-000000000000}"/>
+          </ac:spMkLst>
+        </pc:spChg>
+        <pc:spChg chg="add">
+          <ac:chgData name="Ronald Eaglin" userId="c6b87d18-4edc-427f-8929-d997ad231435" providerId="ADAL" clId="{F7EFB3B1-56A6-4C16-B59D-F434F55AC407}" dt="2026-10-16T18:19:43.017" v="0" actId="26606"/>
+          <ac:spMkLst>
+            <pc:docMk/>
+            <pc:sldMk cId="0" sldId="256"/>
+            <ac:spMk id="8" creationId="{C2554CA6-288E-4202-BC52-2E5A8F0C0AED}"/>
+          </ac:spMkLst>
+        </pc:spChg>
+        <pc:spChg chg="add">
+          <ac:chgData name="Ronald Eaglin" userId="c6b87d18-4edc-427f-8929-d997ad231435" providerId="ADAL" clId="{F7EFB3B1-56A6-4C16-B59D-F434F55AC407}" dt="2026-10-16T18:19:43.017" v="0" actId="26606"/>
+          <ac:spMkLst>
+            <pc:docMk/>
+            <pc:sldMk cId="0" sldId="256"/>
+            <ac:spMk id="10" creationId="{B10BB131-AC8E-4A8E-A5D1-36260F720C3B}"/>
+          </ac:spMkLst>
+        </pc:spChg>
+        <pc:spChg chg="add">
+          <ac:chgData name="Ronald Eaglin" userId="c6b87d18-4edc-427f-8929-d997ad231435" providerId="ADAL" clId="{F7EFB3B1-56A6-4C16-B59D-F434F55AC407}" dt="2026-10-16T18:19:43.017" v="0" actId="26606"/>
+          <ac:spMkLst>
+            <pc:docMk/>
+            <pc:sldMk cId="0" sldId="256"/>
+            <ac:spMk id="12" creationId="{5B7778FC-632E-4DCA-A7CB-0D7731CCF970}"/>
+          </ac:spMkLst>
+        </pc:spChg>
+        <pc:spChg chg="add">
+          <ac:chgData name="Ronald Eaglin" userId="c6b87d18-4edc-427f-8929-d997ad231435" providerId="ADAL" clId="{F7EFB3B1-56A6-4C16-B59D-F434F55AC407}" dt="2026-10-16T18:19:43.017" v="0" actId="26606"/>
+          <ac:spMkLst>
+            <pc:docMk/>
+            <pc:sldMk cId="0" sldId="256"/>
+            <ac:spMk id="14" creationId="{FA23A907-97FB-4A8F-880A-DD77401C4296}"/>
+          </ac:spMkLst>
+        </pc:spChg>
+      </pc:sldChg>
+      <pc:sldChg chg="addSp delSp modSp mod setBg">
+        <pc:chgData name="Ronald Eaglin" userId="c6b87d18-4edc-427f-8929-d997ad231435" providerId="ADAL" clId="{F7EFB3B1-56A6-4C16-B59D-F434F55AC407}" dt="2026-10-16T18:19:49.504" v="1" actId="26606"/>
+        <pc:sldMkLst>
+          <pc:docMk/>
+          <pc:sldMk cId="0" sldId="257"/>
+        </pc:sldMkLst>
+        <pc:spChg chg="mod">
+          <ac:chgData name="Ronald Eaglin" userId="c6b87d18-4edc-427f-8929-d997ad231435" providerId="ADAL" clId="{F7EFB3B1-56A6-4C16-B59D-F434F55AC407}" dt="2026-10-16T18:19:49.504" v="1" actId="26606"/>
+          <ac:spMkLst>
+            <pc:docMk/>
+            <pc:sldMk cId="0" sldId="257"/>
+            <ac:spMk id="2" creationId="{00000000-0000-0000-0000-000000000000}"/>
+          </ac:spMkLst>
+        </pc:spChg>
+        <pc:spChg chg="del">
+          <ac:chgData name="Ronald Eaglin" userId="c6b87d18-4edc-427f-8929-d997ad231435" providerId="ADAL" clId="{F7EFB3B1-56A6-4C16-B59D-F434F55AC407}" dt="2026-10-16T18:19:49.504" v="1" actId="26606"/>
+          <ac:spMkLst>
+            <pc:docMk/>
+            <pc:sldMk cId="0" sldId="257"/>
+            <ac:spMk id="3" creationId="{00000000-0000-0000-0000-000000000000}"/>
+          </ac:spMkLst>
+        </pc:spChg>
+        <pc:spChg chg="add">
+          <ac:chgData name="Ronald Eaglin" userId="c6b87d18-4edc-427f-8929-d997ad231435" providerId="ADAL" clId="{F7EFB3B1-56A6-4C16-B59D-F434F55AC407}" dt="2026-10-16T18:19:49.504" v="1" actId="26606"/>
+          <ac:spMkLst>
+            <pc:docMk/>
+            <pc:sldMk cId="0" sldId="257"/>
+            <ac:spMk id="9" creationId="{C05CBC3C-2E5A-4839-8B9B-2E5A6ADF0F58}"/>
+          </ac:spMkLst>
+        </pc:spChg>
+        <pc:spChg chg="add">
+          <ac:chgData name="Ronald Eaglin" userId="c6b87d18-4edc-427f-8929-d997ad231435" providerId="ADAL" clId="{F7EFB3B1-56A6-4C16-B59D-F434F55AC407}" dt="2026-10-16T18:19:49.504" v="1" actId="26606"/>
+          <ac:spMkLst>
+            <pc:docMk/>
+            <pc:sldMk cId="0" sldId="257"/>
+            <ac:spMk id="11" creationId="{DB5B423A-57CC-4C58-AA26-8E2E862B03A0}"/>
+          </ac:spMkLst>
+        </pc:spChg>
+        <pc:graphicFrameChg chg="add">
+          <ac:chgData name="Ronald Eaglin" userId="c6b87d18-4edc-427f-8929-d997ad231435" providerId="ADAL" clId="{F7EFB3B1-56A6-4C16-B59D-F434F55AC407}" dt="2026-10-16T18:19:49.504" v="1" actId="26606"/>
+          <ac:graphicFrameMkLst>
+            <pc:docMk/>
+            <pc:sldMk cId="0" sldId="257"/>
+            <ac:graphicFrameMk id="5" creationId="{211F876E-7314-B580-D494-0D77F83517AE}"/>
+          </ac:graphicFrameMkLst>
+        </pc:graphicFrameChg>
+      </pc:sldChg>
+    </pc:docChg>
+  </pc:docChgLst>
+</pc:chgInfo>
+</file>
+
+<file path=ppt/diagrams/colors1.xml><?xml version="1.0" encoding="utf-8"?>
+<dgm:colorsDef xmlns:dgm="http://schemas.openxmlformats.org/drawingml/2006/diagram" xmlns:a="http://schemas.openxmlformats.org/drawingml/2006/main" uniqueId="urn:microsoft.com/office/officeart/2005/8/colors/colorful5">
+  <dgm:title val=""/>
+  <dgm:desc val=""/>
+  <dgm:catLst>
+    <dgm:cat type="colorful" pri="10500"/>
+  </dgm:catLst>
+  <dgm:styleLbl name="node0">
+    <dgm:fillClrLst meth="repeat">
+      <a:schemeClr val="accent4"/>
+    </dgm:fillClrLst>
+    <dgm:linClrLst meth="repeat">
+      <a:schemeClr val="lt1"/>
+    </dgm:linClrLst>
+    <dgm:effectClrLst/>
+    <dgm:txLinClrLst/>
+    <dgm:txFillClrLst/>
+    <dgm:txEffectClrLst/>
+  </dgm:styleLbl>
+  <dgm:styleLbl name="node1">
+    <dgm:fillClrLst>
+      <a:schemeClr val="accent5"/>
+      <a:schemeClr val="accent6"/>
+    </dgm:fillClrLst>
+    <dgm:linClrLst meth="repeat">
+      <a:schemeClr val="lt1"/>
+    </dgm:linClrLst>
+    <dgm:effectClrLst/>
+    <dgm:txLinClrLst/>
+    <dgm:txFillClrLst/>
+    <dgm:txEffectClrLst/>
+  </dgm:styleLbl>
+  <dgm:styleLbl name="alignNode1">
+    <dgm:fillClrLst>
+      <a:schemeClr val="accent5"/>
+      <a:schemeClr val="accent6"/>
+    </dgm:fillClrLst>
+    <dgm:linClrLst>
+      <a:schemeClr val="accent5"/>
+      <a:schemeClr val="accent6"/>
+    </dgm:linClrLst>
+    <dgm:effectClrLst/>
+    <dgm:txLinClrLst/>
+    <dgm:txFillClrLst/>
+    <dgm:txEffectClrLst/>
+  </dgm:styleLbl>
+  <dgm:styleLbl name="lnNode1">
+    <dgm:fillClrLst>
+      <a:schemeClr val="accent5"/>
+      <a:schemeClr val="accent6"/>
+    </dgm:fillClrLst>
+    <dgm:linClrLst meth="repeat">
+      <a:schemeClr val="lt1"/>
+    </dgm:linClrLst>
+    <dgm:effectClrLst/>
+    <dgm:txLinClrLst/>
+    <dgm:txFillClrLst/>
+    <dgm:txEffectClrLst/>
+  </dgm:styleLbl>
+  <dgm:styleLbl name="vennNode1">
+    <dgm:fillClrLst>
+      <a:schemeClr val="accent5">
+        <a:alpha val="50000"/>
+      </a:schemeClr>
+      <a:schemeClr val="accent6">
+        <a:alpha val="50000"/>
+      </a:schemeClr>
+    </dgm:fillClrLst>
+    <dgm:linClrLst meth="repeat">
+      <a:schemeClr val="lt1"/>
+    </dgm:linClrLst>
+    <dgm:effectClrLst/>
+    <dgm:txLinClrLst/>
+    <dgm:txFillClrLst/>
+    <dgm:txEffectClrLst/>
+  </dgm:styleLbl>
+  <dgm:styleLbl name="node2">
+    <dgm:fillClrLst>
+      <a:schemeClr val="accent6"/>
+    </dgm:fillClrLst>
+    <dgm:linClrLst meth="repeat">
+      <a:schemeClr val="lt1"/>
+    </dgm:linClrLst>
+    <dgm:effectClrLst/>
+    <dgm:txLinClrLst/>
+    <dgm:txFillClrLst/>
+    <dgm:txEffectClrLst/>
+  </dgm:styleLbl>
+  <dgm:styleLbl name="node3">
+    <dgm:fillClrLst>
+      <a:schemeClr val="accent1"/>
+    </dgm:fillClrLst>
+    <dgm:linClrLst meth="repeat">
+      <a:schemeClr val="lt1"/>
+    </dgm:linClrLst>
+    <dgm:effectClrLst/>
+    <dgm:txLinClrLst/>
+    <dgm:txFillClrLst/>
+    <dgm:txEffectClrLst/>
+  </dgm:styleLbl>
+  <dgm:styleLbl name="node4">
+    <dgm:fillClrLst>
+      <a:schemeClr val="accent2"/>
+    </dgm:fillClrLst>
+    <dgm:linClrLst meth="repeat">
+      <a:schemeClr val="lt1"/>
+    </dgm:linClrLst>
+    <dgm:effectClrLst/>
+    <dgm:txLinClrLst/>
+    <dgm:txFillClrLst/>
+    <dgm:txEffectClrLst/>
+  </dgm:styleLbl>
+  <dgm:styleLbl name="fgImgPlace1">
+    <dgm:fillClrLst>
+      <a:schemeClr val="accent5">
+        <a:tint val="50000"/>
+      </a:schemeClr>
+      <a:schemeClr val="accent6">
+        <a:tint val="50000"/>
+      </a:schemeClr>
+    </dgm:fillClrLst>
+    <dgm:linClrLst meth="repeat">
+      <a:schemeClr val="lt1"/>
+    </dgm:linClrLst>
+    <dgm:effectClrLst/>
+    <dgm:txLinClrLst/>
+    <dgm:txFillClrLst meth="repeat">
+      <a:schemeClr val="lt1"/>
+    </dgm:txFillClrLst>
+    <dgm:txEffectClrLst/>
+  </dgm:styleLbl>
+  <dgm:styleLbl name="alignImgPlace1">
+    <dgm:fillClrLst>
+      <a:schemeClr val="accent5">
+        <a:tint val="50000"/>
+      </a:schemeClr>
+      <a:schemeClr val="accent6">
+        <a:tint val="20000"/>
+      </a:schemeClr>
+    </dgm:fillClrLst>
+    <dgm:linClrLst meth="repeat">
+      <a:schemeClr val="lt1"/>
+    </dgm:linClrLst>
+    <dgm:effectClrLst/>
+    <dgm:txLinClrLst/>
+    <dgm:txFillClrLst meth="repeat">
+      <a:schemeClr val="lt1"/>
+    </dgm:txFillClrLst>
+    <dgm:txEffectClrLst/>
+  </dgm:styleLbl>
+  <dgm:styleLbl name="bgImgPlace1">
+    <dgm:fillClrLst>
+      <a:schemeClr val="accent5">
+        <a:tint val="50000"/>
+      </a:schemeClr>
+      <a:schemeClr val="accent6">
+        <a:tint val="20000"/>
+      </a:schemeClr>
+    </dgm:fillClrLst>
+    <dgm:linClrLst meth="repeat">
+      <a:schemeClr val="lt1"/>
+    </dgm:linClrLst>
+    <dgm:effectClrLst/>
+    <dgm:txLinClrLst/>
+    <dgm:txFillClrLst meth="repeat">
+      <a:schemeClr val="lt1"/>
+    </dgm:txFillClrLst>
+    <dgm:txEffectClrLst/>
+  </dgm:styleLbl>
+  <dgm:styleLbl name="sibTrans2D1">
+    <dgm:fillClrLst>
+      <a:schemeClr val="accent5"/>
+      <a:schemeClr val="accent6"/>
+    </dgm:fillClrLst>
+    <dgm:linClrLst meth="repeat">
+      <a:schemeClr val="lt1"/>
+    </dgm:linClrLst>
+    <dgm:effectClrLst/>
+    <dgm:txLinClrLst/>
+    <dgm:txFillClrLst/>
+    <dgm:txEffectClrLst/>
+  </dgm:styleLbl>
+  <dgm:styleLbl name="fgSibTrans2D1">
+    <dgm:fillClrLst>
+      <a:schemeClr val="accent5"/>
+      <a:schemeClr val="accent6"/>
+    </dgm:fillClrLst>
+    <dgm:linClrLst meth="repeat">
+      <a:schemeClr val="lt1"/>
+    </dgm:linClrLst>
+    <dgm:effectClrLst/>
+    <dgm:txLinClrLst/>
+    <dgm:txFillClrLst meth="repeat">
+      <a:schemeClr val="lt1"/>
+    </dgm:txFillClrLst>
+    <dgm:txEffectClrLst/>
+  </dgm:styleLbl>
+  <dgm:styleLbl name="bgSibTrans2D1">
+    <dgm:fillClrLst>
+      <a:schemeClr val="accent5"/>
+      <a:schemeClr val="accent6"/>
+    </dgm:fillClrLst>
+    <dgm:linClrLst meth="repeat">
+      <a:schemeClr val="lt1"/>
+    </dgm:linClrLst>
+    <dgm:effectClrLst/>
+    <dgm:txLinClrLst/>
+    <dgm:txFillClrLst meth="repeat">
+      <a:schemeClr val="lt1"/>
+    </dgm:txFillClrLst>
+    <dgm:txEffectClrLst/>
+  </dgm:styleLbl>
+  <dgm:styleLbl name="sibTrans1D1">
+    <dgm:fillClrLst/>
+    <dgm:linClrLst>
+      <a:schemeClr val="accent5"/>
+      <a:schemeClr val="accent6"/>
+    </dgm:linClrLst>
+    <dgm:effectClrLst/>
+    <dgm:txLinClrLst/>
+    <dgm:txFillClrLst meth="repeat">
+      <a:schemeClr val="tx1"/>
+    </dgm:txFillClrLst>
+    <dgm:txEffectClrLst/>
+  </dgm:styleLbl>
+  <dgm:styleLbl name="callout">
+    <dgm:fillClrLst meth="repeat">
+      <a:schemeClr val="accent5"/>
+    </dgm:fillClrLst>
+    <dgm:linClrLst meth="repeat">
+      <a:schemeClr val="accent5">
+        <a:tint val="50000"/>
+      </a:schemeClr>
+    </dgm:linClrLst>
+    <dgm:effectClrLst/>
+    <dgm:txLinClrLst/>
+    <dgm:txFillClrLst meth="repeat">
+      <a:schemeClr val="tx1"/>
+    </dgm:txFillClrLst>
+    <dgm:txEffectClrLst/>
+  </dgm:styleLbl>
+  <dgm:styleLbl name="asst0">
+    <dgm:fillClrLst meth="repeat">
+      <a:schemeClr val="accent5"/>
+    </dgm:fillClrLst>
+    <dgm:linClrLst meth="repeat">
+      <a:schemeClr val="lt1">
+        <a:shade val="80000"/>
+      </a:schemeClr>
+    </dgm:linClrLst>
+    <dgm:effectClrLst/>
+    <dgm:txLinClrLst/>
+    <dgm:txFillClrLst/>
+    <dgm:txEffectClrLst/>
+  </dgm:styleLbl>
+  <dgm:styleLbl name="asst1">
+    <dgm:fillClrLst meth="repeat">
+      <a:schemeClr val="accent6"/>
+    </dgm:fillClrLst>
+    <dgm:linClrLst meth="repeat">
+      <a:schemeClr val="lt1">
+        <a:shade val="80000"/>
+      </a:schemeClr>
+    </dgm:linClrLst>
+    <dgm:effectClrLst/>
+    <dgm:txLinClrLst/>
+    <dgm:txFillClrLst/>
+    <dgm:txEffectClrLst/>
+  </dgm:styleLbl>
+  <dgm:styleLbl name="asst2">
+    <dgm:fillClrLst>
+      <a:schemeClr val="accent1"/>
+    </dgm:fillClrLst>
+    <dgm:linClrLst meth="repeat">
+      <a:schemeClr val="lt1"/>
+    </dgm:linClrLst>
+    <dgm:effectClrLst/>
+    <dgm:txLinClrLst/>
+    <dgm:txFillClrLst/>
+    <dgm:txEffectClrLst/>
+  </dgm:styleLbl>
+  <dgm:styleLbl name="asst3">
+    <dgm:fillClrLst>
+      <a:schemeClr val="accent2"/>
+    </dgm:fillClrLst>
+    <dgm:linClrLst meth="repeat">
+      <a:schemeClr val="lt1"/>
+    </dgm:linClrLst>
+    <dgm:effectClrLst/>
+    <dgm:txLinClrLst/>
+    <dgm:txFillClrLst/>
+    <dgm:txEffectClrLst/>
+  </dgm:styleLbl>
+  <dgm:styleLbl name="asst4">
+    <dgm:fillClrLst>
+      <a:schemeClr val="accent3"/>
+    </dgm:fillClrLst>
+    <dgm:linClrLst meth="repeat">
+      <a:schemeClr val="lt1"/>
+    </dgm:linClrLst>
+    <dgm:effectClrLst/>
+    <dgm:txLinClrLst/>
+    <dgm:txFillClrLst/>
+    <dgm:txEffectClrLst/>
+  </dgm:styleLbl>
+  <dgm:styleLbl name="parChTrans2D1">
+    <dgm:fillClrLst meth="repeat">
+      <a:schemeClr val="accent5"/>
+    </dgm:fillClrLst>
+    <dgm:linClrLst meth="repeat">
+      <a:schemeClr val="lt1"/>
+    </dgm:linClrLst>
+    <dgm:effectClrLst/>
+    <dgm:txLinClrLst/>
+    <dgm:txFillClrLst meth="repeat">
+      <a:schemeClr val="lt1"/>
+    </dgm:txFillClrLst>
+    <dgm:txEffectClrLst/>
+  </dgm:styleLbl>
+  <dgm:styleLbl name="parChTrans2D2">
+    <dgm:fillClrLst meth="repeat">
+      <a:schemeClr val="accent6"/>
+    </dgm:fillClrLst>
+    <dgm:linClrLst meth="repeat">
+      <a:schemeClr val="lt1"/>
+    </dgm:linClrLst>
+    <dgm:effectClrLst/>
+    <dgm:txLinClrLst/>
+    <dgm:txFillClrLst/>
+    <dgm:txEffectClrLst/>
+  </dgm:styleLbl>
+  <dgm:styleLbl name="parChTrans2D3">
+    <dgm:fillClrLst meth="repeat">
+      <a:schemeClr val="accent6"/>
+    </dgm:fillClrLst>
+    <dgm:linClrLst meth="repeat">
+      <a:schemeClr val="lt1"/>
+    </dgm:linClrLst>
+    <dgm:effectClrLst/>
+    <dgm:txLinClrLst/>
+    <dgm:txFillClrLst/>
+    <dgm:txEffectClrLst/>
+  </dgm:styleLbl>
+  <dgm:styleLbl name="parChTrans2D4">
+    <dgm:fillClrLst meth="repeat">
+      <a:schemeClr val="accent1"/>
+    </dgm:fillClrLst>
+    <dgm:linClrLst meth="repeat">
+      <a:schemeClr val="lt1"/>
+    </dgm:linClrLst>
+    <dgm:effectClrLst/>
+    <dgm:txLinClrLst/>
+    <dgm:txFillClrLst meth="repeat">
+      <a:schemeClr val="lt1"/>
+    </dgm:txFillClrLst>
+    <dgm:txEffectClrLst/>
+  </dgm:styleLbl>
+  <dgm:styleLbl name="parChTrans1D1">
+    <dgm:fillClrLst meth="repeat">
+      <a:schemeClr val="accent5"/>
+    </dgm:fillClrLst>
+    <dgm:linClrLst meth="repeat">
+      <a:schemeClr val="accent5"/>
+    </dgm:linClrLst>
+    <dgm:effectClrLst/>
+    <dgm:txLinClrLst/>
+    <dgm:txFillClrLst meth="repeat">
+      <a:schemeClr val="tx1"/>
+    </dgm:txFillClrLst>
+    <dgm:txEffectClrLst/>
+  </dgm:styleLbl>
+  <dgm:styleLbl name="parChTrans1D2">
+    <dgm:fillClrLst meth="repeat">
+      <a:schemeClr val="accent6">
+        <a:tint val="90000"/>
+      </a:schemeClr>
+    </dgm:fillClrLst>
+    <dgm:linClrLst meth="repeat">
+      <a:schemeClr val="accent6"/>
+    </dgm:linClrLst>
+    <dgm:effectClrLst/>
+    <dgm:txLinClrLst/>
+    <dgm:txFillClrLst meth="repeat">
+      <a:schemeClr val="tx1"/>
+    </dgm:txFillClrLst>
+    <dgm:txEffectClrLst/>
+  </dgm:styleLbl>
+  <dgm:styleLbl name="parChTrans1D3">
+    <dgm:fillClrLst meth="repeat">
+      <a:schemeClr val="accent6">
+        <a:tint val="70000"/>
+      </a:schemeClr>
+    </dgm:fillClrLst>
+    <dgm:linClrLst meth="repeat">
+      <a:schemeClr val="accent1"/>
+    </dgm:linClrLst>
+    <dgm:effectClrLst/>
+    <dgm:txLinClrLst/>
+    <dgm:txFillClrLst meth="repeat">
+      <a:schemeClr val="tx1"/>
+    </dgm:txFillClrLst>
+    <dgm:txEffectClrLst/>
+  </dgm:styleLbl>
+  <dgm:styleLbl name="parChTrans1D4">
+    <dgm:fillClrLst meth="repeat">
+      <a:schemeClr val="accent6">
+        <a:tint val="50000"/>
+      </a:schemeClr>
+    </dgm:fillClrLst>
+    <dgm:linClrLst meth="repeat">
+      <a:schemeClr val="accent2"/>
+    </dgm:linClrLst>
+    <dgm:effectClrLst/>
+    <dgm:txLinClrLst/>
+    <dgm:txFillClrLst meth="repeat">
+      <a:schemeClr val="tx1"/>
+    </dgm:txFillClrLst>
+    <dgm:txEffectClrLst/>
+  </dgm:styleLbl>
+  <dgm:styleLbl name="fgAcc1">
+    <dgm:fillClrLst meth="repeat">
+      <a:schemeClr val="lt1">
+        <a:alpha val="90000"/>
+      </a:schemeClr>
+    </dgm:fillClrLst>
+    <dgm:linClrLst>
+      <a:schemeClr val="accent5"/>
+      <a:schemeClr val="accent6"/>
+    </dgm:linClrLst>
+    <dgm:effectClrLst/>
+    <dgm:txLinClrLst/>
+    <dgm:txFillClrLst meth="repeat">
+      <a:schemeClr val="dk1"/>
+    </dgm:txFillClrLst>
+    <dgm:txEffectClrLst/>
+  </dgm:styleLbl>
+  <dgm:styleLbl name="conFgAcc1">
+    <dgm:fillClrLst meth="repeat">
+      <a:schemeClr val="lt1">
+        <a:alpha val="90000"/>
+      </a:schemeClr>
+    </dgm:fillClrLst>
+    <dgm:linClrLst>
+      <a:schemeClr val="accent5"/>
+      <a:schemeClr val="accent6"/>
+    </dgm:linClrLst>
+    <dgm:effectClrLst/>
+    <dgm:txLinClrLst/>
+    <dgm:txFillClrLst meth="repeat">
+      <a:schemeClr val="dk1"/>
+    </dgm:txFillClrLst>
+    <dgm:txEffectClrLst/>
+  </dgm:styleLbl>
+  <dgm:styleLbl name="alignAcc1">
+    <dgm:fillClrLst meth="repeat">
+      <a:schemeClr val="lt1">
+        <a:alpha val="90000"/>
+      </a:schemeClr>
+    </dgm:fillClrLst>
+    <dgm:linClrLst>
+      <a:schemeClr val="accent5"/>
+      <a:schemeClr val="accent6"/>
+    </dgm:linClrLst>
+    <dgm:effectClrLst/>
+    <dgm:txLinClrLst/>
+    <dgm:txFillClrLst meth="repeat">
+      <a:schemeClr val="dk1"/>
+    </dgm:txFillClrLst>
+    <dgm:txEffectClrLst/>
+  </dgm:styleLbl>
+  <dgm:styleLbl name="trAlignAcc1">
+    <dgm:fillClrLst meth="repeat">
+      <a:schemeClr val="lt1">
+        <a:alpha val="40000"/>
+      </a:schemeClr>
+    </dgm:fillClrLst>
+    <dgm:linClrLst meth="repeat">
+      <a:schemeClr val="accent5"/>
+    </dgm:linClrLst>
+    <dgm:effectClrLst/>
+    <dgm:txLinClrLst/>
+    <dgm:txFillClrLst meth="repeat">
+      <a:schemeClr val="dk1"/>
+    </dgm:txFillClrLst>
+    <dgm:txEffectClrLst/>
+  </dgm:styleLbl>
+  <dgm:styleLbl name="bgAcc1">
+    <dgm:fillClrLst meth="repeat">
+      <a:schemeClr val="lt1">
+        <a:alpha val="90000"/>
+      </a:schemeClr>
+    </dgm:fillClrLst>
+    <dgm:linClrLst>
+      <a:schemeClr val="accent5"/>
+      <a:schemeClr val="accent6"/>
+    </dgm:linClrLst>
+    <dgm:effectClrLst/>
+    <dgm:txLinClrLst/>
+    <dgm:txFillClrLst meth="repeat">
+      <a:schemeClr val="dk1"/>
+    </dgm:txFillClrLst>
+    <dgm:txEffectClrLst/>
+  </dgm:styleLbl>
+  <dgm:styleLbl name="solidFgAcc1">
+    <dgm:fillClrLst meth="repeat">
+      <a:schemeClr val="lt1"/>
+    </dgm:fillClrLst>
+    <dgm:linClrLst>
+      <a:schemeClr val="accent5"/>
+      <a:schemeClr val="accent6"/>
+    </dgm:linClrLst>
+    <dgm:effectClrLst/>
+    <dgm:txLinClrLst/>
+    <dgm:txFillClrLst meth="repeat">
+      <a:schemeClr val="dk1"/>
+    </dgm:txFillClrLst>
+    <dgm:txEffectClrLst/>
+  </dgm:styleLbl>
+  <dgm:styleLbl name="solidAlignAcc1">
+    <dgm:fillClrLst meth="repeat">
+      <a:schemeClr val="lt1"/>
+    </dgm:fillClrLst>
+    <dgm:linClrLst>
+      <a:schemeClr val="accent5"/>
+      <a:schemeClr val="accent6"/>
+    </dgm:linClrLst>
+    <dgm:effectClrLst/>
+    <dgm:txLinClrLst/>
+    <dgm:txFillClrLst meth="repeat">
+      <a:schemeClr val="dk1"/>
+    </dgm:txFillClrLst>
+    <dgm:txEffectClrLst/>
+  </dgm:styleLbl>
+  <dgm:styleLbl name="solidBgAcc1">
+    <dgm:fillClrLst meth="repeat">
+      <a:schemeClr val="lt1"/>
+    </dgm:fillClrLst>
+    <dgm:linClrLst>
+      <a:schemeClr val="accent5"/>
+      <a:schemeClr val="accent6"/>
+    </dgm:linClrLst>
+    <dgm:effectClrLst/>
+    <dgm:txLinClrLst/>
+    <dgm:txFillClrLst meth="repeat">
+      <a:schemeClr val="dk1"/>
+    </dgm:txFillClrLst>
+    <dgm:txEffectClrLst/>
+  </dgm:styleLbl>
+  <dgm:styleLbl name="fgAccFollowNode1">
+    <dgm:fillClrLst>
+      <a:schemeClr val="accent5">
+        <a:tint val="40000"/>
+        <a:alpha val="90000"/>
+      </a:schemeClr>
+      <a:schemeClr val="accent6">
+        <a:tint val="40000"/>
+        <a:alpha val="90000"/>
+      </a:schemeClr>
+    </dgm:fillClrLst>
+    <dgm:linClrLst>
+      <a:schemeClr val="accent5">
+        <a:tint val="40000"/>
+        <a:alpha val="90000"/>
+      </a:schemeClr>
+      <a:schemeClr val="accent5">
+        <a:tint val="40000"/>
+        <a:alpha val="90000"/>
+      </a:schemeClr>
+    </dgm:linClrLst>
+    <dgm:effectClrLst/>
+    <dgm:txLinClrLst/>
+    <dgm:txFillClrLst meth="repeat">
+      <a:schemeClr val="dk1"/>
+    </dgm:txFillClrLst>
+    <dgm:txEffectClrLst/>
+  </dgm:styleLbl>
+  <dgm:styleLbl name="alignAccFollowNode1">
+    <dgm:fillClrLst>
+      <a:schemeClr val="accent5">
+        <a:tint val="40000"/>
+        <a:alpha val="90000"/>
+      </a:schemeClr>
+      <a:schemeClr val="accent6">
+        <a:tint val="40000"/>
+        <a:alpha val="90000"/>
+      </a:schemeClr>
+    </dgm:fillClrLst>
+    <dgm:linClrLst>
+      <a:schemeClr val="accent5">
+        <a:tint val="40000"/>
+        <a:alpha val="90000"/>
+      </a:schemeClr>
+      <a:schemeClr val="accent6">
+        <a:tint val="40000"/>
+        <a:alpha val="90000"/>
+      </a:schemeClr>
+    </dgm:linClrLst>
+    <dgm:effectClrLst/>
+    <dgm:txLinClrLst/>
+    <dgm:txFillClrLst meth="repeat">
+      <a:schemeClr val="dk1"/>
+    </dgm:txFillClrLst>
+    <dgm:txEffectClrLst/>
+  </dgm:styleLbl>
+  <dgm:styleLbl name="bgAccFollowNode1">
+    <dgm:fillClrLst>
+      <a:schemeClr val="accent5">
+        <a:tint val="40000"/>
+        <a:alpha val="90000"/>
+      </a:schemeClr>
+      <a:schemeClr val="accent6">
+        <a:tint val="40000"/>
+        <a:alpha val="90000"/>
+      </a:schemeClr>
+    </dgm:fillClrLst>
+    <dgm:linClrLst>
+      <a:schemeClr val="accent5">
+        <a:tint val="40000"/>
+        <a:alpha val="90000"/>
+      </a:schemeClr>
+      <a:schemeClr val="accent6">
+        <a:tint val="40000"/>
+        <a:alpha val="90000"/>
+      </a:schemeClr>
+    </dgm:linClrLst>
+    <dgm:effectClrLst/>
+    <dgm:txLinClrLst/>
+    <dgm:txFillClrLst meth="repeat">
+      <a:schemeClr val="dk1"/>
+    </dgm:txFillClrLst>
+    <dgm:txEffectClrLst/>
+  </dgm:styleLbl>
+  <dgm:styleLbl name="fgAcc0">
+    <dgm:fillClrLst meth="repeat">
+      <a:schemeClr val="lt1">
+        <a:alpha val="90000"/>
+      </a:schemeClr>
+    </dgm:fillClrLst>
+    <dgm:linClrLst>
+      <a:schemeClr val="accent4"/>
+    </dgm:linClrLst>
+    <dgm:effectClrLst/>
+    <dgm:txLinClrLst/>
+    <dgm:txFillClrLst meth="repeat">
+      <a:schemeClr val="dk1"/>
+    </dgm:txFillClrLst>
+    <dgm:txEffectClrLst/>
+  </dgm:styleLbl>
+  <dgm:styleLbl name="fgAcc2">
+    <dgm:fillClrLst meth="repeat">
+      <a:schemeClr val="lt1">
+        <a:alpha val="90000"/>
+      </a:schemeClr>
+    </dgm:fillClrLst>
+    <dgm:linClrLst>
+      <a:schemeClr val="accent6"/>
+    </dgm:linClrLst>
+    <dgm:effectClrLst/>
+    <dgm:txLinClrLst/>
+    <dgm:txFillClrLst meth="repeat">
+      <a:schemeClr val="dk1"/>
+    </dgm:txFillClrLst>
+    <dgm:txEffectClrLst/>
+  </dgm:styleLbl>
+  <dgm:styleLbl name="fgAcc3">
+    <dgm:fillClrLst meth="repeat">
+      <a:schemeClr val="lt1">
+        <a:alpha val="90000"/>
+      </a:schemeClr>
+    </dgm:fillClrLst>
+    <dgm:linClrLst>
+      <a:schemeClr val="accent1"/>
+    </dgm:linClrLst>
+    <dgm:effectClrLst/>
+    <dgm:txLinClrLst/>
+    <dgm:txFillClrLst meth="repeat">
+      <a:schemeClr val="dk1"/>
+    </dgm:txFillClrLst>
+    <dgm:txEffectClrLst/>
+  </dgm:styleLbl>
+  <dgm:styleLbl name="fgAcc4">
+    <dgm:fillClrLst meth="repeat">
+      <a:schemeClr val="lt1">
+        <a:alpha val="90000"/>
+      </a:schemeClr>
+    </dgm:fillClrLst>
+    <dgm:linClrLst>
+      <a:schemeClr val="accent2"/>
+    </dgm:linClrLst>
+    <dgm:effectClrLst/>
+    <dgm:txLinClrLst/>
+    <dgm:txFillClrLst meth="repeat">
+      <a:schemeClr val="dk1"/>
+    </dgm:txFillClrLst>
+    <dgm:txEffectClrLst/>
+  </dgm:styleLbl>
+  <dgm:styleLbl name="bgShp">
+    <dgm:fillClrLst meth="repeat">
+      <a:schemeClr val="accent5">
+        <a:tint val="40000"/>
+      </a:schemeClr>
+    </dgm:fillClrLst>
+    <dgm:linClrLst meth="repeat">
+      <a:schemeClr val="dk1"/>
+    </dgm:linClrLst>
+    <dgm:effectClrLst/>
+    <dgm:txLinClrLst/>
+    <dgm:txFillClrLst meth="repeat">
+      <a:schemeClr val="dk1"/>
+    </dgm:txFillClrLst>
+    <dgm:txEffectClrLst/>
+  </dgm:styleLbl>
+  <dgm:styleLbl name="dkBgShp">
+    <dgm:fillClrLst meth="repeat">
+      <a:schemeClr val="accent5">
+        <a:shade val="90000"/>
+      </a:schemeClr>
+    </dgm:fillClrLst>
+    <dgm:linClrLst meth="repeat">
+      <a:schemeClr val="dk1"/>
+    </dgm:linClrLst>
+    <dgm:effectClrLst/>
+    <dgm:txLinClrLst/>
+    <dgm:txFillClrLst meth="repeat">
+      <a:schemeClr val="lt1"/>
+    </dgm:txFillClrLst>
+    <dgm:txEffectClrLst/>
+  </dgm:styleLbl>
+  <dgm:styleLbl name="trBgShp">
+    <dgm:fillClrLst meth="repeat">
+      <a:schemeClr val="accent5">
+        <a:tint val="50000"/>
+        <a:alpha val="40000"/>
+      </a:schemeClr>
+    </dgm:fillClrLst>
+    <dgm:linClrLst meth="repeat">
+      <a:schemeClr val="accent5"/>
+    </dgm:linClrLst>
+    <dgm:effectClrLst/>
+    <dgm:txLinClrLst/>
+    <dgm:txFillClrLst meth="repeat">
+      <a:schemeClr val="lt1"/>
+    </dgm:txFillClrLst>
+    <dgm:txEffectClrLst/>
+  </dgm:styleLbl>
+  <dgm:styleLbl name="fgShp">
+    <dgm:fillClrLst meth="repeat">
+      <a:schemeClr val="accent5">
+        <a:tint val="40000"/>
+      </a:schemeClr>
+    </dgm:fillClrLst>
+    <dgm:linClrLst meth="repeat">
+      <a:schemeClr val="lt1"/>
+    </dgm:linClrLst>
+    <dgm:effectClrLst/>
+    <dgm:txLinClrLst/>
+    <dgm:txFillClrLst meth="repeat">
+      <a:schemeClr val="dk1"/>
+    </dgm:txFillClrLst>
+    <dgm:txEffectClrLst/>
+  </dgm:styleLbl>
+  <dgm:styleLbl name="revTx">
+    <dgm:fillClrLst meth="repeat">
+      <a:schemeClr val="lt1">
+        <a:alpha val="0"/>
+      </a:schemeClr>
+    </dgm:fillClrLst>
+    <dgm:linClrLst meth="repeat">
+      <a:schemeClr val="dk1">
+        <a:alpha val="0"/>
+      </a:schemeClr>
+    </dgm:linClrLst>
+    <dgm:effectClrLst/>
+    <dgm:txLinClrLst/>
+    <dgm:txFillClrLst meth="repeat">
+      <a:schemeClr val="tx1"/>
+    </dgm:txFillClrLst>
+    <dgm:txEffectClrLst/>
+  </dgm:styleLbl>
+</dgm:colorsDef>
+</file>
+
+<file path=ppt/diagrams/data1.xml><?xml version="1.0" encoding="utf-8"?>
+<dgm:dataModel xmlns:dgm="http://schemas.openxmlformats.org/drawingml/2006/diagram" xmlns:a="http://schemas.openxmlformats.org/drawingml/2006/main">
+  <dgm:ptLst>
+    <dgm:pt modelId="{2CBFF9C9-7D52-4E19-8855-51A653DA9CE0}" type="doc">
+      <dgm:prSet loTypeId="urn:microsoft.com/office/officeart/2005/8/layout/vList2" loCatId="list" qsTypeId="urn:microsoft.com/office/officeart/2005/8/quickstyle/simple1" qsCatId="simple" csTypeId="urn:microsoft.com/office/officeart/2005/8/colors/colorful5" csCatId="colorful"/>
+      <dgm:spPr/>
+      <dgm:t>
+        <a:bodyPr/>
+        <a:lstStyle/>
+        <a:p>
+          <a:endParaRPr lang="en-US"/>
+        </a:p>
+      </dgm:t>
+    </dgm:pt>
+    <dgm:pt modelId="{5AE49A12-D260-4810-BECD-FFDF7ACADA64}">
+      <dgm:prSet/>
+      <dgm:spPr/>
+      <dgm:t>
+        <a:bodyPr/>
+        <a:lstStyle/>
+        <a:p>
+          <a:r>
+            <a:rPr lang="en-US"/>
+            <a:t>AI progress is cyclical, not a straight upward line</a:t>
+          </a:r>
+        </a:p>
+      </dgm:t>
+    </dgm:pt>
+    <dgm:pt modelId="{217EA87A-9A51-49F9-A1A4-153A9BEED941}" type="parTrans" cxnId="{4DEE4B38-25AE-4616-A426-3206D1698546}">
+      <dgm:prSet/>
+      <dgm:spPr/>
+      <dgm:t>
+        <a:bodyPr/>
+        <a:lstStyle/>
+        <a:p>
+          <a:endParaRPr lang="en-US"/>
+        </a:p>
+      </dgm:t>
+    </dgm:pt>
+    <dgm:pt modelId="{614383F1-2CA4-486E-BD11-E15C0E57EA4B}" type="sibTrans" cxnId="{4DEE4B38-25AE-4616-A426-3206D1698546}">
+      <dgm:prSet/>
+      <dgm:spPr/>
+      <dgm:t>
+        <a:bodyPr/>
+        <a:lstStyle/>
+        <a:p>
+          <a:endParaRPr lang="en-US"/>
+        </a:p>
+      </dgm:t>
+    </dgm:pt>
+    <dgm:pt modelId="{63B7DA53-67BD-4660-A51F-94DE2E9B9388}">
+      <dgm:prSet/>
+      <dgm:spPr/>
+      <dgm:t>
+        <a:bodyPr/>
+        <a:lstStyle/>
+        <a:p>
+          <a:r>
+            <a:rPr lang="en-US"/>
+            <a:t>Cycle: breakthrough, hype, overpromise, disappointment, funding collapse</a:t>
+          </a:r>
+        </a:p>
+      </dgm:t>
+    </dgm:pt>
+    <dgm:pt modelId="{A7EC64BC-081C-44F0-A77C-910B669EECE8}" type="parTrans" cxnId="{4FC6EC40-C71C-4869-9736-4031BBA613A7}">
+      <dgm:prSet/>
+      <dgm:spPr/>
+      <dgm:t>
+        <a:bodyPr/>
+        <a:lstStyle/>
+        <a:p>
+          <a:endParaRPr lang="en-US"/>
+        </a:p>
+      </dgm:t>
+    </dgm:pt>
+    <dgm:pt modelId="{90C1431C-CDD8-40D7-9696-4550FA0FEE8C}" type="sibTrans" cxnId="{4FC6EC40-C71C-4869-9736-4031BBA613A7}">
+      <dgm:prSet/>
+      <dgm:spPr/>
+      <dgm:t>
+        <a:bodyPr/>
+        <a:lstStyle/>
+        <a:p>
+          <a:endParaRPr lang="en-US"/>
+        </a:p>
+      </dgm:t>
+    </dgm:pt>
+    <dgm:pt modelId="{DA82F6B8-90F8-4344-8C66-D9963ABC4718}">
+      <dgm:prSet/>
+      <dgm:spPr/>
+      <dgm:t>
+        <a:bodyPr/>
+        <a:lstStyle/>
+        <a:p>
+          <a:r>
+            <a:rPr lang="en-US"/>
+            <a:t>'AI winter' means sustained cuts in funding and interest</a:t>
+          </a:r>
+        </a:p>
+      </dgm:t>
+    </dgm:pt>
+    <dgm:pt modelId="{DE67D9E0-CE55-487C-B1AC-74FE27DB8B07}" type="parTrans" cxnId="{8F66FEF3-5D7E-4A81-B947-73CE2C59DBD3}">
+      <dgm:prSet/>
+      <dgm:spPr/>
+      <dgm:t>
+        <a:bodyPr/>
+        <a:lstStyle/>
+        <a:p>
+          <a:endParaRPr lang="en-US"/>
+        </a:p>
+      </dgm:t>
+    </dgm:pt>
+    <dgm:pt modelId="{276FECA6-7797-467F-8CC8-9127F5F5D2DC}" type="sibTrans" cxnId="{8F66FEF3-5D7E-4A81-B947-73CE2C59DBD3}">
+      <dgm:prSet/>
+      <dgm:spPr/>
+      <dgm:t>
+        <a:bodyPr/>
+        <a:lstStyle/>
+        <a:p>
+          <a:endParaRPr lang="en-US"/>
+        </a:p>
+      </dgm:t>
+    </dgm:pt>
+    <dgm:pt modelId="{8B4047EE-5885-441F-A8B4-2102BFB1E95E}">
+      <dgm:prSet/>
+      <dgm:spPr/>
+      <dgm:t>
+        <a:bodyPr/>
+        <a:lstStyle/>
+        <a:p>
+          <a:r>
+            <a:rPr lang="en-US"/>
+            <a:t>Pattern repeats because expectations outrun technical reality</a:t>
+          </a:r>
+        </a:p>
+      </dgm:t>
+    </dgm:pt>
+    <dgm:pt modelId="{6B2E7593-FAB8-4C66-85DF-21BE397611D5}" type="parTrans" cxnId="{5080F39F-48D2-4898-9089-5D62C1A0A3F0}">
+      <dgm:prSet/>
+      <dgm:spPr/>
+      <dgm:t>
+        <a:bodyPr/>
+        <a:lstStyle/>
+        <a:p>
+          <a:endParaRPr lang="en-US"/>
+        </a:p>
+      </dgm:t>
+    </dgm:pt>
+    <dgm:pt modelId="{6D47D18C-BDB8-419A-8C72-B443C45CBFD2}" type="sibTrans" cxnId="{5080F39F-48D2-4898-9089-5D62C1A0A3F0}">
+      <dgm:prSet/>
+      <dgm:spPr/>
+      <dgm:t>
+        <a:bodyPr/>
+        <a:lstStyle/>
+        <a:p>
+          <a:endParaRPr lang="en-US"/>
+        </a:p>
+      </dgm:t>
+    </dgm:pt>
+    <dgm:pt modelId="{66D4ED4D-2AA1-49EB-9E6D-B9383C208A7C}">
+      <dgm:prSet/>
+      <dgm:spPr/>
+      <dgm:t>
+        <a:bodyPr/>
+        <a:lstStyle/>
+        <a:p>
+          <a:r>
+            <a:rPr lang="en-US"/>
+            <a:t>Understanding cycles explains today's field structure and vocabulary</a:t>
+          </a:r>
+        </a:p>
+      </dgm:t>
+    </dgm:pt>
+    <dgm:pt modelId="{35D6470E-B375-416A-8A3A-44572DAC5454}" type="parTrans" cxnId="{A425F6B2-555E-4B81-87CE-9D85BA965D8A}">
+      <dgm:prSet/>
+      <dgm:spPr/>
+      <dgm:t>
+        <a:bodyPr/>
+        <a:lstStyle/>
+        <a:p>
+          <a:endParaRPr lang="en-US"/>
+        </a:p>
+      </dgm:t>
+    </dgm:pt>
+    <dgm:pt modelId="{48173F67-9961-47D6-B7FC-EFCEEC3D23D5}" type="sibTrans" cxnId="{A425F6B2-555E-4B81-87CE-9D85BA965D8A}">
+      <dgm:prSet/>
+      <dgm:spPr/>
+      <dgm:t>
+        <a:bodyPr/>
+        <a:lstStyle/>
+        <a:p>
+          <a:endParaRPr lang="en-US"/>
+        </a:p>
+      </dgm:t>
+    </dgm:pt>
+    <dgm:pt modelId="{08340771-1E08-499D-B061-F6E9817A5989}" type="pres">
+      <dgm:prSet presAssocID="{2CBFF9C9-7D52-4E19-8855-51A653DA9CE0}" presName="linear" presStyleCnt="0">
+        <dgm:presLayoutVars>
+          <dgm:animLvl val="lvl"/>
+          <dgm:resizeHandles val="exact"/>
+        </dgm:presLayoutVars>
+      </dgm:prSet>
+      <dgm:spPr/>
+    </dgm:pt>
+    <dgm:pt modelId="{1D0C178C-8A63-4E6C-A33C-6B65F9F9C5DA}" type="pres">
+      <dgm:prSet presAssocID="{5AE49A12-D260-4810-BECD-FFDF7ACADA64}" presName="parentText" presStyleLbl="node1" presStyleIdx="0" presStyleCnt="5">
+        <dgm:presLayoutVars>
+          <dgm:chMax val="0"/>
+          <dgm:bulletEnabled val="1"/>
+        </dgm:presLayoutVars>
+      </dgm:prSet>
+      <dgm:spPr/>
+    </dgm:pt>
+    <dgm:pt modelId="{45AF726E-64EC-4DD0-AFA4-0B0F1A60AB5D}" type="pres">
+      <dgm:prSet presAssocID="{614383F1-2CA4-486E-BD11-E15C0E57EA4B}" presName="spacer" presStyleCnt="0"/>
+      <dgm:spPr/>
+    </dgm:pt>
+    <dgm:pt modelId="{9A78BA5F-3F61-4966-8D40-33CC1F8A5F05}" type="pres">
+      <dgm:prSet presAssocID="{63B7DA53-67BD-4660-A51F-94DE2E9B9388}" presName="parentText" presStyleLbl="node1" presStyleIdx="1" presStyleCnt="5">
+        <dgm:presLayoutVars>
+          <dgm:chMax val="0"/>
+          <dgm:bulletEnabled val="1"/>
+        </dgm:presLayoutVars>
+      </dgm:prSet>
+      <dgm:spPr/>
+    </dgm:pt>
+    <dgm:pt modelId="{BDDB3D8D-6D53-4D90-8012-0DC1779B6936}" type="pres">
+      <dgm:prSet presAssocID="{90C1431C-CDD8-40D7-9696-4550FA0FEE8C}" presName="spacer" presStyleCnt="0"/>
+      <dgm:spPr/>
+    </dgm:pt>
+    <dgm:pt modelId="{3AC64C58-049E-48B7-A4B1-7FFDCC7B733D}" type="pres">
+      <dgm:prSet presAssocID="{DA82F6B8-90F8-4344-8C66-D9963ABC4718}" presName="parentText" presStyleLbl="node1" presStyleIdx="2" presStyleCnt="5">
+        <dgm:presLayoutVars>
+          <dgm:chMax val="0"/>
+          <dgm:bulletEnabled val="1"/>
+        </dgm:presLayoutVars>
+      </dgm:prSet>
+      <dgm:spPr/>
+    </dgm:pt>
+    <dgm:pt modelId="{6AD94703-60BE-48BC-AA56-193E5B63756F}" type="pres">
+      <dgm:prSet presAssocID="{276FECA6-7797-467F-8CC8-9127F5F5D2DC}" presName="spacer" presStyleCnt="0"/>
+      <dgm:spPr/>
+    </dgm:pt>
+    <dgm:pt modelId="{71E73A01-88FB-4041-949C-EEAF12DE5BC9}" type="pres">
+      <dgm:prSet presAssocID="{8B4047EE-5885-441F-A8B4-2102BFB1E95E}" presName="parentText" presStyleLbl="node1" presStyleIdx="3" presStyleCnt="5">
+        <dgm:presLayoutVars>
+          <dgm:chMax val="0"/>
+          <dgm:bulletEnabled val="1"/>
+        </dgm:presLayoutVars>
+      </dgm:prSet>
+      <dgm:spPr/>
+    </dgm:pt>
+    <dgm:pt modelId="{A8B1970D-BEC6-4DF4-9CF8-6BBAE056E610}" type="pres">
+      <dgm:prSet presAssocID="{6D47D18C-BDB8-419A-8C72-B443C45CBFD2}" presName="spacer" presStyleCnt="0"/>
+      <dgm:spPr/>
+    </dgm:pt>
+    <dgm:pt modelId="{144AC980-0E58-44DE-9F3D-37C6ECEE8D48}" type="pres">
+      <dgm:prSet presAssocID="{66D4ED4D-2AA1-49EB-9E6D-B9383C208A7C}" presName="parentText" presStyleLbl="node1" presStyleIdx="4" presStyleCnt="5">
+        <dgm:presLayoutVars>
+          <dgm:chMax val="0"/>
+          <dgm:bulletEnabled val="1"/>
+        </dgm:presLayoutVars>
+      </dgm:prSet>
+      <dgm:spPr/>
+    </dgm:pt>
+  </dgm:ptLst>
+  <dgm:cxnLst>
+    <dgm:cxn modelId="{90E4BC10-3530-4C27-AB72-CE570B4BDD16}" type="presOf" srcId="{DA82F6B8-90F8-4344-8C66-D9963ABC4718}" destId="{3AC64C58-049E-48B7-A4B1-7FFDCC7B733D}" srcOrd="0" destOrd="0" presId="urn:microsoft.com/office/officeart/2005/8/layout/vList2"/>
+    <dgm:cxn modelId="{2E379828-6C8D-4E0E-BEEE-6B896BC2D513}" type="presOf" srcId="{2CBFF9C9-7D52-4E19-8855-51A653DA9CE0}" destId="{08340771-1E08-499D-B061-F6E9817A5989}" srcOrd="0" destOrd="0" presId="urn:microsoft.com/office/officeart/2005/8/layout/vList2"/>
+    <dgm:cxn modelId="{4DEE4B38-25AE-4616-A426-3206D1698546}" srcId="{2CBFF9C9-7D52-4E19-8855-51A653DA9CE0}" destId="{5AE49A12-D260-4810-BECD-FFDF7ACADA64}" srcOrd="0" destOrd="0" parTransId="{217EA87A-9A51-49F9-A1A4-153A9BEED941}" sibTransId="{614383F1-2CA4-486E-BD11-E15C0E57EA4B}"/>
+    <dgm:cxn modelId="{4FC6EC40-C71C-4869-9736-4031BBA613A7}" srcId="{2CBFF9C9-7D52-4E19-8855-51A653DA9CE0}" destId="{63B7DA53-67BD-4660-A51F-94DE2E9B9388}" srcOrd="1" destOrd="0" parTransId="{A7EC64BC-081C-44F0-A77C-910B669EECE8}" sibTransId="{90C1431C-CDD8-40D7-9696-4550FA0FEE8C}"/>
+    <dgm:cxn modelId="{E5004056-9436-406A-B350-E8253146CBF6}" type="presOf" srcId="{63B7DA53-67BD-4660-A51F-94DE2E9B9388}" destId="{9A78BA5F-3F61-4966-8D40-33CC1F8A5F05}" srcOrd="0" destOrd="0" presId="urn:microsoft.com/office/officeart/2005/8/layout/vList2"/>
+    <dgm:cxn modelId="{5080F39F-48D2-4898-9089-5D62C1A0A3F0}" srcId="{2CBFF9C9-7D52-4E19-8855-51A653DA9CE0}" destId="{8B4047EE-5885-441F-A8B4-2102BFB1E95E}" srcOrd="3" destOrd="0" parTransId="{6B2E7593-FAB8-4C66-85DF-21BE397611D5}" sibTransId="{6D47D18C-BDB8-419A-8C72-B443C45CBFD2}"/>
+    <dgm:cxn modelId="{A425F6B2-555E-4B81-87CE-9D85BA965D8A}" srcId="{2CBFF9C9-7D52-4E19-8855-51A653DA9CE0}" destId="{66D4ED4D-2AA1-49EB-9E6D-B9383C208A7C}" srcOrd="4" destOrd="0" parTransId="{35D6470E-B375-416A-8A3A-44572DAC5454}" sibTransId="{48173F67-9961-47D6-B7FC-EFCEEC3D23D5}"/>
+    <dgm:cxn modelId="{6DAEFDB2-00CA-45C0-963D-62791E99E46D}" type="presOf" srcId="{66D4ED4D-2AA1-49EB-9E6D-B9383C208A7C}" destId="{144AC980-0E58-44DE-9F3D-37C6ECEE8D48}" srcOrd="0" destOrd="0" presId="urn:microsoft.com/office/officeart/2005/8/layout/vList2"/>
+    <dgm:cxn modelId="{9C657DDF-D5CB-43CB-8B70-AD0618046BB4}" type="presOf" srcId="{8B4047EE-5885-441F-A8B4-2102BFB1E95E}" destId="{71E73A01-88FB-4041-949C-EEAF12DE5BC9}" srcOrd="0" destOrd="0" presId="urn:microsoft.com/office/officeart/2005/8/layout/vList2"/>
+    <dgm:cxn modelId="{8F66FEF3-5D7E-4A81-B947-73CE2C59DBD3}" srcId="{2CBFF9C9-7D52-4E19-8855-51A653DA9CE0}" destId="{DA82F6B8-90F8-4344-8C66-D9963ABC4718}" srcOrd="2" destOrd="0" parTransId="{DE67D9E0-CE55-487C-B1AC-74FE27DB8B07}" sibTransId="{276FECA6-7797-467F-8CC8-9127F5F5D2DC}"/>
+    <dgm:cxn modelId="{A9EF13F4-FA88-4001-A947-2CB700099CE1}" type="presOf" srcId="{5AE49A12-D260-4810-BECD-FFDF7ACADA64}" destId="{1D0C178C-8A63-4E6C-A33C-6B65F9F9C5DA}" srcOrd="0" destOrd="0" presId="urn:microsoft.com/office/officeart/2005/8/layout/vList2"/>
+    <dgm:cxn modelId="{250AAB6E-820C-4B71-ADC9-2572CA10919C}" type="presParOf" srcId="{08340771-1E08-499D-B061-F6E9817A5989}" destId="{1D0C178C-8A63-4E6C-A33C-6B65F9F9C5DA}" srcOrd="0" destOrd="0" presId="urn:microsoft.com/office/officeart/2005/8/layout/vList2"/>
+    <dgm:cxn modelId="{85547934-DD8F-464B-81D6-C02513A6AF5B}" type="presParOf" srcId="{08340771-1E08-499D-B061-F6E9817A5989}" destId="{45AF726E-64EC-4DD0-AFA4-0B0F1A60AB5D}" srcOrd="1" destOrd="0" presId="urn:microsoft.com/office/officeart/2005/8/layout/vList2"/>
+    <dgm:cxn modelId="{8CADEBE2-3C1C-4610-9AD5-E02079A4149D}" type="presParOf" srcId="{08340771-1E08-499D-B061-F6E9817A5989}" destId="{9A78BA5F-3F61-4966-8D40-33CC1F8A5F05}" srcOrd="2" destOrd="0" presId="urn:microsoft.com/office/officeart/2005/8/layout/vList2"/>
+    <dgm:cxn modelId="{D3AEA088-4817-4684-9E94-C16F3C0C6384}" type="presParOf" srcId="{08340771-1E08-499D-B061-F6E9817A5989}" destId="{BDDB3D8D-6D53-4D90-8012-0DC1779B6936}" srcOrd="3" destOrd="0" presId="urn:microsoft.com/office/officeart/2005/8/layout/vList2"/>
+    <dgm:cxn modelId="{5EE86E89-8924-48EE-B1D6-67E8EA5AC068}" type="presParOf" srcId="{08340771-1E08-499D-B061-F6E9817A5989}" destId="{3AC64C58-049E-48B7-A4B1-7FFDCC7B733D}" srcOrd="4" destOrd="0" presId="urn:microsoft.com/office/officeart/2005/8/layout/vList2"/>
+    <dgm:cxn modelId="{91C793A6-2807-4DBD-A790-EDF64D50F95A}" type="presParOf" srcId="{08340771-1E08-499D-B061-F6E9817A5989}" destId="{6AD94703-60BE-48BC-AA56-193E5B63756F}" srcOrd="5" destOrd="0" presId="urn:microsoft.com/office/officeart/2005/8/layout/vList2"/>
+    <dgm:cxn modelId="{1131412F-B865-4EEF-9C50-EC0BEFB15AB7}" type="presParOf" srcId="{08340771-1E08-499D-B061-F6E9817A5989}" destId="{71E73A01-88FB-4041-949C-EEAF12DE5BC9}" srcOrd="6" destOrd="0" presId="urn:microsoft.com/office/officeart/2005/8/layout/vList2"/>
+    <dgm:cxn modelId="{F0504719-CA5E-4557-B2DA-DE46EF9AF849}" type="presParOf" srcId="{08340771-1E08-499D-B061-F6E9817A5989}" destId="{A8B1970D-BEC6-4DF4-9CF8-6BBAE056E610}" srcOrd="7" destOrd="0" presId="urn:microsoft.com/office/officeart/2005/8/layout/vList2"/>
+    <dgm:cxn modelId="{2D32D445-DA2A-486E-B0C3-D790E0E07FE6}" type="presParOf" srcId="{08340771-1E08-499D-B061-F6E9817A5989}" destId="{144AC980-0E58-44DE-9F3D-37C6ECEE8D48}" srcOrd="8" destOrd="0" presId="urn:microsoft.com/office/officeart/2005/8/layout/vList2"/>
+  </dgm:cxnLst>
+  <dgm:bg/>
+  <dgm:whole/>
+  <dgm:extLst>
+    <a:ext uri="http://schemas.microsoft.com/office/drawing/2008/diagram">
+      <dsp:dataModelExt xmlns:dsp="http://schemas.microsoft.com/office/drawing/2008/diagram" relId="rId7" minVer="http://schemas.openxmlformats.org/drawingml/2006/diagram"/>
+    </a:ext>
+  </dgm:extLst>
+</dgm:dataModel>
+</file>
+
+<file path=ppt/diagrams/drawing1.xml><?xml version="1.0" encoding="utf-8"?>
+<dsp:drawing xmlns:dgm="http://schemas.openxmlformats.org/drawingml/2006/diagram" xmlns:dsp="http://schemas.microsoft.com/office/drawing/2008/diagram" xmlns:a="http://schemas.openxmlformats.org/drawingml/2006/main">
+  <dsp:spTree>
+    <dsp:nvGrpSpPr>
+      <dsp:cNvPr id="0" name=""/>
+      <dsp:cNvGrpSpPr/>
+    </dsp:nvGrpSpPr>
+    <dsp:grpSpPr/>
+    <dsp:sp modelId="{1D0C178C-8A63-4E6C-A33C-6B65F9F9C5DA}">
+      <dsp:nvSpPr>
+        <dsp:cNvPr id="0" name=""/>
+        <dsp:cNvSpPr/>
+      </dsp:nvSpPr>
+      <dsp:spPr>
+        <a:xfrm>
+          <a:off x="0" y="103649"/>
+          <a:ext cx="5811128" cy="1034280"/>
+        </a:xfrm>
+        <a:prstGeom prst="roundRect">
+          <a:avLst/>
+        </a:prstGeom>
+        <a:solidFill>
+          <a:schemeClr val="accent5">
+            <a:hueOff val="0"/>
+            <a:satOff val="0"/>
+            <a:lumOff val="0"/>
+            <a:alphaOff val="0"/>
+          </a:schemeClr>
+        </a:solidFill>
+        <a:ln w="12700" cap="flat" cmpd="sng">
+          <a:solidFill>
+            <a:schemeClr val="lt1">
+              <a:hueOff val="0"/>
+              <a:satOff val="0"/>
+              <a:lumOff val="0"/>
+              <a:alphaOff val="0"/>
+            </a:schemeClr>
+          </a:solidFill>
+          <a:prstDash val="solid"/>
+        </a:ln>
+        <a:effectLst/>
+      </dsp:spPr>
+      <dsp:style>
+        <a:lnRef idx="2">
+          <a:scrgbClr r="0" g="0" b="0"/>
+        </a:lnRef>
+        <a:fillRef idx="1">
+          <a:scrgbClr r="0" g="0" b="0"/>
+        </a:fillRef>
+        <a:effectRef idx="0">
+          <a:scrgbClr r="0" g="0" b="0"/>
+        </a:effectRef>
+        <a:fontRef idx="minor">
+          <a:schemeClr val="lt1"/>
+        </a:fontRef>
+      </dsp:style>
+      <dsp:txBody>
+        <a:bodyPr spcFirstLastPara="0" vert="horz" wrap="square" lIns="99060" tIns="99060" rIns="99060" bIns="99060" numCol="1" spcCol="1270" anchor="ctr" anchorCtr="0">
+          <a:noAutofit/>
+        </a:bodyPr>
+        <a:lstStyle/>
+        <a:p>
+          <a:pPr marL="0" lvl="0" indent="0" algn="l" defTabSz="1155700">
+            <a:lnSpc>
+              <a:spcPct val="90000"/>
+            </a:lnSpc>
+            <a:spcBef>
+              <a:spcPct val="0"/>
+            </a:spcBef>
+            <a:spcAft>
+              <a:spcPct val="35000"/>
+            </a:spcAft>
+            <a:buNone/>
+          </a:pPr>
+          <a:r>
+            <a:rPr lang="en-US" sz="2600" kern="1200"/>
+            <a:t>AI progress is cyclical, not a straight upward line</a:t>
+          </a:r>
+        </a:p>
+      </dsp:txBody>
+      <dsp:txXfrm>
+        <a:off x="50489" y="154138"/>
+        <a:ext cx="5710150" cy="933302"/>
+      </dsp:txXfrm>
+    </dsp:sp>
+    <dsp:sp modelId="{9A78BA5F-3F61-4966-8D40-33CC1F8A5F05}">
+      <dsp:nvSpPr>
+        <dsp:cNvPr id="0" name=""/>
+        <dsp:cNvSpPr/>
+      </dsp:nvSpPr>
+      <dsp:spPr>
+        <a:xfrm>
+          <a:off x="0" y="1212809"/>
+          <a:ext cx="5811128" cy="1034280"/>
+        </a:xfrm>
+        <a:prstGeom prst="roundRect">
+          <a:avLst/>
+        </a:prstGeom>
+        <a:solidFill>
+          <a:schemeClr val="accent5">
+            <a:hueOff val="-1689636"/>
+            <a:satOff val="-4355"/>
+            <a:lumOff val="-2941"/>
+            <a:alphaOff val="0"/>
+          </a:schemeClr>
+        </a:solidFill>
+        <a:ln w="12700" cap="flat" cmpd="sng">
+          <a:solidFill>
+            <a:schemeClr val="lt1">
+              <a:hueOff val="0"/>
+              <a:satOff val="0"/>
+              <a:lumOff val="0"/>
+              <a:alphaOff val="0"/>
+            </a:schemeClr>
+          </a:solidFill>
+          <a:prstDash val="solid"/>
+        </a:ln>
+        <a:effectLst/>
+      </dsp:spPr>
+      <dsp:style>
+        <a:lnRef idx="2">
+          <a:scrgbClr r="0" g="0" b="0"/>
+        </a:lnRef>
+        <a:fillRef idx="1">
+          <a:scrgbClr r="0" g="0" b="0"/>
+        </a:fillRef>
+        <a:effectRef idx="0">
+          <a:scrgbClr r="0" g="0" b="0"/>
+        </a:effectRef>
+        <a:fontRef idx="minor">
+          <a:schemeClr val="lt1"/>
+        </a:fontRef>
+      </dsp:style>
+      <dsp:txBody>
+        <a:bodyPr spcFirstLastPara="0" vert="horz" wrap="square" lIns="99060" tIns="99060" rIns="99060" bIns="99060" numCol="1" spcCol="1270" anchor="ctr" anchorCtr="0">
+          <a:noAutofit/>
+        </a:bodyPr>
+        <a:lstStyle/>
+        <a:p>
+          <a:pPr marL="0" lvl="0" indent="0" algn="l" defTabSz="1155700">
+            <a:lnSpc>
+              <a:spcPct val="90000"/>
+            </a:lnSpc>
+            <a:spcBef>
+              <a:spcPct val="0"/>
+            </a:spcBef>
+            <a:spcAft>
+              <a:spcPct val="35000"/>
+            </a:spcAft>
+            <a:buNone/>
+          </a:pPr>
+          <a:r>
+            <a:rPr lang="en-US" sz="2600" kern="1200"/>
+            <a:t>Cycle: breakthrough, hype, overpromise, disappointment, funding collapse</a:t>
+          </a:r>
+        </a:p>
+      </dsp:txBody>
+      <dsp:txXfrm>
+        <a:off x="50489" y="1263298"/>
+        <a:ext cx="5710150" cy="933302"/>
+      </dsp:txXfrm>
+    </dsp:sp>
+    <dsp:sp modelId="{3AC64C58-049E-48B7-A4B1-7FFDCC7B733D}">
+      <dsp:nvSpPr>
+        <dsp:cNvPr id="0" name=""/>
+        <dsp:cNvSpPr/>
+      </dsp:nvSpPr>
+      <dsp:spPr>
+        <a:xfrm>
+          <a:off x="0" y="2321969"/>
+          <a:ext cx="5811128" cy="1034280"/>
+        </a:xfrm>
+        <a:prstGeom prst="roundRect">
+          <a:avLst/>
+        </a:prstGeom>
+        <a:solidFill>
+          <a:schemeClr val="accent5">
+            <a:hueOff val="-3379271"/>
+            <a:satOff val="-8710"/>
+            <a:lumOff val="-5883"/>
+            <a:alphaOff val="0"/>
+          </a:schemeClr>
+        </a:solidFill>
+        <a:ln w="12700" cap="flat" cmpd="sng">
+          <a:solidFill>
+            <a:schemeClr val="lt1">
+              <a:hueOff val="0"/>
+              <a:satOff val="0"/>
+              <a:lumOff val="0"/>
+              <a:alphaOff val="0"/>
+            </a:schemeClr>
+          </a:solidFill>
+          <a:prstDash val="solid"/>
+        </a:ln>
+        <a:effectLst/>
+      </dsp:spPr>
+      <dsp:style>
+        <a:lnRef idx="2">
+          <a:scrgbClr r="0" g="0" b="0"/>
+        </a:lnRef>
+        <a:fillRef idx="1">
+          <a:scrgbClr r="0" g="0" b="0"/>
+        </a:fillRef>
+        <a:effectRef idx="0">
+          <a:scrgbClr r="0" g="0" b="0"/>
+        </a:effectRef>
+        <a:fontRef idx="minor">
+          <a:schemeClr val="lt1"/>
+        </a:fontRef>
+      </dsp:style>
+      <dsp:txBody>
+        <a:bodyPr spcFirstLastPara="0" vert="horz" wrap="square" lIns="99060" tIns="99060" rIns="99060" bIns="99060" numCol="1" spcCol="1270" anchor="ctr" anchorCtr="0">
+          <a:noAutofit/>
+        </a:bodyPr>
+        <a:lstStyle/>
+        <a:p>
+          <a:pPr marL="0" lvl="0" indent="0" algn="l" defTabSz="1155700">
+            <a:lnSpc>
+              <a:spcPct val="90000"/>
+            </a:lnSpc>
+            <a:spcBef>
+              <a:spcPct val="0"/>
+            </a:spcBef>
+            <a:spcAft>
+              <a:spcPct val="35000"/>
+            </a:spcAft>
+            <a:buNone/>
+          </a:pPr>
+          <a:r>
+            <a:rPr lang="en-US" sz="2600" kern="1200"/>
+            <a:t>'AI winter' means sustained cuts in funding and interest</a:t>
+          </a:r>
+        </a:p>
+      </dsp:txBody>
+      <dsp:txXfrm>
+        <a:off x="50489" y="2372458"/>
+        <a:ext cx="5710150" cy="933302"/>
+      </dsp:txXfrm>
+    </dsp:sp>
+    <dsp:sp modelId="{71E73A01-88FB-4041-949C-EEAF12DE5BC9}">
+      <dsp:nvSpPr>
+        <dsp:cNvPr id="0" name=""/>
+        <dsp:cNvSpPr/>
+      </dsp:nvSpPr>
+      <dsp:spPr>
+        <a:xfrm>
+          <a:off x="0" y="3431129"/>
+          <a:ext cx="5811128" cy="1034280"/>
+        </a:xfrm>
+        <a:prstGeom prst="roundRect">
+          <a:avLst/>
+        </a:prstGeom>
+        <a:solidFill>
+          <a:schemeClr val="accent5">
+            <a:hueOff val="-5068907"/>
+            <a:satOff val="-13064"/>
+            <a:lumOff val="-8824"/>
+            <a:alphaOff val="0"/>
+          </a:schemeClr>
+        </a:solidFill>
+        <a:ln w="12700" cap="flat" cmpd="sng">
+          <a:solidFill>
+            <a:schemeClr val="lt1">
+              <a:hueOff val="0"/>
+              <a:satOff val="0"/>
+              <a:lumOff val="0"/>
+              <a:alphaOff val="0"/>
+            </a:schemeClr>
+          </a:solidFill>
+          <a:prstDash val="solid"/>
+        </a:ln>
+        <a:effectLst/>
+      </dsp:spPr>
+      <dsp:style>
+        <a:lnRef idx="2">
+          <a:scrgbClr r="0" g="0" b="0"/>
+        </a:lnRef>
+        <a:fillRef idx="1">
+          <a:scrgbClr r="0" g="0" b="0"/>
+        </a:fillRef>
+        <a:effectRef idx="0">
+          <a:scrgbClr r="0" g="0" b="0"/>
+        </a:effectRef>
+        <a:fontRef idx="minor">
+          <a:schemeClr val="lt1"/>
+        </a:fontRef>
+      </dsp:style>
+      <dsp:txBody>
+        <a:bodyPr spcFirstLastPara="0" vert="horz" wrap="square" lIns="99060" tIns="99060" rIns="99060" bIns="99060" numCol="1" spcCol="1270" anchor="ctr" anchorCtr="0">
+          <a:noAutofit/>
+        </a:bodyPr>
+        <a:lstStyle/>
+        <a:p>
+          <a:pPr marL="0" lvl="0" indent="0" algn="l" defTabSz="1155700">
+            <a:lnSpc>
+              <a:spcPct val="90000"/>
+            </a:lnSpc>
+            <a:spcBef>
+              <a:spcPct val="0"/>
+            </a:spcBef>
+            <a:spcAft>
+              <a:spcPct val="35000"/>
+            </a:spcAft>
+            <a:buNone/>
+          </a:pPr>
+          <a:r>
+            <a:rPr lang="en-US" sz="2600" kern="1200"/>
+            <a:t>Pattern repeats because expectations outrun technical reality</a:t>
+          </a:r>
+        </a:p>
+      </dsp:txBody>
+      <dsp:txXfrm>
+        <a:off x="50489" y="3481618"/>
+        <a:ext cx="5710150" cy="933302"/>
+      </dsp:txXfrm>
+    </dsp:sp>
+    <dsp:sp modelId="{144AC980-0E58-44DE-9F3D-37C6ECEE8D48}">
+      <dsp:nvSpPr>
+        <dsp:cNvPr id="0" name=""/>
+        <dsp:cNvSpPr/>
+      </dsp:nvSpPr>
+      <dsp:spPr>
+        <a:xfrm>
+          <a:off x="0" y="4540289"/>
+          <a:ext cx="5811128" cy="1034280"/>
+        </a:xfrm>
+        <a:prstGeom prst="roundRect">
+          <a:avLst/>
+        </a:prstGeom>
+        <a:solidFill>
+          <a:schemeClr val="accent5">
+            <a:hueOff val="-6758543"/>
+            <a:satOff val="-17419"/>
+            <a:lumOff val="-11765"/>
+            <a:alphaOff val="0"/>
+          </a:schemeClr>
+        </a:solidFill>
+        <a:ln w="12700" cap="flat" cmpd="sng">
+          <a:solidFill>
+            <a:schemeClr val="lt1">
+              <a:hueOff val="0"/>
+              <a:satOff val="0"/>
+              <a:lumOff val="0"/>
+              <a:alphaOff val="0"/>
+            </a:schemeClr>
+          </a:solidFill>
+          <a:prstDash val="solid"/>
+        </a:ln>
+        <a:effectLst/>
+      </dsp:spPr>
+      <dsp:style>
+        <a:lnRef idx="2">
+          <a:scrgbClr r="0" g="0" b="0"/>
+        </a:lnRef>
+        <a:fillRef idx="1">
+          <a:scrgbClr r="0" g="0" b="0"/>
+        </a:fillRef>
+        <a:effectRef idx="0">
+          <a:scrgbClr r="0" g="0" b="0"/>
+        </a:effectRef>
+        <a:fontRef idx="minor">
+          <a:schemeClr val="lt1"/>
+        </a:fontRef>
+      </dsp:style>
+      <dsp:txBody>
+        <a:bodyPr spcFirstLastPara="0" vert="horz" wrap="square" lIns="99060" tIns="99060" rIns="99060" bIns="99060" numCol="1" spcCol="1270" anchor="ctr" anchorCtr="0">
+          <a:noAutofit/>
+        </a:bodyPr>
+        <a:lstStyle/>
+        <a:p>
+          <a:pPr marL="0" lvl="0" indent="0" algn="l" defTabSz="1155700">
+            <a:lnSpc>
+              <a:spcPct val="90000"/>
+            </a:lnSpc>
+            <a:spcBef>
+              <a:spcPct val="0"/>
+            </a:spcBef>
+            <a:spcAft>
+              <a:spcPct val="35000"/>
+            </a:spcAft>
+            <a:buNone/>
+          </a:pPr>
+          <a:r>
+            <a:rPr lang="en-US" sz="2600" kern="1200"/>
+            <a:t>Understanding cycles explains today's field structure and vocabulary</a:t>
+          </a:r>
+        </a:p>
+      </dsp:txBody>
+      <dsp:txXfrm>
+        <a:off x="50489" y="4590778"/>
+        <a:ext cx="5710150" cy="933302"/>
+      </dsp:txXfrm>
+    </dsp:sp>
+  </dsp:spTree>
+</dsp:drawing>
+</file>
+
+<file path=ppt/diagrams/layout1.xml><?xml version="1.0" encoding="utf-8"?>
+<dgm:layoutDef xmlns:dgm="http://schemas.openxmlformats.org/drawingml/2006/diagram" xmlns:a="http://schemas.openxmlformats.org/drawingml/2006/main" uniqueId="urn:microsoft.com/office/officeart/2005/8/layout/vList2">
+  <dgm:title val=""/>
+  <dgm:desc val=""/>
+  <dgm:catLst>
+    <dgm:cat type="list" pri="3000"/>
+    <dgm:cat type="convert" pri="1000"/>
+  </dgm:catLst>
+  <dgm:sampData>
+    <dgm:dataModel>
+      <dgm:ptLst>
+        <dgm:pt modelId="0" type="doc"/>
+        <dgm:pt modelId="1">
+          <dgm:prSet phldr="1"/>
+        </dgm:pt>
+        <dgm:pt modelId="11">
+          <dgm:prSet phldr="1"/>
+        </dgm:pt>
+        <dgm:pt modelId="2">
+          <dgm:prSet phldr="1"/>
+        </dgm:pt>
+        <dgm:pt modelId="21">
+          <dgm:prSet phldr="1"/>
+        </dgm:pt>
+      </dgm:ptLst>
+      <dgm:cxnLst>
+        <dgm:cxn modelId="4" srcId="0" destId="1" srcOrd="0" destOrd="0"/>
+        <dgm:cxn modelId="5" srcId="0" destId="2" srcOrd="1" destOrd="0"/>
+        <dgm:cxn modelId="12" srcId="1" destId="11" srcOrd="0" destOrd="0"/>
+        <dgm:cxn modelId="23" srcId="2" destId="21" srcOrd="0" destOrd="0"/>
+      </dgm:cxnLst>
+      <dgm:bg/>
+      <dgm:whole/>
+    </dgm:dataModel>
+  </dgm:sampData>
+  <dgm:styleData>
+    <dgm:dataModel>
+      <dgm:ptLst>
+        <dgm:pt modelId="0" type="doc"/>
+        <dgm:pt modelId="1"/>
+        <dgm:pt modelId="2"/>
+      </dgm:ptLst>
+      <dgm:cxnLst>
+        <dgm:cxn modelId="3" srcId="0" destId="1" srcOrd="0" destOrd="0"/>
+        <dgm:cxn modelId="4" srcId="0" destId="2" srcOrd="1" destOrd="0"/>
+      </dgm:cxnLst>
+      <dgm:bg/>
+      <dgm:whole/>
+    </dgm:dataModel>
+  </dgm:styleData>
+  <dgm:clrData>
+    <dgm:dataModel>
+      <dgm:ptLst>
+        <dgm:pt modelId="0" type="doc"/>
+        <dgm:pt modelId="1"/>
+        <dgm:pt modelId="2"/>
+        <dgm:pt modelId="3"/>
+        <dgm:pt modelId="4"/>
+      </dgm:ptLst>
+      <dgm:cxnLst>
+        <dgm:cxn modelId="5" srcId="0" destId="1" srcOrd="0" destOrd="0"/>
+        <dgm:cxn modelId="6" srcId="0" destId="2" srcOrd="1" destOrd="0"/>
+        <dgm:cxn modelId="7" srcId="0" destId="3" srcOrd="2" destOrd="0"/>
+        <dgm:cxn modelId="8" srcId="0" destId="4" srcOrd="3" destOrd="0"/>
+      </dgm:cxnLst>
+      <dgm:bg/>
+      <dgm:whole/>
+    </dgm:dataModel>
+  </dgm:clrData>
+  <dgm:layoutNode name="linear">
+    <dgm:varLst>
+      <dgm:animLvl val="lvl"/>
+      <dgm:resizeHandles val="exact"/>
+    </dgm:varLst>
+    <dgm:alg type="lin">
+      <dgm:param type="linDir" val="fromT"/>
+      <dgm:param type="vertAlign" val="mid"/>
+    </dgm:alg>
+    <dgm:shape xmlns:r="http://schemas.openxmlformats.org/officeDocument/2006/relationships" r:blip="">
+      <dgm:adjLst/>
+    </dgm:shape>
+    <dgm:presOf/>
+    <dgm:constrLst>
+      <dgm:constr type="w" for="ch" forName="parentText" refType="w"/>
+      <dgm:constr type="h" for="ch" forName="parentText" refType="primFontSz" refFor="ch" refForName="parentText" fact="0.52"/>
+      <dgm:constr type="w" for="ch" forName="childText" refType="w"/>
+      <dgm:constr type="h" for="ch" forName="childText" refType="primFontSz" refFor="ch" refForName="parentText" fact="0.46"/>
+      <dgm:constr type="h" for="ch" forName="parentText" op="equ"/>
+      <dgm:constr type="primFontSz" for="ch" forName="parentText" op="equ" val="65"/>
+      <dgm:constr type="primFontSz" for="ch" forName="childText" refType="primFontSz" refFor="ch" refForName="parentText" op="equ"/>
+      <dgm:constr type="h" for="ch" forName="spacer" refType="primFontSz" refFor="ch" refForName="parentText" fact="0.08"/>
+    </dgm:constrLst>
+    <dgm:ruleLst>
+      <dgm:rule type="primFontSz" for="ch" forName="parentText" val="5" fact="NaN" max="NaN"/>
+    </dgm:ruleLst>
+    <dgm:forEach name="Name0" axis="ch" ptType="node">
+      <dgm:layoutNode name="parentText" styleLbl="node1">
+        <dgm:varLst>
+          <dgm:chMax val="0"/>
+          <dgm:bulletEnabled val="1"/>
+        </dgm:varLst>
+        <dgm:alg type="tx">
+          <dgm:param type="parTxLTRAlign" val="l"/>
+          <dgm:param type="parTxRTLAlign" val="r"/>
+        </dgm:alg>
+        <dgm:shape xmlns:r="http://schemas.openxmlformats.org/officeDocument/2006/relationships" type="roundRect" r:blip="">
+          <dgm:adjLst/>
+        </dgm:shape>
+        <dgm:presOf axis="self"/>
+        <dgm:constrLst>
+          <dgm:constr type="tMarg" refType="primFontSz" fact="0.3"/>
+          <dgm:constr type="bMarg" refType="primFontSz" fact="0.3"/>
+          <dgm:constr type="lMarg" refType="primFontSz" fact="0.3"/>
+          <dgm:constr type="rMarg" refType="primFontSz" fact="0.3"/>
+        </dgm:constrLst>
+        <dgm:ruleLst>
+          <dgm:rule type="h" val="INF" fact="NaN" max="NaN"/>
+        </dgm:ruleLst>
+      </dgm:layoutNode>
+      <dgm:choose name="Name1">
+        <dgm:if name="Name2" axis="ch" ptType="node" func="cnt" op="gte" val="1">
+          <dgm:layoutNode name="childText" styleLbl="revTx">
+            <dgm:varLst>
+              <dgm:bulletEnabled val="1"/>
+            </dgm:varLst>
+            <dgm:alg type="tx">
+              <dgm:param type="stBulletLvl" val="1"/>
+              <dgm:param type="lnSpAfChP" val="20"/>
+            </dgm:alg>
+            <dgm:shape xmlns:r="http://schemas.openxmlformats.org/officeDocument/2006/relationships" type="rect" r:blip="">
+              <dgm:adjLst/>
+            </dgm:shape>
+            <dgm:presOf axis="des" ptType="node"/>
+            <dgm:constrLst>
+              <dgm:constr type="tMarg" refType="primFontSz" fact="0.1"/>
+              <dgm:constr type="bMarg" refType="primFontSz" fact="0.1"/>
+              <dgm:constr type="lMarg" refType="w" fact="0.09"/>
+            </dgm:constrLst>
+            <dgm:ruleLst>
+              <dgm:rule type="h" val="INF" fact="NaN" max="NaN"/>
+            </dgm:ruleLst>
+          </dgm:layoutNode>
+        </dgm:if>
+        <dgm:else name="Name3">
+          <dgm:choose name="Name4">
+            <dgm:if name="Name5" axis="par ch" ptType="doc node" func="cnt" op="gte" val="2">
+              <dgm:forEach name="Name6" axis="followSib" ptType="sibTrans" cnt="1">
+                <dgm:layoutNode name="spacer">
+                  <dgm:alg type="sp"/>
+                  <dgm:shape xmlns:r="http://schemas.openxmlformats.org/officeDocument/2006/relationships" r:blip="">
+                    <dgm:adjLst/>
+                  </dgm:shape>
+                  <dgm:presOf/>
+                  <dgm:constrLst/>
+                  <dgm:ruleLst/>
+                </dgm:layoutNode>
+              </dgm:forEach>
+            </dgm:if>
+            <dgm:else name="Name7"/>
+          </dgm:choose>
+        </dgm:else>
+      </dgm:choose>
+    </dgm:forEach>
+  </dgm:layoutNode>
+</dgm:layoutDef>
+</file>
+
+<file path=ppt/diagrams/quickStyle1.xml><?xml version="1.0" encoding="utf-8"?>
+<dgm:styleDef xmlns:dgm="http://schemas.openxmlformats.org/drawingml/2006/diagram" xmlns:a="http://schemas.openxmlformats.org/drawingml/2006/main" uniqueId="urn:microsoft.com/office/officeart/2005/8/quickstyle/simple1">
+  <dgm:title val=""/>
+  <dgm:desc val=""/>
+  <dgm:catLst>
+    <dgm:cat type="simple" pri="10100"/>
+  </dgm:catLst>
+  <dgm:scene3d>
+    <a:camera prst="orthographicFront"/>
+    <a:lightRig rig="threePt" dir="t"/>
+  </dgm:scene3d>
+  <dgm:styleLbl name="node0">
+    <dgm:scene3d>
+      <a:camera prst="orthographicFront"/>
+      <a:lightRig rig="threePt" dir="t"/>
+    </dgm:scene3d>
+    <dgm:sp3d/>
+    <dgm:txPr/>
+    <dgm:style>
+      <a:lnRef idx="2">
+        <a:scrgbClr r="0" g="0" b="0"/>
+      </a:lnRef>
+      <a:fillRef idx="1">
+        <a:scrgbClr r="0" g="0" b="0"/>
+      </a:fillRef>
+      <a:effectRef idx="0">
+        <a:scrgbClr r="0" g="0" b="0"/>
+      </a:effectRef>
+      <a:fontRef idx="minor">
+        <a:schemeClr val="lt1"/>
+      </a:fontRef>
+    </dgm:style>
+  </dgm:styleLbl>
+  <dgm:styleLbl name="lnNode1">
+    <dgm:scene3d>
+      <a:camera prst="orthographicFront"/>
+      <a:lightRig rig="threePt" dir="t"/>
+    </dgm:scene3d>
+    <dgm:sp3d/>
+    <dgm:txPr/>
+    <dgm:style>
+      <a:lnRef idx="2">
+        <a:scrgbClr r="0" g="0" b="0"/>
+      </a:lnRef>
+      <a:fillRef idx="1">
+        <a:scrgbClr r="0" g="0" b="0"/>
+      </a:fillRef>
+      <a:effectRef idx="0">
+        <a:scrgbClr r="0" g="0" b="0"/>
+      </a:effectRef>
+      <a:fontRef idx="minor">
+        <a:schemeClr val="lt1"/>
+      </a:fontRef>
+    </dgm:style>
+  </dgm:styleLbl>
+  <dgm:styleLbl name="vennNode1">
+    <dgm:scene3d>
+      <a:camera prst="orthographicFront"/>
+      <a:lightRig rig="threePt" dir="t"/>
+    </dgm:scene3d>
+    <dgm:sp3d/>
+    <dgm:txPr/>
+    <dgm:style>
+      <a:lnRef idx="2">
+        <a:scrgbClr r="0" g="0" b="0"/>
+      </a:lnRef>
+      <a:fillRef idx="1">
+        <a:scrgbClr r="0" g="0" b="0"/>
+      </a:fillRef>
+      <a:effectRef idx="0">
+        <a:scrgbClr r="0" g="0" b="0"/>
+      </a:effectRef>
+      <a:fontRef idx="minor">
+        <a:schemeClr val="tx1"/>
+      </a:fontRef>
+    </dgm:style>
+  </dgm:styleLbl>
+  <dgm:styleLbl name="alignNode1">
+    <dgm:scene3d>
+      <a:camera prst="orthographicFront"/>
+      <a:lightRig rig="threePt" dir="t"/>
+    </dgm:scene3d>
+    <dgm:sp3d/>
+    <dgm:txPr/>
+    <dgm:style>
+      <a:lnRef idx="2">
+        <a:scrgbClr r="0" g="0" b="0"/>
+      </a:lnRef>
+      <a:fillRef idx="1">
+        <a:scrgbClr r="0" g="0" b="0"/>
+      </a:fillRef>
+      <a:effectRef idx="0">
+        <a:scrgbClr r="0" g="0" b="0"/>
+      </a:effectRef>
+      <a:fontRef idx="minor">
+        <a:schemeClr val="lt1"/>
+      </a:fontRef>
+    </dgm:style>
+  </dgm:styleLbl>
+  <dgm:styleLbl name="node1">
+    <dgm:scene3d>
+      <a:camera prst="orthographicFront"/>
+      <a:lightRig rig="threePt" dir="t"/>
+    </dgm:scene3d>
+    <dgm:sp3d/>
+    <dgm:txPr/>
+    <dgm:style>
+      <a:lnRef idx="2">
+        <a:scrgbClr r="0" g="0" b="0"/>
+      </a:lnRef>
+      <a:fillRef idx="1">
+        <a:scrgbClr r="0" g="0" b="0"/>
+      </a:fillRef>
+      <a:effectRef idx="0">
+        <a:scrgbClr r="0" g="0" b="0"/>
+      </a:effectRef>
+      <a:fontRef idx="minor">
+        <a:schemeClr val="lt1"/>
+      </a:fontRef>
+    </dgm:style>
+  </dgm:styleLbl>
+  <dgm:styleLbl name="node2">
+    <dgm:scene3d>
+      <a:camera prst="orthographicFront"/>
+      <a:lightRig rig="threePt" dir="t"/>
+    </dgm:scene3d>
+    <dgm:sp3d/>
+    <dgm:txPr/>
+    <dgm:style>
+      <a:lnRef idx="2">
+        <a:scrgbClr r="0" g="0" b="0"/>
+      </a:lnRef>
+      <a:fillRef idx="1">
+        <a:scrgbClr r="0" g="0" b="0"/>
+      </a:fillRef>
+      <a:effectRef idx="0">
+        <a:scrgbClr r="0" g="0" b="0"/>
+      </a:effectRef>
+      <a:fontRef idx="minor">
+        <a:schemeClr val="lt1"/>
+      </a:fontRef>
+    </dgm:style>
+  </dgm:styleLbl>
+  <dgm:styleLbl name="node3">
+    <dgm:scene3d>
+      <a:camera prst="orthographicFront"/>
+      <a:lightRig rig="threePt" dir="t"/>
+    </dgm:scene3d>
+    <dgm:sp3d/>
+    <dgm:txPr/>
+    <dgm:style>
+      <a:lnRef idx="2">
+        <a:scrgbClr r="0" g="0" b="0"/>
+      </a:lnRef>
+      <a:fillRef idx="1">
+        <a:scrgbClr r="0" g="0" b="0"/>
+      </a:fillRef>
+      <a:effectRef idx="0">
+        <a:scrgbClr r="0" g="0" b="0"/>
+      </a:effectRef>
+      <a:fontRef idx="minor">
+        <a:schemeClr val="lt1"/>
+      </a:fontRef>
+    </dgm:style>
+  </dgm:styleLbl>
+  <dgm:styleLbl name="node4">
+    <dgm:scene3d>
+      <a:camera prst="orthographicFront"/>
+      <a:lightRig rig="threePt" dir="t"/>
+    </dgm:scene3d>
+    <dgm:sp3d/>
+    <dgm:txPr/>
+    <dgm:style>
+      <a:lnRef idx="2">
+        <a:scrgbClr r="0" g="0" b="0"/>
+      </a:lnRef>
+      <a:fillRef idx="1">
+        <a:scrgbClr r="0" g="0" b="0"/>
+      </a:fillRef>
+      <a:effectRef idx="0">
+        <a:scrgbClr r="0" g="0" b="0"/>
+      </a:effectRef>
+      <a:fontRef idx="minor">
+        <a:schemeClr val="lt1"/>
+      </a:fontRef>
+    </dgm:style>
+  </dgm:styleLbl>
+  <dgm:styleLbl name="fgImgPlace1">
+    <dgm:scene3d>
+      <a:camera prst="orthographicFront"/>
+      <a:lightRig rig="threePt" dir="t"/>
+    </dgm:scene3d>
+    <dgm:sp3d/>
+    <dgm:txPr/>
+    <dgm:style>
+      <a:lnRef idx="2">
+        <a:scrgbClr r="0" g="0" b="0"/>
+      </a:lnRef>
+      <a:fillRef idx="1">
+        <a:scrgbClr r="0" g="0" b="0"/>
+      </a:fillRef>
+      <a:effectRef idx="0">
+        <a:scrgbClr r="0" g="0" b="0"/>
+      </a:effectRef>
+      <a:fontRef idx="minor"/>
+    </dgm:style>
+  </dgm:styleLbl>
+  <dgm:styleLbl name="alignImgPlace1">
+    <dgm:scene3d>
+      <a:camera prst="orthographicFront"/>
+      <a:lightRig rig="threePt" dir="t"/>
+    </dgm:scene3d>
+    <dgm:sp3d/>
+    <dgm:txPr/>
+    <dgm:style>
+      <a:lnRef idx="2">
+        <a:scrgbClr r="0" g="0" b="0"/>
+      </a:lnRef>
+      <a:fillRef idx="1">
+        <a:scrgbClr r="0" g="0" b="0"/>
+      </a:fillRef>
+      <a:effectRef idx="0">
+        <a:scrgbClr r="0" g="0" b="0"/>
+      </a:effectRef>
+      <a:fontRef idx="minor"/>
+    </dgm:style>
+  </dgm:styleLbl>
+  <dgm:styleLbl name="bgImgPlace1">
+    <dgm:scene3d>
+      <a:camera prst="orthographicFront"/>
+      <a:lightRig rig="threePt" dir="t"/>
+    </dgm:scene3d>
+    <dgm:sp3d/>
+    <dgm:txPr/>
+    <dgm:style>
+      <a:lnRef idx="2">
+        <a:scrgbClr r="0" g="0" b="0"/>
+      </a:lnRef>
+      <a:fillRef idx="1">
+        <a:scrgbClr r="0" g="0" b="0"/>
+      </a:fillRef>
+      <a:effectRef idx="0">
+        <a:scrgbClr r="0" g="0" b="0"/>
+      </a:effectRef>
+      <a:fontRef idx="minor"/>
+    </dgm:style>
+  </dgm:styleLbl>
+  <dgm:styleLbl name="sibTrans2D1">
+    <dgm:scene3d>
+      <a:camera prst="orthographicFront"/>
+      <a:lightRig rig="threePt" dir="t"/>
+    </dgm:scene3d>
+    <dgm:sp3d/>
+    <dgm:txPr/>
+    <dgm:style>
+      <a:lnRef idx="0">
+        <a:scrgbClr r="0" g="0" b="0"/>
+      </a:lnRef>
+      <a:fillRef idx="1">
+        <a:scrgbClr r="0" g="0" b="0"/>
+      </a:fillRef>
+      <a:effectRef idx="0">
+        <a:scrgbClr r="0" g="0" b="0"/>
+      </a:effectRef>
+      <a:fontRef idx="minor">
+        <a:schemeClr val="lt1"/>
+      </a:fontRef>
+    </dgm:style>
+  </dgm:styleLbl>
+  <dgm:styleLbl name="fgSibTrans2D1">
+    <dgm:scene3d>
+      <a:camera prst="orthographicFront"/>
+      <a:lightRig rig="threePt" dir="t"/>
+    </dgm:scene3d>
+    <dgm:sp3d/>
+    <dgm:txPr/>
+    <dgm:style>
+      <a:lnRef idx="0">
+        <a:scrgbClr r="0" g="0" b="0"/>
+      </a:lnRef>
+      <a:fillRef idx="1">
+        <a:scrgbClr r="0" g="0" b="0"/>
+      </a:fillRef>
+      <a:effectRef idx="0">
+        <a:scrgbClr r="0" g="0" b="0"/>
+      </a:effectRef>
+      <a:fontRef idx="minor">
+        <a:schemeClr val="lt1"/>
+      </a:fontRef>
+    </dgm:style>
+  </dgm:styleLbl>
+  <dgm:styleLbl name="bgSibTrans2D1">
+    <dgm:scene3d>
+      <a:camera prst="orthographicFront"/>
+      <a:lightRig rig="threePt" dir="t"/>
+    </dgm:scene3d>
+    <dgm:sp3d/>
+    <dgm:txPr/>
+    <dgm:style>
+      <a:lnRef idx="0">
+        <a:scrgbClr r="0" g="0" b="0"/>
+      </a:lnRef>
+      <a:fillRef idx="1">
+        <a:scrgbClr r="0" g="0" b="0"/>
+      </a:fillRef>
+      <a:effectRef idx="0">
+        <a:scrgbClr r="0" g="0" b="0"/>
+      </a:effectRef>
+      <a:fontRef idx="minor">
+        <a:schemeClr val="lt1"/>
+      </a:fontRef>
+    </dgm:style>
+  </dgm:styleLbl>
+  <dgm:styleLbl name="sibTrans1D1">
+    <dgm:scene3d>
+      <a:camera prst="orthographicFront"/>
+      <a:lightRig rig="threePt" dir="t"/>
+    </dgm:scene3d>
+    <dgm:sp3d/>
+    <dgm:txPr/>
+    <dgm:style>
+      <a:lnRef idx="1">
+        <a:scrgbClr r="0" g="0" b="0"/>
+      </a:lnRef>
+      <a:fillRef idx="0">
+        <a:scrgbClr r="0" g="0" b="0"/>
+      </a:fillRef>
+      <a:effectRef idx="0">
+        <a:scrgbClr r="0" g="0" b="0"/>
+      </a:effectRef>
+      <a:fontRef idx="minor"/>
+    </dgm:style>
+  </dgm:styleLbl>
+  <dgm:styleLbl name="callout">
+    <dgm:scene3d>
+      <a:camera prst="orthographicFront"/>
+      <a:lightRig rig="threePt" dir="t"/>
+    </dgm:scene3d>
+    <dgm:sp3d/>
+    <dgm:txPr/>
+    <dgm:style>
+      <a:lnRef idx="2">
+        <a:scrgbClr r="0" g="0" b="0"/>
+      </a:lnRef>
+      <a:fillRef idx="1">
+        <a:scrgbClr r="0" g="0" b="0"/>
+      </a:fillRef>
+      <a:effectRef idx="0">
+        <a:scrgbClr r="0" g="0" b="0"/>
+      </a:effectRef>
+      <a:fontRef idx="minor"/>
+    </dgm:style>
+  </dgm:styleLbl>
+  <dgm:styleLbl name="asst0">
+    <dgm:scene3d>
+      <a:camera prst="orthographicFront"/>
+      <a:lightRig rig="threePt" dir="t"/>
+    </dgm:scene3d>
+    <dgm:sp3d/>
+    <dgm:txPr/>
+    <dgm:style>
+      <a:lnRef idx="2">
+        <a:scrgbClr r="0" g="0" b="0"/>
+      </a:lnRef>
+      <a:fillRef idx="1">
+        <a:scrgbClr r="0" g="0" b="0"/>
+      </a:fillRef>
+      <a:effectRef idx="0">
+        <a:scrgbClr r="0" g="0" b="0"/>
+      </a:effectRef>
+      <a:fontRef idx="minor">
+        <a:schemeClr val="lt1"/>
+      </a:fontRef>
+    </dgm:style>
+  </dgm:styleLbl>
+  <dgm:styleLbl name="asst1">
+    <dgm:scene3d>
+      <a:camera prst="orthographicFront"/>
+      <a:lightRig rig="threePt" dir="t"/>
+    </dgm:scene3d>
+    <dgm:sp3d/>
+    <dgm:txPr/>
+    <dgm:style>
+      <a:lnRef idx="2">
+        <a:scrgbClr r="0" g="0" b="0"/>
+      </a:lnRef>
+      <a:fillRef idx="1">
+        <a:scrgbClr r="0" g="0" b="0"/>
+      </a:fillRef>
+      <a:effectRef idx="0">
+        <a:scrgbClr r="0" g="0" b="0"/>
+      </a:effectRef>
+      <a:fontRef idx="minor">
+        <a:schemeClr val="lt1"/>
+      </a:fontRef>
+    </dgm:style>
+  </dgm:styleLbl>
+  <dgm:styleLbl name="asst2">
+    <dgm:scene3d>
+      <a:camera prst="orthographicFront"/>
+      <a:lightRig rig="threePt" dir="t"/>
+    </dgm:scene3d>
+    <dgm:sp3d/>
+    <dgm:txPr/>
+    <dgm:style>
+      <a:lnRef idx="2">
+        <a:scrgbClr r="0" g="0" b="0"/>
+      </a:lnRef>
+      <a:fillRef idx="1">
+        <a:scrgbClr r="0" g="0" b="0"/>
+      </a:fillRef>
+      <a:effectRef idx="0">
+        <a:scrgbClr r="0" g="0" b="0"/>
+      </a:effectRef>
+      <a:fontRef idx="minor">
+        <a:schemeClr val="lt1"/>
+      </a:fontRef>
+    </dgm:style>
+  </dgm:styleLbl>
+  <dgm:styleLbl name="asst3">
+    <dgm:scene3d>
+      <a:camera prst="orthographicFront"/>
+      <a:lightRig rig="threePt" dir="t"/>
+    </dgm:scene3d>
+    <dgm:sp3d/>
+    <dgm:txPr/>
+    <dgm:style>
+      <a:lnRef idx="2">
+        <a:scrgbClr r="0" g="0" b="0"/>
+      </a:lnRef>
+      <a:fillRef idx="1">
+        <a:scrgbClr r="0" g="0" b="0"/>
+      </a:fillRef>
+      <a:effectRef idx="0">
+        <a:scrgbClr r="0" g="0" b="0"/>
+      </a:effectRef>
+      <a:fontRef idx="minor">
+        <a:schemeClr val="lt1"/>
+      </a:fontRef>
+    </dgm:style>
+  </dgm:styleLbl>
+  <dgm:styleLbl name="asst4">
+    <dgm:scene3d>
+      <a:camera prst="orthographicFront"/>
+      <a:lightRig rig="threePt" dir="t"/>
+    </dgm:scene3d>
+    <dgm:sp3d/>
+    <dgm:txPr/>
+    <dgm:style>
+      <a:lnRef idx="2">
+        <a:scrgbClr r="0" g="0" b="0"/>
+      </a:lnRef>
+      <a:fillRef idx="1">
+        <a:scrgbClr r="0" g="0" b="0"/>
+      </a:fillRef>
+      <a:effectRef idx="0">
+        <a:scrgbClr r="0" g="0" b="0"/>
+      </a:effectRef>
+      <a:fontRef idx="minor">
+        <a:schemeClr val="lt1"/>
+      </a:fontRef>
+    </dgm:style>
+  </dgm:styleLbl>
+  <dgm:styleLbl name="parChTrans2D1">
+    <dgm:scene3d>
+      <a:camera prst="orthographicFront"/>
+      <a:lightRig rig="threePt" dir="t"/>
+    </dgm:scene3d>
+    <dgm:sp3d/>
+    <dgm:txPr/>
+    <dgm:style>
+      <a:lnRef idx="2">
+        <a:scrgbClr r="0" g="0" b="0"/>
+      </a:lnRef>
+      <a:fillRef idx="1">
+        <a:scrgbClr r="0" g="0" b="0"/>
+      </a:fillRef>
+      <a:effectRef idx="0">
+        <a:scrgbClr r="0" g="0" b="0"/>
+      </a:effectRef>
+      <a:fontRef idx="minor">
+        <a:schemeClr val="lt1"/>
+      </a:fontRef>
+    </dgm:style>
+  </dgm:styleLbl>
+  <dgm:styleLbl name="parChTrans2D2">
+    <dgm:scene3d>
+      <a:camera prst="orthographicFront"/>
+      <a:lightRig rig="threePt" dir="t"/>
+    </dgm:scene3d>
+    <dgm:sp3d/>
+    <dgm:txPr/>
+    <dgm:style>
+      <a:lnRef idx="2">
+        <a:scrgbClr r="0" g="0" b="0"/>
+      </a:lnRef>
+      <a:fillRef idx="1">
+        <a:scrgbClr r="0" g="0" b="0"/>
+      </a:fillRef>
+      <a:effectRef idx="0">
+        <a:scrgbClr r="0" g="0" b="0"/>
+      </a:effectRef>
+      <a:fontRef idx="minor">
+        <a:schemeClr val="lt1"/>
+      </a:fontRef>
+    </dgm:style>
+  </dgm:styleLbl>
+  <dgm:styleLbl name="parChTrans2D3">
+    <dgm:scene3d>
+      <a:camera prst="orthographicFront"/>
+      <a:lightRig rig="threePt" dir="t"/>
+    </dgm:scene3d>
+    <dgm:sp3d/>
+    <dgm:txPr/>
+    <dgm:style>
+      <a:lnRef idx="2">
+        <a:scrgbClr r="0" g="0" b="0"/>
+      </a:lnRef>
+      <a:fillRef idx="1">
+        <a:scrgbClr r="0" g="0" b="0"/>
+      </a:fillRef>
+      <a:effectRef idx="0">
+        <a:scrgbClr r="0" g="0" b="0"/>
+      </a:effectRef>
+      <a:fontRef idx="minor">
+        <a:schemeClr val="lt1"/>
+      </a:fontRef>
+    </dgm:style>
+  </dgm:styleLbl>
+  <dgm:styleLbl name="parChTrans2D4">
+    <dgm:scene3d>
+      <a:camera prst="orthographicFront"/>
+      <a:lightRig rig="threePt" dir="t"/>
+    </dgm:scene3d>
+    <dgm:sp3d/>
+    <dgm:txPr/>
+    <dgm:style>
+      <a:lnRef idx="2">
+        <a:scrgbClr r="0" g="0" b="0"/>
+      </a:lnRef>
+      <a:fillRef idx="1">
+        <a:scrgbClr r="0" g="0" b="0"/>
+      </a:fillRef>
+      <a:effectRef idx="0">
+        <a:scrgbClr r="0" g="0" b="0"/>
+      </a:effectRef>
+      <a:fontRef idx="minor">
+        <a:schemeClr val="lt1"/>
+      </a:fontRef>
+    </dgm:style>
+  </dgm:styleLbl>
+  <dgm:styleLbl name="parChTrans1D1">
+    <dgm:scene3d>
+      <a:camera prst="orthographicFront"/>
+      <a:lightRig rig="threePt" dir="t"/>
+    </dgm:scene3d>
+    <dgm:sp3d/>
+    <dgm:txPr/>
+    <dgm:style>
+      <a:lnRef idx="2">
+        <a:scrgbClr r="0" g="0" b="0"/>
+      </a:lnRef>
+      <a:fillRef idx="0">
+        <a:scrgbClr r="0" g="0" b="0"/>
+      </a:fillRef>
+      <a:effectRef idx="0">
+        <a:scrgbClr r="0" g="0" b="0"/>
+      </a:effectRef>
+      <a:fontRef idx="minor"/>
+    </dgm:style>
+  </dgm:styleLbl>
+  <dgm:styleLbl name="parChTrans1D2">
+    <dgm:scene3d>
+      <a:camera prst="orthographicFront"/>
+      <a:lightRig rig="threePt" dir="t"/>
+    </dgm:scene3d>
+    <dgm:sp3d/>
+    <dgm:txPr/>
+    <dgm:style>
+      <a:lnRef idx="2">
+        <a:scrgbClr r="0" g="0" b="0"/>
+      </a:lnRef>
+      <a:fillRef idx="0">
+        <a:scrgbClr r="0" g="0" b="0"/>
+      </a:fillRef>
+      <a:effectRef idx="0">
+        <a:scrgbClr r="0" g="0" b="0"/>
+      </a:effectRef>
+      <a:fontRef idx="minor"/>
+    </dgm:style>
+  </dgm:styleLbl>
+  <dgm:styleLbl name="parChTrans1D3">
+    <dgm:scene3d>
+      <a:camera prst="orthographicFront"/>
+      <a:lightRig rig="threePt" dir="t"/>
+    </dgm:scene3d>
+    <dgm:sp3d/>
+    <dgm:txPr/>
+    <dgm:style>
+      <a:lnRef idx="2">
+        <a:scrgbClr r="0" g="0" b="0"/>
+      </a:lnRef>
+      <a:fillRef idx="0">
+        <a:scrgbClr r="0" g="0" b="0"/>
+      </a:fillRef>
+      <a:effectRef idx="0">
+        <a:scrgbClr r="0" g="0" b="0"/>
+      </a:effectRef>
+      <a:fontRef idx="minor"/>
+    </dgm:style>
+  </dgm:styleLbl>
+  <dgm:styleLbl name="parChTrans1D4">
+    <dgm:scene3d>
+      <a:camera prst="orthographicFront"/>
+      <a:lightRig rig="threePt" dir="t"/>
+    </dgm:scene3d>
+    <dgm:sp3d/>
+    <dgm:txPr/>
+    <dgm:style>
+      <a:lnRef idx="2">
+        <a:scrgbClr r="0" g="0" b="0"/>
+      </a:lnRef>
+      <a:fillRef idx="0">
+        <a:scrgbClr r="0" g="0" b="0"/>
+      </a:fillRef>
+      <a:effectRef idx="0">
+        <a:scrgbClr r="0" g="0" b="0"/>
+      </a:effectRef>
+      <a:fontRef idx="minor"/>
+    </dgm:style>
+  </dgm:styleLbl>
+  <dgm:styleLbl name="fgAcc1">
+    <dgm:scene3d>
+      <a:camera prst="orthographicFront"/>
+      <a:lightRig rig="threePt" dir="t"/>
+    </dgm:scene3d>
+    <dgm:sp3d/>
+    <dgm:txPr/>
+    <dgm:style>
+      <a:lnRef idx="2">
+        <a:scrgbClr r="0" g="0" b="0"/>
+      </a:lnRef>
+      <a:fillRef idx="1">
+        <a:scrgbClr r="0" g="0" b="0"/>
+      </a:fillRef>
+      <a:effectRef idx="0">
+        <a:scrgbClr r="0" g="0" b="0"/>
+      </a:effectRef>
+      <a:fontRef idx="minor"/>
+    </dgm:style>
+  </dgm:styleLbl>
+  <dgm:styleLbl name="conFgAcc1">
+    <dgm:scene3d>
+      <a:camera prst="orthographicFront"/>
+      <a:lightRig rig="threePt" dir="t"/>
+    </dgm:scene3d>
+    <dgm:sp3d/>
+    <dgm:txPr/>
+    <dgm:style>
+      <a:lnRef idx="2">
+        <a:scrgbClr r="0" g="0" b="0"/>
+      </a:lnRef>
+      <a:fillRef idx="1">
+        <a:scrgbClr r="0" g="0" b="0"/>
+      </a:fillRef>
+      <a:effectRef idx="0">
+        <a:scrgbClr r="0" g="0" b="0"/>
+      </a:effectRef>
+      <a:fontRef idx="minor"/>
+    </dgm:style>
+  </dgm:styleLbl>
+  <dgm:styleLbl name="alignAcc1">
+    <dgm:scene3d>
+      <a:camera prst="orthographicFront"/>
+      <a:lightRig rig="threePt" dir="t"/>
+    </dgm:scene3d>
+    <dgm:sp3d/>
+    <dgm:txPr/>
+    <dgm:style>
+      <a:lnRef idx="2">
+        <a:scrgbClr r="0" g="0" b="0"/>
+      </a:lnRef>
+      <a:fillRef idx="1">
+        <a:scrgbClr r="0" g="0" b="0"/>
+      </a:fillRef>
+      <a:effectRef idx="0">
+        <a:scrgbClr r="0" g="0" b="0"/>
+      </a:effectRef>
+      <a:fontRef idx="minor"/>
+    </dgm:style>
+  </dgm:styleLbl>
+  <dgm:styleLbl name="trAlignAcc1">
+    <dgm:scene3d>
+      <a:camera prst="orthographicFront"/>
+      <a:lightRig rig="threePt" dir="t"/>
+    </dgm:scene3d>
+    <dgm:sp3d/>
+    <dgm:txPr/>
+    <dgm:style>
+      <a:lnRef idx="1">
+        <a:scrgbClr r="0" g="0" b="0"/>
+      </a:lnRef>
+      <a:fillRef idx="1">
+        <a:scrgbClr r="0" g="0" b="0"/>
+      </a:fillRef>
+      <a:effectRef idx="0">
+        <a:scrgbClr r="0" g="0" b="0"/>
+      </a:effectRef>
+      <a:fontRef idx="minor"/>
+    </dgm:style>
+  </dgm:styleLbl>
+  <dgm:styleLbl name="bgAcc1">
+    <dgm:scene3d>
+      <a:camera prst="orthographicFront"/>
+      <a:lightRig rig="threePt" dir="t"/>
+    </dgm:scene3d>
+    <dgm:sp3d/>
+    <dgm:txPr/>
+    <dgm:style>
+      <a:lnRef idx="2">
+        <a:scrgbClr r="0" g="0" b="0"/>
+      </a:lnRef>
+      <a:fillRef idx="1">
+        <a:scrgbClr r="0" g="0" b="0"/>
+      </a:fillRef>
+      <a:effectRef idx="0">
+        <a:scrgbClr r="0" g="0" b="0"/>
+      </a:effectRef>
+      <a:fontRef idx="minor"/>
+    </dgm:style>
+  </dgm:styleLbl>
+  <dgm:styleLbl name="solidFgAcc1">
+    <dgm:scene3d>
+      <a:camera prst="orthographicFront"/>
+      <a:lightRig rig="threePt" dir="t"/>
+    </dgm:scene3d>
+    <dgm:sp3d/>
+    <dgm:txPr/>
+    <dgm:style>
+      <a:lnRef idx="2">
+        <a:scrgbClr r="0" g="0" b="0"/>
+      </a:lnRef>
+      <a:fillRef idx="1">
+        <a:scrgbClr r="0" g="0" b="0"/>
+      </a:fillRef>
+      <a:effectRef idx="0">
+        <a:scrgbClr r="0" g="0" b="0"/>
+      </a:effectRef>
+      <a:fontRef idx="minor"/>
+    </dgm:style>
+  </dgm:styleLbl>
+  <dgm:styleLbl name="solidAlignAcc1">
+    <dgm:scene3d>
+      <a:camera prst="orthographicFront"/>
+      <a:lightRig rig="threePt" dir="t"/>
+    </dgm:scene3d>
+    <dgm:sp3d/>
+    <dgm:txPr/>
+    <dgm:style>
+      <a:lnRef idx="2">
+        <a:scrgbClr r="0" g="0" b="0"/>
+      </a:lnRef>
+      <a:fillRef idx="1">
+        <a:scrgbClr r="0" g="0" b="0"/>
+      </a:fillRef>
+      <a:effectRef idx="0">
+        <a:scrgbClr r="0" g="0" b="0"/>
+      </a:effectRef>
+      <a:fontRef idx="minor"/>
+    </dgm:style>
+  </dgm:styleLbl>
+  <dgm:styleLbl name="solidBgAcc1">
+    <dgm:scene3d>
+      <a:camera prst="orthographicFront"/>
+      <a:lightRig rig="threePt" dir="t"/>
+    </dgm:scene3d>
+    <dgm:sp3d/>
+    <dgm:txPr/>
+    <dgm:style>
+      <a:lnRef idx="2">
+        <a:scrgbClr r="0" g="0" b="0"/>
+      </a:lnRef>
+      <a:fillRef idx="1">
+        <a:scrgbClr r="0" g="0" b="0"/>
+      </a:fillRef>
+      <a:effectRef idx="0">
+        <a:scrgbClr r="0" g="0" b="0"/>
+      </a:effectRef>
+      <a:fontRef idx="minor"/>
+    </dgm:style>
+  </dgm:styleLbl>
+  <dgm:styleLbl name="fgAccFollowNode1">
+    <dgm:scene3d>
+      <a:camera prst="orthographicFront"/>
+      <a:lightRig rig="threePt" dir="t"/>
+    </dgm:scene3d>
+    <dgm:sp3d/>
+    <dgm:txPr/>
+    <dgm:style>
+      <a:lnRef idx="2">
+        <a:scrgbClr r="0" g="0" b="0"/>
+      </a:lnRef>
+      <a:fillRef idx="1">
+        <a:scrgbClr r="0" g="0" b="0"/>
+      </a:fillRef>
+      <a:effectRef idx="0">
+        <a:scrgbClr r="0" g="0" b="0"/>
+      </a:effectRef>
+      <a:fontRef idx="minor"/>
+    </dgm:style>
+  </dgm:styleLbl>
+  <dgm:styleLbl name="alignAccFollowNode1">
+    <dgm:scene3d>
+      <a:camera prst="orthographicFront"/>
+      <a:lightRig rig="threePt" dir="t"/>
+    </dgm:scene3d>
+    <dgm:sp3d/>
+    <dgm:txPr/>
+    <dgm:style>
+      <a:lnRef idx="2">
+        <a:scrgbClr r="0" g="0" b="0"/>
+      </a:lnRef>
+      <a:fillRef idx="1">
+        <a:scrgbClr r="0" g="0" b="0"/>
+      </a:fillRef>
+      <a:effectRef idx="0">
+        <a:scrgbClr r="0" g="0" b="0"/>
+      </a:effectRef>
+      <a:fontRef idx="minor"/>
+    </dgm:style>
+  </dgm:styleLbl>
+  <dgm:styleLbl name="bgAccFollowNode1">
+    <dgm:scene3d>
+      <a:camera prst="orthographicFront"/>
+      <a:lightRig rig="threePt" dir="t"/>
+    </dgm:scene3d>
+    <dgm:sp3d/>
+    <dgm:txPr/>
+    <dgm:style>
+      <a:lnRef idx="2">
+        <a:scrgbClr r="0" g="0" b="0"/>
+      </a:lnRef>
+      <a:fillRef idx="1">
+        <a:scrgbClr r="0" g="0" b="0"/>
+      </a:fillRef>
+      <a:effectRef idx="0">
+        <a:scrgbClr r="0" g="0" b="0"/>
+      </a:effectRef>
+      <a:fontRef idx="minor"/>
+    </dgm:style>
+  </dgm:styleLbl>
+  <dgm:styleLbl name="fgAcc0">
+    <dgm:scene3d>
+      <a:camera prst="orthographicFront"/>
+      <a:lightRig rig="threePt" dir="t"/>
+    </dgm:scene3d>
+    <dgm:sp3d/>
+    <dgm:txPr/>
+    <dgm:style>
+      <a:lnRef idx="2">
+        <a:scrgbClr r="0" g="0" b="0"/>
+      </a:lnRef>
+      <a:fillRef idx="1">
+        <a:scrgbClr r="0" g="0" b="0"/>
+      </a:fillRef>
+      <a:effectRef idx="0">
+        <a:scrgbClr r="0" g="0" b="0"/>
+      </a:effectRef>
+      <a:fontRef idx="minor"/>
+    </dgm:style>
+  </dgm:styleLbl>
+  <dgm:styleLbl name="fgAcc2">
+    <dgm:scene3d>
+      <a:camera prst="orthographicFront"/>
+      <a:lightRig rig="threePt" dir="t"/>
+    </dgm:scene3d>
+    <dgm:sp3d/>
+    <dgm:txPr/>
+    <dgm:style>
+      <a:lnRef idx="2">
+        <a:scrgbClr r="0" g="0" b="0"/>
+      </a:lnRef>
+      <a:fillRef idx="1">
+        <a:scrgbClr r="0" g="0" b="0"/>
+      </a:fillRef>
+      <a:effectRef idx="0">
+        <a:scrgbClr r="0" g="0" b="0"/>
+      </a:effectRef>
+      <a:fontRef idx="minor"/>
+    </dgm:style>
+  </dgm:styleLbl>
+  <dgm:styleLbl name="fgAcc3">
+    <dgm:scene3d>
+      <a:camera prst="orthographicFront"/>
+      <a:lightRig rig="threePt" dir="t"/>
+    </dgm:scene3d>
+    <dgm:sp3d/>
+    <dgm:txPr/>
+    <dgm:style>
+      <a:lnRef idx="2">
+        <a:scrgbClr r="0" g="0" b="0"/>
+      </a:lnRef>
+      <a:fillRef idx="1">
+        <a:scrgbClr r="0" g="0" b="0"/>
+      </a:fillRef>
+      <a:effectRef idx="0">
+        <a:scrgbClr r="0" g="0" b="0"/>
+      </a:effectRef>
+      <a:fontRef idx="minor"/>
+    </dgm:style>
+  </dgm:styleLbl>
+  <dgm:styleLbl name="fgAcc4">
+    <dgm:scene3d>
+      <a:camera prst="orthographicFront"/>
+      <a:lightRig rig="threePt" dir="t"/>
+    </dgm:scene3d>
+    <dgm:sp3d/>
+    <dgm:txPr/>
+    <dgm:style>
+      <a:lnRef idx="2">
+        <a:scrgbClr r="0" g="0" b="0"/>
+      </a:lnRef>
+      <a:fillRef idx="1">
+        <a:scrgbClr r="0" g="0" b="0"/>
+      </a:fillRef>
+      <a:effectRef idx="0">
+        <a:scrgbClr r="0" g="0" b="0"/>
+      </a:effectRef>
+      <a:fontRef idx="minor"/>
+    </dgm:style>
+  </dgm:styleLbl>
+  <dgm:styleLbl name="bgShp">
+    <dgm:scene3d>
+      <a:camera prst="orthographicFront"/>
+      <a:lightRig rig="threePt" dir="t"/>
+    </dgm:scene3d>
+    <dgm:sp3d/>
+    <dgm:txPr/>
+    <dgm:style>
+      <a:lnRef idx="0">
+        <a:scrgbClr r="0" g="0" b="0"/>
+      </a:lnRef>
+      <a:fillRef idx="1">
+        <a:scrgbClr r="0" g="0" b="0"/>
+      </a:fillRef>
+      <a:effectRef idx="0">
+        <a:scrgbClr r="0" g="0" b="0"/>
+      </a:effectRef>
+      <a:fontRef idx="minor"/>
+    </dgm:style>
+  </dgm:styleLbl>
+  <dgm:styleLbl name="dkBgShp">
+    <dgm:scene3d>
+      <a:camera prst="orthographicFront"/>
+      <a:lightRig rig="threePt" dir="t"/>
+    </dgm:scene3d>
+    <dgm:sp3d/>
+    <dgm:txPr/>
+    <dgm:style>
+      <a:lnRef idx="0">
+        <a:scrgbClr r="0" g="0" b="0"/>
+      </a:lnRef>
+      <a:fillRef idx="1">
+        <a:scrgbClr r="0" g="0" b="0"/>
+      </a:fillRef>
+      <a:effectRef idx="0">
+        <a:scrgbClr r="0" g="0" b="0"/>
+      </a:effectRef>
+      <a:fontRef idx="minor"/>
+    </dgm:style>
+  </dgm:styleLbl>
+  <dgm:styleLbl name="trBgShp">
+    <dgm:scene3d>
+      <a:camera prst="orthographicFront"/>
+      <a:lightRig rig="threePt" dir="t"/>
+    </dgm:scene3d>
+    <dgm:sp3d/>
+    <dgm:txPr/>
+    <dgm:style>
+      <a:lnRef idx="0">
+        <a:scrgbClr r="0" g="0" b="0"/>
+      </a:lnRef>
+      <a:fillRef idx="1">
+        <a:scrgbClr r="0" g="0" b="0"/>
+      </a:fillRef>
+      <a:effectRef idx="0">
+        <a:scrgbClr r="0" g="0" b="0"/>
+      </a:effectRef>
+      <a:fontRef idx="minor"/>
+    </dgm:style>
+  </dgm:styleLbl>
+  <dgm:styleLbl name="fgShp">
+    <dgm:scene3d>
+      <a:camera prst="orthographicFront"/>
+      <a:lightRig rig="threePt" dir="t"/>
+    </dgm:scene3d>
+    <dgm:sp3d/>
+    <dgm:txPr/>
+    <dgm:style>
+      <a:lnRef idx="2">
+        <a:scrgbClr r="0" g="0" b="0"/>
+      </a:lnRef>
+      <a:fillRef idx="1">
+        <a:scrgbClr r="0" g="0" b="0"/>
+      </a:fillRef>
+      <a:effectRef idx="0">
+        <a:scrgbClr r="0" g="0" b="0"/>
+      </a:effectRef>
+      <a:fontRef idx="minor"/>
+    </dgm:style>
+  </dgm:styleLbl>
+  <dgm:styleLbl name="revTx">
+    <dgm:scene3d>
+      <a:camera prst="orthographicFront"/>
+      <a:lightRig rig="threePt" dir="t"/>
+    </dgm:scene3d>
+    <dgm:sp3d/>
+    <dgm:txPr/>
+    <dgm:style>
+      <a:lnRef idx="0">
+        <a:scrgbClr r="0" g="0" b="0"/>
+      </a:lnRef>
+      <a:fillRef idx="0">
+        <a:scrgbClr r="0" g="0" b="0"/>
+      </a:fillRef>
+      <a:effectRef idx="0">
+        <a:scrgbClr r="0" g="0" b="0"/>
+      </a:effectRef>
+      <a:fontRef idx="minor"/>
+    </dgm:style>
+  </dgm:styleLbl>
+</dgm:styleDef>
+</file>
+
 <file path=ppt/notesMasters/notesMaster1.xml><?xml version="1.0" encoding="utf-8"?>
-<p:notesMaster xmlns:p="http://schemas.openxmlformats.org/presentationml/2006/main" xmlns:a="http://schemas.openxmlformats.org/drawingml/2006/main" xmlns:r="http://schemas.openxmlformats.org/officeDocument/2006/relationships">
+<p:notesMaster xmlns:a="http://schemas.openxmlformats.org/drawingml/2006/main" xmlns:r="http://schemas.openxmlformats.org/officeDocument/2006/relationships" xmlns:p="http://schemas.openxmlformats.org/presentationml/2006/main">
   <p:cSld>
     <p:bg>
       <p:bgPr>
@@ -70,24 +2958,286 @@
           <a:bodyPr/>
           <a:lstStyle/>
           <a:p>
-            <a:r>
-              <a:t/>
-            </a:r>
+            <a:endParaRPr/>
           </a:p>
         </p:txBody>
       </p:sp>
     </p:spTree>
   </p:cSld>
   <p:clrMap bg1="lt1" tx1="dk1" bg2="lt2" tx2="dk2" accent1="accent1" accent2="accent2" accent3="accent3" accent4="accent4" accent5="accent5" accent6="accent6" hlink="hlink" folHlink="folHlink"/>
-  <p:txStyles>
-    <p:bodyStyle/>
-    <p:otherStyle/>
-  </p:txStyles>
+  <p:notesStyle>
+    <a:lvl1pPr marL="0" algn="l" defTabSz="914400" rtl="0" eaLnBrk="1" latinLnBrk="0" hangingPunct="1">
+      <a:defRPr sz="1200" kern="1200">
+        <a:solidFill>
+          <a:schemeClr val="tx1"/>
+        </a:solidFill>
+        <a:latin typeface="+mn-lt"/>
+        <a:ea typeface="+mn-ea"/>
+        <a:cs typeface="+mn-cs"/>
+      </a:defRPr>
+    </a:lvl1pPr>
+    <a:lvl2pPr marL="457200" algn="l" defTabSz="914400" rtl="0" eaLnBrk="1" latinLnBrk="0" hangingPunct="1">
+      <a:defRPr sz="1200" kern="1200">
+        <a:solidFill>
+          <a:schemeClr val="tx1"/>
+        </a:solidFill>
+        <a:latin typeface="+mn-lt"/>
+        <a:ea typeface="+mn-ea"/>
+        <a:cs typeface="+mn-cs"/>
+      </a:defRPr>
+    </a:lvl2pPr>
+    <a:lvl3pPr marL="914400" algn="l" defTabSz="914400" rtl="0" eaLnBrk="1" latinLnBrk="0" hangingPunct="1">
+      <a:defRPr sz="1200" kern="1200">
+        <a:solidFill>
+          <a:schemeClr val="tx1"/>
+        </a:solidFill>
+        <a:latin typeface="+mn-lt"/>
+        <a:ea typeface="+mn-ea"/>
+        <a:cs typeface="+mn-cs"/>
+      </a:defRPr>
+    </a:lvl3pPr>
+    <a:lvl4pPr marL="1371600" algn="l" defTabSz="914400" rtl="0" eaLnBrk="1" latinLnBrk="0" hangingPunct="1">
+      <a:defRPr sz="1200" kern="1200">
+        <a:solidFill>
+          <a:schemeClr val="tx1"/>
+        </a:solidFill>
+        <a:latin typeface="+mn-lt"/>
+        <a:ea typeface="+mn-ea"/>
+        <a:cs typeface="+mn-cs"/>
+      </a:defRPr>
+    </a:lvl4pPr>
+    <a:lvl5pPr marL="1828800" algn="l" defTabSz="914400" rtl="0" eaLnBrk="1" latinLnBrk="0" hangingPunct="1">
+      <a:defRPr sz="1200" kern="1200">
+        <a:solidFill>
+          <a:schemeClr val="tx1"/>
+        </a:solidFill>
+        <a:latin typeface="+mn-lt"/>
+        <a:ea typeface="+mn-ea"/>
+        <a:cs typeface="+mn-cs"/>
+      </a:defRPr>
+    </a:lvl5pPr>
+    <a:lvl6pPr marL="2286000" algn="l" defTabSz="914400" rtl="0" eaLnBrk="1" latinLnBrk="0" hangingPunct="1">
+      <a:defRPr sz="1200" kern="1200">
+        <a:solidFill>
+          <a:schemeClr val="tx1"/>
+        </a:solidFill>
+        <a:latin typeface="+mn-lt"/>
+        <a:ea typeface="+mn-ea"/>
+        <a:cs typeface="+mn-cs"/>
+      </a:defRPr>
+    </a:lvl6pPr>
+    <a:lvl7pPr marL="2743200" algn="l" defTabSz="914400" rtl="0" eaLnBrk="1" latinLnBrk="0" hangingPunct="1">
+      <a:defRPr sz="1200" kern="1200">
+        <a:solidFill>
+          <a:schemeClr val="tx1"/>
+        </a:solidFill>
+        <a:latin typeface="+mn-lt"/>
+        <a:ea typeface="+mn-ea"/>
+        <a:cs typeface="+mn-cs"/>
+      </a:defRPr>
+    </a:lvl7pPr>
+    <a:lvl8pPr marL="3200400" algn="l" defTabSz="914400" rtl="0" eaLnBrk="1" latinLnBrk="0" hangingPunct="1">
+      <a:defRPr sz="1200" kern="1200">
+        <a:solidFill>
+          <a:schemeClr val="tx1"/>
+        </a:solidFill>
+        <a:latin typeface="+mn-lt"/>
+        <a:ea typeface="+mn-ea"/>
+        <a:cs typeface="+mn-cs"/>
+      </a:defRPr>
+    </a:lvl8pPr>
+    <a:lvl9pPr marL="3657600" algn="l" defTabSz="914400" rtl="0" eaLnBrk="1" latinLnBrk="0" hangingPunct="1">
+      <a:defRPr sz="1200" kern="1200">
+        <a:solidFill>
+          <a:schemeClr val="tx1"/>
+        </a:solidFill>
+        <a:latin typeface="+mn-lt"/>
+        <a:ea typeface="+mn-ea"/>
+        <a:cs typeface="+mn-cs"/>
+      </a:defRPr>
+    </a:lvl9pPr>
+  </p:notesStyle>
 </p:notesMaster>
 </file>
 
 <file path=ppt/notesSlides/notesSlide1.xml><?xml version="1.0" encoding="utf-8"?>
-<p:notes xmlns:p="http://schemas.openxmlformats.org/presentationml/2006/main" xmlns:a="http://schemas.openxmlformats.org/drawingml/2006/main" xmlns:r="http://schemas.openxmlformats.org/officeDocument/2006/relationships">
+<p:notes xmlns:a="http://schemas.openxmlformats.org/drawingml/2006/main" xmlns:r="http://schemas.openxmlformats.org/officeDocument/2006/relationships" xmlns:p="http://schemas.openxmlformats.org/presentationml/2006/main">
+  <p:cSld>
+    <p:spTree>
+      <p:nvGrpSpPr>
+        <p:cNvPr id="1" name=""/>
+        <p:cNvGrpSpPr/>
+        <p:nvPr/>
+      </p:nvGrpSpPr>
+      <p:grpSpPr>
+        <a:xfrm>
+          <a:off x="0" y="0"/>
+          <a:ext cx="0" cy="0"/>
+          <a:chOff x="0" y="0"/>
+          <a:chExt cx="0" cy="0"/>
+        </a:xfrm>
+      </p:grpSpPr>
+      <p:sp>
+        <p:nvSpPr>
+          <p:cNvPr id="2" name="Slide Image Placeholder 1"/>
+          <p:cNvSpPr>
+            <a:spLocks noGrp="1" noRot="1" noChangeAspect="1"/>
+          </p:cNvSpPr>
+          <p:nvPr>
+            <p:ph type="sldImg"/>
+          </p:nvPr>
+        </p:nvSpPr>
+        <p:spPr>
+          <a:xfrm>
+            <a:off x="0" y="457200"/>
+            <a:ext cx="5486400" cy="3086100"/>
+          </a:xfrm>
+          <a:prstGeom prst="rect">
+            <a:avLst/>
+          </a:prstGeom>
+          <a:noFill/>
+          <a:ln>
+            <a:solidFill>
+              <a:prstClr val="black"/>
+            </a:solidFill>
+          </a:ln>
+        </p:spPr>
+        <p:txBody>
+          <a:bodyPr/>
+          <a:lstStyle/>
+          <a:p>
+            <a:endParaRPr/>
+          </a:p>
+        </p:txBody>
+      </p:sp>
+      <p:sp>
+        <p:nvSpPr>
+          <p:cNvPr id="3" name="Notes Placeholder 2"/>
+          <p:cNvSpPr>
+            <a:spLocks noGrp="1"/>
+          </p:cNvSpPr>
+          <p:nvPr>
+            <p:ph type="body" idx="1"/>
+          </p:nvPr>
+        </p:nvSpPr>
+        <p:spPr>
+          <a:xfrm>
+            <a:off x="685800" y="3771900"/>
+            <a:ext cx="5486400" cy="3600450"/>
+          </a:xfrm>
+          <a:prstGeom prst="rect">
+            <a:avLst/>
+          </a:prstGeom>
+        </p:spPr>
+        <p:txBody>
+          <a:bodyPr/>
+          <a:lstStyle/>
+          <a:p>
+            <a:r>
+              <a:rPr lang="en-US" dirty="0"/>
+              <a:t>Welcome. Today we trace AI's history not as steady progress but as a series of boom-and-bust cycles. We will look at the first wave of optimism after 1956, the first AI winter of 1974-1980, the expert systems boom and second winter of 1980-1993, the statistical renewal driven by data and compute, and the practical lessons these cycles offer for evaluating today's claims.</a:t>
+            </a:r>
+          </a:p>
+        </p:txBody>
+      </p:sp>
+    </p:spTree>
+  </p:cSld>
+  <p:clrMapOvr>
+    <a:masterClrMapping/>
+  </p:clrMapOvr>
+</p:notes>
+</file>
+
+<file path=ppt/notesSlides/notesSlide2.xml><?xml version="1.0" encoding="utf-8"?>
+<p:notes xmlns:a="http://schemas.openxmlformats.org/drawingml/2006/main" xmlns:r="http://schemas.openxmlformats.org/officeDocument/2006/relationships" xmlns:p="http://schemas.openxmlformats.org/presentationml/2006/main">
+  <p:cSld>
+    <p:spTree>
+      <p:nvGrpSpPr>
+        <p:cNvPr id="1" name=""/>
+        <p:cNvGrpSpPr/>
+        <p:nvPr/>
+      </p:nvGrpSpPr>
+      <p:grpSpPr>
+        <a:xfrm>
+          <a:off x="0" y="0"/>
+          <a:ext cx="0" cy="0"/>
+          <a:chOff x="0" y="0"/>
+          <a:chExt cx="0" cy="0"/>
+        </a:xfrm>
+      </p:grpSpPr>
+      <p:sp>
+        <p:nvSpPr>
+          <p:cNvPr id="2" name="Slide Image Placeholder 1"/>
+          <p:cNvSpPr>
+            <a:spLocks noGrp="1" noRot="1" noChangeAspect="1"/>
+          </p:cNvSpPr>
+          <p:nvPr>
+            <p:ph type="sldImg"/>
+          </p:nvPr>
+        </p:nvSpPr>
+        <p:spPr>
+          <a:xfrm>
+            <a:off x="0" y="457200"/>
+            <a:ext cx="5486400" cy="3086100"/>
+          </a:xfrm>
+          <a:prstGeom prst="rect">
+            <a:avLst/>
+          </a:prstGeom>
+          <a:noFill/>
+          <a:ln>
+            <a:solidFill>
+              <a:prstClr val="black"/>
+            </a:solidFill>
+          </a:ln>
+        </p:spPr>
+        <p:txBody>
+          <a:bodyPr/>
+          <a:lstStyle/>
+          <a:p>
+            <a:endParaRPr/>
+          </a:p>
+        </p:txBody>
+      </p:sp>
+      <p:sp>
+        <p:nvSpPr>
+          <p:cNvPr id="3" name="Notes Placeholder 2"/>
+          <p:cNvSpPr>
+            <a:spLocks noGrp="1"/>
+          </p:cNvSpPr>
+          <p:nvPr>
+            <p:ph type="body" idx="1"/>
+          </p:nvPr>
+        </p:nvSpPr>
+        <p:spPr>
+          <a:xfrm>
+            <a:off x="685800" y="3771900"/>
+            <a:ext cx="5486400" cy="3600450"/>
+          </a:xfrm>
+          <a:prstGeom prst="rect">
+            <a:avLst/>
+          </a:prstGeom>
+        </p:spPr>
+        <p:txBody>
+          <a:bodyPr/>
+          <a:lstStyle/>
+          <a:p>
+            <a:r>
+              <a:rPr lang="en-US" dirty="0"/>
+              <a:t>Introduce the cycle model: a genuine technical breakthrough generates excitement; researchers and media extrapolate far beyond what the method can do; funders invest heavily; results fail to match promises; money and prestige evaporate. The term 'AI winter' was coined by analogy with nuclear winter at an AAAI meeting in 1984, when researchers who had lived through the first winter warned another was coming. Note that research never stopped during winters — it continued quietly under other names such as informatics, machine learning, or knowledge-based systems. This pattern explains why the field repeatedly rebrands itself.</a:t>
+            </a:r>
+          </a:p>
+        </p:txBody>
+      </p:sp>
+    </p:spTree>
+  </p:cSld>
+  <p:clrMapOvr>
+    <a:masterClrMapping/>
+  </p:clrMapOvr>
+</p:notes>
+</file>
+
+<file path=ppt/notesSlides/notesSlide3.xml><?xml version="1.0" encoding="utf-8"?>
+<p:notes xmlns:a="http://schemas.openxmlformats.org/drawingml/2006/main" xmlns:r="http://schemas.openxmlformats.org/officeDocument/2006/relationships" xmlns:p="http://schemas.openxmlformats.org/presentationml/2006/main">
   <p:cSld>
     <p:spTree>
       <p:nvGrpSpPr>
@@ -131,7 +3281,9 @@
         <p:txBody>
           <a:bodyPr/>
           <a:lstStyle/>
-          <a:p/>
+          <a:p>
+            <a:endParaRPr/>
+          </a:p>
         </p:txBody>
       </p:sp>
       <p:sp>
@@ -159,7 +3311,7 @@
           <a:p>
             <a:r>
               <a:rPr lang="en-US" dirty="0"/>
-              <a:t>Welcome. Today we trace AI's history not as steady progress but as a series of boom-and-bust cycles. We will look at the first wave of optimism after 1956, the first AI winter of 1974-1980, the expert systems boom and second winter of 1980-1993, the statistical renewal driven by data and compute, and the practical lessons these cycles offer for evaluating today's claims.</a:t>
+              <a:t>The 1956 Dartmouth Summer Research Project, organised by McCarthy, Minsky, Rochester and Shannon, gave the field its name. Early successes were real: Newell and Simon's Logic Theorist proved theorems from Principia Mathematica; Samuel's checkers program learned to beat its author; Winograd's SHRDLU manipulated a blocks world with natural language. Leading figures made bold claims — Herbert Simon said in 1965 that machines would be capable of any work a man can do within twenty years; Minsky claimed in 1970 that a machine with general human intelligence was three to eight years away. Funding agencies, especially ARPA/DARPA, gave block grants with few deliverables attached. Crucially, these successes worked on toy problems; they did not scale to real-world complexity.</a:t>
             </a:r>
           </a:p>
         </p:txBody>
@@ -172,8 +3324,8 @@
 </p:notes>
 </file>
 
-<file path=ppt/notesSlides/notesSlide2.xml><?xml version="1.0" encoding="utf-8"?>
-<p:notes xmlns:p="http://schemas.openxmlformats.org/presentationml/2006/main" xmlns:a="http://schemas.openxmlformats.org/drawingml/2006/main" xmlns:r="http://schemas.openxmlformats.org/officeDocument/2006/relationships">
+<file path=ppt/notesSlides/notesSlide4.xml><?xml version="1.0" encoding="utf-8"?>
+<p:notes xmlns:a="http://schemas.openxmlformats.org/drawingml/2006/main" xmlns:r="http://schemas.openxmlformats.org/officeDocument/2006/relationships" xmlns:p="http://schemas.openxmlformats.org/presentationml/2006/main">
   <p:cSld>
     <p:spTree>
       <p:nvGrpSpPr>
@@ -217,7 +3369,9 @@
         <p:txBody>
           <a:bodyPr/>
           <a:lstStyle/>
-          <a:p/>
+          <a:p>
+            <a:endParaRPr/>
+          </a:p>
         </p:txBody>
       </p:sp>
       <p:sp>
@@ -245,7 +3399,7 @@
           <a:p>
             <a:r>
               <a:rPr lang="en-US" dirty="0"/>
-              <a:t>Introduce the cycle model: a genuine technical breakthrough generates excitement; researchers and media extrapolate far beyond what the method can do; funders invest heavily; results fail to match promises; money and prestige evaporate. The term 'AI winter' was coined by analogy with nuclear winter at an AAAI meeting in 1984, when researchers who had lived through the first winter warned another was coming. Note that research never stopped during winters — it continued quietly under other names such as informatics, machine learning, or knowledge-based systems. This pattern explains why the field repeatedly rebrands itself.</a:t>
+              <a:t>Technical causes: intractability — problems that worked on small examples exploded combinatorially at realistic scale; lack of commonsense knowledge; Minsky and Papert's Perceptrons (1969) discouraged neural network research. Economic and political causes: the 1966 ALPAC report killed machine translation funding; Sir James Lighthill's 1973 report to the UK Science Research Council concluded AI had failed to deliver on its grand objectives, leading to near-elimination of UK AI funding outside Edinburgh and Essex; the 1969 Mansfield Amendment required DARPA to fund mission-oriented work, and DARPA cancelled Speech Understanding Research in 1974. Hardware was also a hard limit: machines of the era had tiny memories by modern standards. Research continued at reduced scale and visibility.</a:t>
             </a:r>
           </a:p>
         </p:txBody>
@@ -258,8 +3412,8 @@
 </p:notes>
 </file>
 
-<file path=ppt/notesSlides/notesSlide3.xml><?xml version="1.0" encoding="utf-8"?>
-<p:notes xmlns:p="http://schemas.openxmlformats.org/presentationml/2006/main" xmlns:a="http://schemas.openxmlformats.org/drawingml/2006/main" xmlns:r="http://schemas.openxmlformats.org/officeDocument/2006/relationships">
+<file path=ppt/notesSlides/notesSlide5.xml><?xml version="1.0" encoding="utf-8"?>
+<p:notes xmlns:a="http://schemas.openxmlformats.org/drawingml/2006/main" xmlns:r="http://schemas.openxmlformats.org/officeDocument/2006/relationships" xmlns:p="http://schemas.openxmlformats.org/presentationml/2006/main">
   <p:cSld>
     <p:spTree>
       <p:nvGrpSpPr>
@@ -303,7 +3457,9 @@
         <p:txBody>
           <a:bodyPr/>
           <a:lstStyle/>
-          <a:p/>
+          <a:p>
+            <a:endParaRPr/>
+          </a:p>
         </p:txBody>
       </p:sp>
       <p:sp>
@@ -331,7 +3487,7 @@
           <a:p>
             <a:r>
               <a:rPr lang="en-US" dirty="0"/>
-              <a:t>The 1956 Dartmouth Summer Research Project, organised by McCarthy, Minsky, Rochester and Shannon, gave the field its name. Early successes were real: Newell and Simon's Logic Theorist proved theorems from Principia Mathematica; Samuel's checkers program learned to beat its author; Winograd's SHRDLU manipulated a blocks world with natural language. Leading figures made bold claims — Herbert Simon said in 1965 that machines would be capable of any work a man can do within twenty years; Minsky claimed in 1970 that a machine with general human intelligence was three to eight years away. Funding agencies, especially ARPA/DARPA, gave block grants with few deliverables attached. Crucially, these successes worked on toy problems; they did not scale to real-world complexity.</a:t>
+              <a:t>Expert systems such as MYCIN (medical diagnosis), DENDRAL (chemistry) and especially DEC's XCON (configuring VAX orders) delivered measurable commercial value, and by the mid-1980s an industry worth over a billion dollars had formed around them, including specialised LISP machine hardware from Symbolics and LMI. Japan's Fifth Generation Computer Project (1982) triggered defensive funding: DARPA's Strategic Computing Initiative and the UK's Alvey programme. The collapse came from several directions: knowledge acquisition was a bottleneck requiring expensive experts; rule bases became brittle at the edges of their domain and failed ungracefully; maintenance costs ballooned as rules interacted; and general-purpose workstations from Sun and Apple undercut LISP machines, destroying that hardware market in 1987. DARPA's new leadership concluded AI was not the next wave; the Fifth Generation project ended in 1992 without meeting its goals.</a:t>
             </a:r>
           </a:p>
         </p:txBody>
@@ -344,8 +3500,8 @@
 </p:notes>
 </file>
 
-<file path=ppt/notesSlides/notesSlide4.xml><?xml version="1.0" encoding="utf-8"?>
-<p:notes xmlns:p="http://schemas.openxmlformats.org/presentationml/2006/main" xmlns:a="http://schemas.openxmlformats.org/drawingml/2006/main" xmlns:r="http://schemas.openxmlformats.org/officeDocument/2006/relationships">
+<file path=ppt/notesSlides/notesSlide6.xml><?xml version="1.0" encoding="utf-8"?>
+<p:notes xmlns:a="http://schemas.openxmlformats.org/drawingml/2006/main" xmlns:r="http://schemas.openxmlformats.org/officeDocument/2006/relationships" xmlns:p="http://schemas.openxmlformats.org/presentationml/2006/main">
   <p:cSld>
     <p:spTree>
       <p:nvGrpSpPr>
@@ -389,7 +3545,9 @@
         <p:txBody>
           <a:bodyPr/>
           <a:lstStyle/>
-          <a:p/>
+          <a:p>
+            <a:endParaRPr/>
+          </a:p>
         </p:txBody>
       </p:sp>
       <p:sp>
@@ -417,7 +3575,7 @@
           <a:p>
             <a:r>
               <a:rPr lang="en-US" dirty="0"/>
-              <a:t>Technical causes: intractability — problems that worked on small examples exploded combinatorially at realistic scale; lack of commonsense knowledge; Minsky and Papert's Perceptrons (1969) discouraged neural network research. Economic and political causes: the 1966 ALPAC report killed machine translation funding; Sir James Lighthill's 1973 report to the UK Science Research Council concluded AI had failed to deliver on its grand objectives, leading to near-elimination of UK AI funding outside Edinburgh and Essex; the 1969 Mansfield Amendment required DARPA to fund mission-oriented work, and DARPA cancelled Speech Understanding Research in 1974. Hardware was also a hard limit: machines of the era had tiny memories by modern standards. Research continued at reduced scale and visibility.</a:t>
+              <a:t>From the 1990s, AI recovered by changing method rather than ambition. Instead of asking experts to articulate rules, systems induced patterns from large datasets — probabilistic and statistical methods, Bayesian networks, hidden Markov models in speech, and later deep neural networks. Three enabling forces converged: (1) data, from the web, digitised records and labelled sets such as ImageNet; (2) compute, from steadily cheaper processors and then GPUs repurposed for parallel matrix maths, plus cloud infrastructure; (3) algorithmic advances, including practical backpropagation, convolutional networks, and the 2017 transformer architecture. Note the field also rebranded itself during this period as machine learning and data science, avoiding the tainted 'AI' label. Milestones: Deep Blue beating Kasparov in 1997, AlexNet's ImageNet win in 2012, AlphaGo in 2016, and the large language models of the 2020s.</a:t>
             </a:r>
           </a:p>
         </p:txBody>
@@ -430,8 +3588,8 @@
 </p:notes>
 </file>
 
-<file path=ppt/notesSlides/notesSlide5.xml><?xml version="1.0" encoding="utf-8"?>
-<p:notes xmlns:p="http://schemas.openxmlformats.org/presentationml/2006/main" xmlns:a="http://schemas.openxmlformats.org/drawingml/2006/main" xmlns:r="http://schemas.openxmlformats.org/officeDocument/2006/relationships">
+<file path=ppt/notesSlides/notesSlide7.xml><?xml version="1.0" encoding="utf-8"?>
+<p:notes xmlns:a="http://schemas.openxmlformats.org/drawingml/2006/main" xmlns:r="http://schemas.openxmlformats.org/officeDocument/2006/relationships" xmlns:p="http://schemas.openxmlformats.org/presentationml/2006/main">
   <p:cSld>
     <p:spTree>
       <p:nvGrpSpPr>
@@ -475,7 +3633,9 @@
         <p:txBody>
           <a:bodyPr/>
           <a:lstStyle/>
-          <a:p/>
+          <a:p>
+            <a:endParaRPr/>
+          </a:p>
         </p:txBody>
       </p:sp>
       <p:sp>
@@ -503,7 +3663,7 @@
           <a:p>
             <a:r>
               <a:rPr lang="en-US" dirty="0"/>
-              <a:t>Expert systems such as MYCIN (medical diagnosis), DENDRAL (chemistry) and especially DEC's XCON (configuring VAX orders) delivered measurable commercial value, and by the mid-1980s an industry worth over a billion dollars had formed around them, including specialised LISP machine hardware from Symbolics and LMI. Japan's Fifth Generation Computer Project (1982) triggered defensive funding: DARPA's Strategic Computing Initiative and the UK's Alvey programme. The collapse came from several directions: knowledge acquisition was a bottleneck requiring expensive experts; rule bases became brittle at the edges of their domain and failed ungracefully; maintenance costs ballooned as rules interacted; and general-purpose workstations from Sun and Apple undercut LISP machines, destroying that hardware market in 1987. DARPA's new leadership concluded AI was not the next wave; the Fifth Generation project ended in 1992 without meeting its goals.</a:t>
+              <a:t>Summarise: AI has moved through optimism (1956-73), the first winter (1974-80), the expert systems boom and second winter (1980-93), and a data-driven renewal. The recurring causes are technical — scaling limits, brittleness, missing commonsense — and economic — speculative investment, defensive national programmes, and reliance on narrow hardware markets. Practical guidance for students and future professionals: ask what exactly was demonstrated and on what data; ask about maintenance and total cost of ownership, the lesson of expert systems; be sceptical of timeline claims for general intelligence; and remember that winters did not end research, they ended funding and attention. Recognising warning signs protects both research programmes and organisational investment. Invite discussion: are current large-model expectations sustainable, or are we near another correction?</a:t>
             </a:r>
           </a:p>
         </p:txBody>
@@ -516,8 +3676,8 @@
 </p:notes>
 </file>
 
-<file path=ppt/notesSlides/notesSlide6.xml><?xml version="1.0" encoding="utf-8"?>
-<p:notes xmlns:p="http://schemas.openxmlformats.org/presentationml/2006/main" xmlns:a="http://schemas.openxmlformats.org/drawingml/2006/main" xmlns:r="http://schemas.openxmlformats.org/officeDocument/2006/relationships">
+<file path=ppt/notesSlides/notesSlide8.xml><?xml version="1.0" encoding="utf-8"?>
+<p:notes xmlns:a="http://schemas.openxmlformats.org/drawingml/2006/main" xmlns:r="http://schemas.openxmlformats.org/officeDocument/2006/relationships" xmlns:p="http://schemas.openxmlformats.org/presentationml/2006/main">
   <p:cSld>
     <p:spTree>
       <p:nvGrpSpPr>
@@ -561,7 +3721,9 @@
         <p:txBody>
           <a:bodyPr/>
           <a:lstStyle/>
-          <a:p/>
+          <a:p>
+            <a:endParaRPr/>
+          </a:p>
         </p:txBody>
       </p:sp>
       <p:sp>
@@ -589,178 +3751,6 @@
           <a:p>
             <a:r>
               <a:rPr lang="en-US" dirty="0"/>
-              <a:t>From the 1990s, AI recovered by changing method rather than ambition. Instead of asking experts to articulate rules, systems induced patterns from large datasets — probabilistic and statistical methods, Bayesian networks, hidden Markov models in speech, and later deep neural networks. Three enabling forces converged: (1) data, from the web, digitised records and labelled sets such as ImageNet; (2) compute, from steadily cheaper processors and then GPUs repurposed for parallel matrix maths, plus cloud infrastructure; (3) algorithmic advances, including practical backpropagation, convolutional networks, and the 2017 transformer architecture. Note the field also rebranded itself during this period as machine learning and data science, avoiding the tainted 'AI' label. Milestones: Deep Blue beating Kasparov in 1997, AlexNet's ImageNet win in 2012, AlphaGo in 2016, and the large language models of the 2020s.</a:t>
-            </a:r>
-          </a:p>
-        </p:txBody>
-      </p:sp>
-    </p:spTree>
-  </p:cSld>
-  <p:clrMapOvr>
-    <a:masterClrMapping/>
-  </p:clrMapOvr>
-</p:notes>
-</file>
-
-<file path=ppt/notesSlides/notesSlide7.xml><?xml version="1.0" encoding="utf-8"?>
-<p:notes xmlns:p="http://schemas.openxmlformats.org/presentationml/2006/main" xmlns:a="http://schemas.openxmlformats.org/drawingml/2006/main" xmlns:r="http://schemas.openxmlformats.org/officeDocument/2006/relationships">
-  <p:cSld>
-    <p:spTree>
-      <p:nvGrpSpPr>
-        <p:cNvPr id="1" name=""/>
-        <p:cNvGrpSpPr/>
-        <p:nvPr/>
-      </p:nvGrpSpPr>
-      <p:grpSpPr>
-        <a:xfrm>
-          <a:off x="0" y="0"/>
-          <a:ext cx="0" cy="0"/>
-          <a:chOff x="0" y="0"/>
-          <a:chExt cx="0" cy="0"/>
-        </a:xfrm>
-      </p:grpSpPr>
-      <p:sp>
-        <p:nvSpPr>
-          <p:cNvPr id="2" name="Slide Image Placeholder 1"/>
-          <p:cNvSpPr>
-            <a:spLocks noGrp="1" noRot="1" noChangeAspect="1"/>
-          </p:cNvSpPr>
-          <p:nvPr>
-            <p:ph type="sldImg"/>
-          </p:nvPr>
-        </p:nvSpPr>
-        <p:spPr>
-          <a:xfrm>
-            <a:off x="685800" y="457200"/>
-            <a:ext cx="4114800" cy="3086100"/>
-          </a:xfrm>
-          <a:prstGeom prst="rect">
-            <a:avLst/>
-          </a:prstGeom>
-          <a:noFill/>
-          <a:ln>
-            <a:solidFill>
-              <a:prstClr val="black"/>
-            </a:solidFill>
-          </a:ln>
-        </p:spPr>
-        <p:txBody>
-          <a:bodyPr/>
-          <a:lstStyle/>
-          <a:p/>
-        </p:txBody>
-      </p:sp>
-      <p:sp>
-        <p:nvSpPr>
-          <p:cNvPr id="3" name="Notes Placeholder 2"/>
-          <p:cNvSpPr>
-            <a:spLocks noGrp="1"/>
-          </p:cNvSpPr>
-          <p:nvPr>
-            <p:ph type="body" idx="1"/>
-          </p:nvPr>
-        </p:nvSpPr>
-        <p:spPr>
-          <a:xfrm>
-            <a:off x="685800" y="3771900"/>
-            <a:ext cx="5486400" cy="3600450"/>
-          </a:xfrm>
-          <a:prstGeom prst="rect">
-            <a:avLst/>
-          </a:prstGeom>
-        </p:spPr>
-        <p:txBody>
-          <a:bodyPr/>
-          <a:lstStyle/>
-          <a:p>
-            <a:r>
-              <a:rPr lang="en-US" dirty="0"/>
-              <a:t>Summarise: AI has moved through optimism (1956-73), the first winter (1974-80), the expert systems boom and second winter (1980-93), and a data-driven renewal. The recurring causes are technical — scaling limits, brittleness, missing commonsense — and economic — speculative investment, defensive national programmes, and reliance on narrow hardware markets. Practical guidance for students and future professionals: ask what exactly was demonstrated and on what data; ask about maintenance and total cost of ownership, the lesson of expert systems; be sceptical of timeline claims for general intelligence; and remember that winters did not end research, they ended funding and attention. Recognising warning signs protects both research programmes and organisational investment. Invite discussion: are current large-model expectations sustainable, or are we near another correction?</a:t>
-            </a:r>
-          </a:p>
-        </p:txBody>
-      </p:sp>
-    </p:spTree>
-  </p:cSld>
-  <p:clrMapOvr>
-    <a:masterClrMapping/>
-  </p:clrMapOvr>
-</p:notes>
-</file>
-
-<file path=ppt/notesSlides/notesSlide8.xml><?xml version="1.0" encoding="utf-8"?>
-<p:notes xmlns:p="http://schemas.openxmlformats.org/presentationml/2006/main" xmlns:a="http://schemas.openxmlformats.org/drawingml/2006/main" xmlns:r="http://schemas.openxmlformats.org/officeDocument/2006/relationships">
-  <p:cSld>
-    <p:spTree>
-      <p:nvGrpSpPr>
-        <p:cNvPr id="1" name=""/>
-        <p:cNvGrpSpPr/>
-        <p:nvPr/>
-      </p:nvGrpSpPr>
-      <p:grpSpPr>
-        <a:xfrm>
-          <a:off x="0" y="0"/>
-          <a:ext cx="0" cy="0"/>
-          <a:chOff x="0" y="0"/>
-          <a:chExt cx="0" cy="0"/>
-        </a:xfrm>
-      </p:grpSpPr>
-      <p:sp>
-        <p:nvSpPr>
-          <p:cNvPr id="2" name="Slide Image Placeholder 1"/>
-          <p:cNvSpPr>
-            <a:spLocks noGrp="1" noRot="1" noChangeAspect="1"/>
-          </p:cNvSpPr>
-          <p:nvPr>
-            <p:ph type="sldImg"/>
-          </p:nvPr>
-        </p:nvSpPr>
-        <p:spPr>
-          <a:xfrm>
-            <a:off x="685800" y="457200"/>
-            <a:ext cx="4114800" cy="3086100"/>
-          </a:xfrm>
-          <a:prstGeom prst="rect">
-            <a:avLst/>
-          </a:prstGeom>
-          <a:noFill/>
-          <a:ln>
-            <a:solidFill>
-              <a:prstClr val="black"/>
-            </a:solidFill>
-          </a:ln>
-        </p:spPr>
-        <p:txBody>
-          <a:bodyPr/>
-          <a:lstStyle/>
-          <a:p/>
-        </p:txBody>
-      </p:sp>
-      <p:sp>
-        <p:nvSpPr>
-          <p:cNvPr id="3" name="Notes Placeholder 2"/>
-          <p:cNvSpPr>
-            <a:spLocks noGrp="1"/>
-          </p:cNvSpPr>
-          <p:nvPr>
-            <p:ph type="body" idx="1"/>
-          </p:nvPr>
-        </p:nvSpPr>
-        <p:spPr>
-          <a:xfrm>
-            <a:off x="685800" y="3771900"/>
-            <a:ext cx="5486400" cy="3600450"/>
-          </a:xfrm>
-          <a:prstGeom prst="rect">
-            <a:avLst/>
-          </a:prstGeom>
-        </p:spPr>
-        <p:txBody>
-          <a:bodyPr/>
-          <a:lstStyle/>
-          <a:p>
-            <a:r>
-              <a:rPr lang="en-US" dirty="0"/>
               <a:t>Clarify scope for students: this presentation is a focused historical analysis supporting MO4, examining the technical factors (combinatorial explosion, brittleness, knowledge acquisition bottleneck, hardware limits) and economic factors (Lighthill Report, Mansfield Amendment, DARPA redirection, LISP machine market collapse, Fifth Generation competition) behind the 1974-1980 and 1987-1993 winters. Outcomes MO1, MO2, MO3 and MO5 are covered in other sessions of the module.</a:t>
             </a:r>
           </a:p>
@@ -775,7 +3765,7 @@
 </file>
 
 <file path=ppt/slideLayouts/slideLayout1.xml><?xml version="1.0" encoding="utf-8"?>
-<p:sldLayout xmlns:p="http://schemas.openxmlformats.org/presentationml/2006/main" xmlns:a="http://schemas.openxmlformats.org/drawingml/2006/main" xmlns:r="http://schemas.openxmlformats.org/officeDocument/2006/relationships" type="tx" preserve="1">
+<p:sldLayout xmlns:a="http://schemas.openxmlformats.org/drawingml/2006/main" xmlns:r="http://schemas.openxmlformats.org/officeDocument/2006/relationships" xmlns:p="http://schemas.openxmlformats.org/presentationml/2006/main" type="tx" preserve="1">
   <p:cSld name="Title and Content">
     <p:spTree>
       <p:nvGrpSpPr>
@@ -1044,6 +4034,14 @@
 <file path=ppt/slides/slide1.xml><?xml version="1.0" encoding="utf-8"?>
 <p:sld xmlns:a="http://schemas.openxmlformats.org/drawingml/2006/main" xmlns:r="http://schemas.openxmlformats.org/officeDocument/2006/relationships" xmlns:p="http://schemas.openxmlformats.org/presentationml/2006/main">
   <p:cSld>
+    <p:bg>
+      <p:bgPr>
+        <a:solidFill>
+          <a:schemeClr val="bg1"/>
+        </a:solidFill>
+        <a:effectLst/>
+      </p:bgPr>
+    </p:bg>
     <p:spTree>
       <p:nvGrpSpPr>
         <p:cNvPr id="1" name=""/>
@@ -1058,6 +4056,129 @@
           <a:chExt cx="0" cy="0"/>
         </a:xfrm>
       </p:grpSpPr>
+      <p:sp useBgFill="1">
+        <p:nvSpPr>
+          <p:cNvPr id="8" name="Rectangle 7">
+            <a:extLst>
+              <a:ext uri="{FF2B5EF4-FFF2-40B4-BE49-F238E27FC236}">
+                <a16:creationId xmlns:a16="http://schemas.microsoft.com/office/drawing/2014/main" id="{C2554CA6-288E-4202-BC52-2E5A8F0C0AED}"/>
+              </a:ext>
+              <a:ext uri="{C183D7F6-B498-43B3-948B-1728B52AA6E4}">
+                <adec:decorative xmlns:adec="http://schemas.microsoft.com/office/drawing/2017/decorative" val="1"/>
+              </a:ext>
+            </a:extLst>
+          </p:cNvPr>
+          <p:cNvSpPr>
+            <a:spLocks noGrp="1" noRot="1" noChangeAspect="1" noMove="1" noResize="1" noEditPoints="1" noAdjustHandles="1" noChangeArrowheads="1" noChangeShapeType="1" noTextEdit="1"/>
+          </p:cNvSpPr>
+          <p:nvPr>
+            <p:extLst>
+              <p:ext uri="{386F3935-93C4-4BCD-93E2-E3B085C9AB24}">
+                <p16:designElem xmlns:p16="http://schemas.microsoft.com/office/powerpoint/2015/main" val="1"/>
+              </p:ext>
+            </p:extLst>
+          </p:nvPr>
+        </p:nvSpPr>
+        <p:spPr>
+          <a:xfrm>
+            <a:off x="3048" y="0"/>
+            <a:ext cx="12188952" cy="6858000"/>
+          </a:xfrm>
+          <a:prstGeom prst="rect">
+            <a:avLst/>
+          </a:prstGeom>
+          <a:ln>
+            <a:noFill/>
+          </a:ln>
+        </p:spPr>
+        <p:style>
+          <a:lnRef idx="2">
+            <a:schemeClr val="accent1">
+              <a:shade val="50000"/>
+            </a:schemeClr>
+          </a:lnRef>
+          <a:fillRef idx="1">
+            <a:schemeClr val="accent1"/>
+          </a:fillRef>
+          <a:effectRef idx="0">
+            <a:schemeClr val="accent1"/>
+          </a:effectRef>
+          <a:fontRef idx="minor">
+            <a:schemeClr val="lt1"/>
+          </a:fontRef>
+        </p:style>
+        <p:txBody>
+          <a:bodyPr rtlCol="0" anchor="ctr"/>
+          <a:lstStyle/>
+          <a:p>
+            <a:pPr algn="ctr"/>
+            <a:endParaRPr lang="en-US"/>
+          </a:p>
+        </p:txBody>
+      </p:sp>
+      <p:sp>
+        <p:nvSpPr>
+          <p:cNvPr id="10" name="Oval 9">
+            <a:extLst>
+              <a:ext uri="{FF2B5EF4-FFF2-40B4-BE49-F238E27FC236}">
+                <a16:creationId xmlns:a16="http://schemas.microsoft.com/office/drawing/2014/main" id="{B10BB131-AC8E-4A8E-A5D1-36260F720C3B}"/>
+              </a:ext>
+              <a:ext uri="{C183D7F6-B498-43B3-948B-1728B52AA6E4}">
+                <adec:decorative xmlns:adec="http://schemas.microsoft.com/office/drawing/2017/decorative" val="1"/>
+              </a:ext>
+            </a:extLst>
+          </p:cNvPr>
+          <p:cNvSpPr>
+            <a:spLocks noGrp="1" noRot="1" noChangeAspect="1" noMove="1" noResize="1" noEditPoints="1" noAdjustHandles="1" noChangeArrowheads="1" noChangeShapeType="1" noTextEdit="1"/>
+          </p:cNvSpPr>
+          <p:nvPr>
+            <p:extLst>
+              <p:ext uri="{386F3935-93C4-4BCD-93E2-E3B085C9AB24}">
+                <p16:designElem xmlns:p16="http://schemas.microsoft.com/office/powerpoint/2015/main" val="1"/>
+              </p:ext>
+            </p:extLst>
+          </p:nvPr>
+        </p:nvSpPr>
+        <p:spPr>
+          <a:xfrm>
+            <a:off x="489189" y="1119031"/>
+            <a:ext cx="4619938" cy="4619938"/>
+          </a:xfrm>
+          <a:prstGeom prst="ellipse">
+            <a:avLst/>
+          </a:prstGeom>
+          <a:solidFill>
+            <a:schemeClr val="accent2"/>
+          </a:solidFill>
+          <a:ln>
+            <a:noFill/>
+          </a:ln>
+        </p:spPr>
+        <p:style>
+          <a:lnRef idx="2">
+            <a:schemeClr val="accent1">
+              <a:shade val="50000"/>
+            </a:schemeClr>
+          </a:lnRef>
+          <a:fillRef idx="1">
+            <a:schemeClr val="accent1"/>
+          </a:fillRef>
+          <a:effectRef idx="0">
+            <a:schemeClr val="accent1"/>
+          </a:effectRef>
+          <a:fontRef idx="minor">
+            <a:schemeClr val="lt1"/>
+          </a:fontRef>
+        </p:style>
+        <p:txBody>
+          <a:bodyPr rtlCol="0" anchor="ctr"/>
+          <a:lstStyle/>
+          <a:p>
+            <a:pPr algn="ctr"/>
+            <a:endParaRPr lang="en-US"/>
+          </a:p>
+        </p:txBody>
+      </p:sp>
       <p:sp>
         <p:nvSpPr>
           <p:cNvPr id="2" name="Title 1"/>
@@ -1068,15 +4189,215 @@
             <p:ph type="title"/>
           </p:nvPr>
         </p:nvSpPr>
-        <p:spPr/>
+        <p:spPr>
+          <a:xfrm>
+            <a:off x="1171074" y="1396686"/>
+            <a:ext cx="3240506" cy="4064628"/>
+          </a:xfrm>
+        </p:spPr>
         <p:txBody>
-          <a:bodyPr/>
+          <a:bodyPr vert="horz" lIns="91440" tIns="45720" rIns="91440" bIns="45720" rtlCol="0" anchor="ctr">
+            <a:normAutofit/>
+          </a:bodyPr>
           <a:lstStyle/>
           <a:p>
             <a:r>
-              <a:rPr lang="en-US" dirty="0"/>
+              <a:rPr lang="en-US" kern="1200">
+                <a:solidFill>
+                  <a:srgbClr val="FFFFFF"/>
+                </a:solidFill>
+                <a:latin typeface="+mj-lt"/>
+                <a:ea typeface="+mj-ea"/>
+                <a:cs typeface="+mj-cs"/>
+              </a:rPr>
               <a:t>AI Winters and Cycles of Progress</a:t>
             </a:r>
+          </a:p>
+        </p:txBody>
+      </p:sp>
+      <p:sp>
+        <p:nvSpPr>
+          <p:cNvPr id="12" name="Arc 11">
+            <a:extLst>
+              <a:ext uri="{FF2B5EF4-FFF2-40B4-BE49-F238E27FC236}">
+                <a16:creationId xmlns:a16="http://schemas.microsoft.com/office/drawing/2014/main" id="{5B7778FC-632E-4DCA-A7CB-0D7731CCF970}"/>
+              </a:ext>
+              <a:ext uri="{C183D7F6-B498-43B3-948B-1728B52AA6E4}">
+                <adec:decorative xmlns:adec="http://schemas.microsoft.com/office/drawing/2017/decorative" val="1"/>
+              </a:ext>
+            </a:extLst>
+          </p:cNvPr>
+          <p:cNvSpPr>
+            <a:spLocks noGrp="1" noRot="1" noChangeAspect="1" noMove="1" noResize="1" noEditPoints="1" noAdjustHandles="1" noChangeArrowheads="1" noChangeShapeType="1" noTextEdit="1"/>
+          </p:cNvSpPr>
+          <p:nvPr>
+            <p:extLst>
+              <p:ext uri="{386F3935-93C4-4BCD-93E2-E3B085C9AB24}">
+                <p16:designElem xmlns:p16="http://schemas.microsoft.com/office/powerpoint/2015/main" val="1"/>
+              </p:ext>
+            </p:extLst>
+          </p:nvPr>
+        </p:nvSpPr>
+        <p:spPr>
+          <a:xfrm rot="19809111">
+            <a:off x="8683720" y="941148"/>
+            <a:ext cx="2987899" cy="2987899"/>
+          </a:xfrm>
+          <a:prstGeom prst="arc">
+            <a:avLst>
+              <a:gd name="adj1" fmla="val 15817365"/>
+              <a:gd name="adj2" fmla="val 1781380"/>
+            </a:avLst>
+          </a:prstGeom>
+          <a:ln w="127000" cap="rnd">
+            <a:solidFill>
+              <a:schemeClr val="accent4"/>
+            </a:solidFill>
+            <a:prstDash val="dash"/>
+            <a:miter lim="800000"/>
+          </a:ln>
+        </p:spPr>
+        <p:style>
+          <a:lnRef idx="1">
+            <a:schemeClr val="accent1"/>
+          </a:lnRef>
+          <a:fillRef idx="0">
+            <a:schemeClr val="accent1"/>
+          </a:fillRef>
+          <a:effectRef idx="0">
+            <a:schemeClr val="accent1"/>
+          </a:effectRef>
+          <a:fontRef idx="minor">
+            <a:schemeClr val="tx1"/>
+          </a:fontRef>
+        </p:style>
+        <p:txBody>
+          <a:bodyPr rtlCol="0" anchor="ctr"/>
+          <a:lstStyle/>
+          <a:p>
+            <a:pPr marL="0" marR="0" lvl="0" indent="0" algn="ctr" defTabSz="914400" rtl="0" eaLnBrk="1" fontAlgn="auto" latinLnBrk="0" hangingPunct="1">
+              <a:lnSpc>
+                <a:spcPct val="100000"/>
+              </a:lnSpc>
+              <a:spcBef>
+                <a:spcPts val="0"/>
+              </a:spcBef>
+              <a:spcAft>
+                <a:spcPts val="0"/>
+              </a:spcAft>
+              <a:buClrTx/>
+              <a:buSzTx/>
+              <a:buFontTx/>
+              <a:buNone/>
+              <a:tabLst/>
+              <a:defRPr/>
+            </a:pPr>
+            <a:endParaRPr kumimoji="0" lang="en-US" sz="1800" b="0" i="0" u="none" strike="noStrike" kern="1200" cap="none" spc="0" normalizeH="0" baseline="0" noProof="0">
+              <a:ln>
+                <a:noFill/>
+              </a:ln>
+              <a:solidFill>
+                <a:srgbClr val="000000"/>
+              </a:solidFill>
+              <a:effectLst/>
+              <a:uLnTx/>
+              <a:uFillTx/>
+              <a:latin typeface="Calibri" panose="020F0502020204030204"/>
+              <a:ea typeface="+mn-ea"/>
+              <a:cs typeface="+mn-cs"/>
+            </a:endParaRPr>
+          </a:p>
+        </p:txBody>
+      </p:sp>
+      <p:sp>
+        <p:nvSpPr>
+          <p:cNvPr id="14" name="Oval 13">
+            <a:extLst>
+              <a:ext uri="{FF2B5EF4-FFF2-40B4-BE49-F238E27FC236}">
+                <a16:creationId xmlns:a16="http://schemas.microsoft.com/office/drawing/2014/main" id="{FA23A907-97FB-4A8F-880A-DD77401C4296}"/>
+              </a:ext>
+              <a:ext uri="{C183D7F6-B498-43B3-948B-1728B52AA6E4}">
+                <adec:decorative xmlns:adec="http://schemas.microsoft.com/office/drawing/2017/decorative" val="1"/>
+              </a:ext>
+            </a:extLst>
+          </p:cNvPr>
+          <p:cNvSpPr>
+            <a:spLocks noGrp="1" noRot="1" noChangeAspect="1" noMove="1" noResize="1" noEditPoints="1" noAdjustHandles="1" noChangeArrowheads="1" noChangeShapeType="1" noTextEdit="1"/>
+          </p:cNvSpPr>
+          <p:nvPr>
+            <p:extLst>
+              <p:ext uri="{386F3935-93C4-4BCD-93E2-E3B085C9AB24}">
+                <p16:designElem xmlns:p16="http://schemas.microsoft.com/office/powerpoint/2015/main" val="1"/>
+              </p:ext>
+            </p:extLst>
+          </p:nvPr>
+        </p:nvSpPr>
+        <p:spPr>
+          <a:xfrm>
+            <a:off x="910048" y="4780992"/>
+            <a:ext cx="546100" cy="546100"/>
+          </a:xfrm>
+          <a:prstGeom prst="ellipse">
+            <a:avLst/>
+          </a:prstGeom>
+          <a:solidFill>
+            <a:schemeClr val="accent5"/>
+          </a:solidFill>
+          <a:ln>
+            <a:noFill/>
+          </a:ln>
+        </p:spPr>
+        <p:style>
+          <a:lnRef idx="2">
+            <a:schemeClr val="accent1">
+              <a:shade val="50000"/>
+            </a:schemeClr>
+          </a:lnRef>
+          <a:fillRef idx="1">
+            <a:schemeClr val="accent1"/>
+          </a:fillRef>
+          <a:effectRef idx="0">
+            <a:schemeClr val="accent1"/>
+          </a:effectRef>
+          <a:fontRef idx="minor">
+            <a:schemeClr val="lt1"/>
+          </a:fontRef>
+        </p:style>
+        <p:txBody>
+          <a:bodyPr rtlCol="0" anchor="ctr"/>
+          <a:lstStyle/>
+          <a:p>
+            <a:pPr marL="0" marR="0" lvl="0" indent="0" algn="ctr" defTabSz="914400" rtl="0" eaLnBrk="1" fontAlgn="auto" latinLnBrk="0" hangingPunct="1">
+              <a:lnSpc>
+                <a:spcPct val="100000"/>
+              </a:lnSpc>
+              <a:spcBef>
+                <a:spcPts val="0"/>
+              </a:spcBef>
+              <a:spcAft>
+                <a:spcPts val="0"/>
+              </a:spcAft>
+              <a:buClrTx/>
+              <a:buSzTx/>
+              <a:buFontTx/>
+              <a:buNone/>
+              <a:tabLst/>
+              <a:defRPr/>
+            </a:pPr>
+            <a:endParaRPr kumimoji="0" lang="en-US" sz="1800" b="0" i="0" u="none" strike="noStrike" kern="1200" cap="none" spc="0" normalizeH="0" baseline="0" noProof="0">
+              <a:ln>
+                <a:noFill/>
+              </a:ln>
+              <a:solidFill>
+                <a:srgbClr val="FFFFFF"/>
+              </a:solidFill>
+              <a:effectLst/>
+              <a:uLnTx/>
+              <a:uFillTx/>
+              <a:latin typeface="Calibri" panose="020F0502020204030204"/>
+              <a:ea typeface="+mn-ea"/>
+              <a:cs typeface="+mn-cs"/>
+            </a:endParaRPr>
           </a:p>
         </p:txBody>
       </p:sp>
@@ -1090,21 +4411,31 @@
             <p:ph idx="1"/>
           </p:nvPr>
         </p:nvSpPr>
-        <p:spPr/>
+        <p:spPr>
+          <a:xfrm>
+            <a:off x="5370153" y="1526033"/>
+            <a:ext cx="5536397" cy="3935281"/>
+          </a:xfrm>
+        </p:spPr>
         <p:txBody>
-          <a:bodyPr/>
+          <a:bodyPr vert="horz" lIns="91440" tIns="45720" rIns="91440" bIns="45720" rtlCol="0">
+            <a:normAutofit/>
+          </a:bodyPr>
           <a:lstStyle/>
           <a:p>
-            <a:pPr algn="ctr">
-              <a:buNone/>
-            </a:pPr>
             <a:r>
-              <a:rPr lang="en-US" dirty="0"/>
+              <a:rPr lang="en-US">
+                <a:ea typeface="+mn-ea"/>
+                <a:cs typeface="+mn-cs"/>
+              </a:rPr>
               <a:t>How hype, funding collapse and renewal shaped artificial intelligence's uneven history</a:t>
             </a:r>
           </a:p>
           <a:p>
-            <a:endParaRPr lang="en-US" dirty="0"/>
+            <a:endParaRPr lang="en-US">
+              <a:ea typeface="+mn-ea"/>
+              <a:cs typeface="+mn-cs"/>
+            </a:endParaRPr>
           </a:p>
         </p:txBody>
       </p:sp>
@@ -1119,6 +4450,14 @@
 <file path=ppt/slides/slide2.xml><?xml version="1.0" encoding="utf-8"?>
 <p:sld xmlns:a="http://schemas.openxmlformats.org/drawingml/2006/main" xmlns:r="http://schemas.openxmlformats.org/officeDocument/2006/relationships" xmlns:p="http://schemas.openxmlformats.org/presentationml/2006/main">
   <p:cSld>
+    <p:bg>
+      <p:bgPr>
+        <a:solidFill>
+          <a:schemeClr val="bg1"/>
+        </a:solidFill>
+        <a:effectLst/>
+      </p:bgPr>
+    </p:bg>
     <p:spTree>
       <p:nvGrpSpPr>
         <p:cNvPr id="1" name=""/>
@@ -1133,6 +4472,467 @@
           <a:chExt cx="0" cy="0"/>
         </a:xfrm>
       </p:grpSpPr>
+      <p:sp useBgFill="1">
+        <p:nvSpPr>
+          <p:cNvPr id="9" name="Rectangle 8">
+            <a:extLst>
+              <a:ext uri="{FF2B5EF4-FFF2-40B4-BE49-F238E27FC236}">
+                <a16:creationId xmlns:a16="http://schemas.microsoft.com/office/drawing/2014/main" id="{C05CBC3C-2E5A-4839-8B9B-2E5A6ADF0F58}"/>
+              </a:ext>
+              <a:ext uri="{C183D7F6-B498-43B3-948B-1728B52AA6E4}">
+                <adec:decorative xmlns:adec="http://schemas.microsoft.com/office/drawing/2017/decorative" val="1"/>
+              </a:ext>
+            </a:extLst>
+          </p:cNvPr>
+          <p:cNvSpPr>
+            <a:spLocks noGrp="1" noRot="1" noChangeAspect="1" noMove="1" noResize="1" noEditPoints="1" noAdjustHandles="1" noChangeArrowheads="1" noChangeShapeType="1" noTextEdit="1"/>
+          </p:cNvSpPr>
+          <p:nvPr>
+            <p:extLst>
+              <p:ext uri="{386F3935-93C4-4BCD-93E2-E3B085C9AB24}">
+                <p16:designElem xmlns:p16="http://schemas.microsoft.com/office/powerpoint/2015/main" val="1"/>
+              </p:ext>
+            </p:extLst>
+          </p:nvPr>
+        </p:nvSpPr>
+        <p:spPr>
+          <a:xfrm>
+            <a:off x="0" y="0"/>
+            <a:ext cx="12188952" cy="6858000"/>
+          </a:xfrm>
+          <a:prstGeom prst="rect">
+            <a:avLst/>
+          </a:prstGeom>
+          <a:ln>
+            <a:noFill/>
+          </a:ln>
+        </p:spPr>
+        <p:style>
+          <a:lnRef idx="2">
+            <a:schemeClr val="accent1">
+              <a:shade val="50000"/>
+            </a:schemeClr>
+          </a:lnRef>
+          <a:fillRef idx="1">
+            <a:schemeClr val="accent1"/>
+          </a:fillRef>
+          <a:effectRef idx="0">
+            <a:schemeClr val="accent1"/>
+          </a:effectRef>
+          <a:fontRef idx="minor">
+            <a:schemeClr val="lt1"/>
+          </a:fontRef>
+        </p:style>
+        <p:txBody>
+          <a:bodyPr rtlCol="0" anchor="ctr"/>
+          <a:lstStyle/>
+          <a:p>
+            <a:pPr algn="ctr"/>
+            <a:endParaRPr lang="en-US"/>
+          </a:p>
+        </p:txBody>
+      </p:sp>
+      <p:sp>
+        <p:nvSpPr>
+          <p:cNvPr id="11" name="Freeform: Shape 10">
+            <a:extLst>
+              <a:ext uri="{FF2B5EF4-FFF2-40B4-BE49-F238E27FC236}">
+                <a16:creationId xmlns:a16="http://schemas.microsoft.com/office/drawing/2014/main" id="{DB5B423A-57CC-4C58-AA26-8E2E862B03A0}"/>
+              </a:ext>
+              <a:ext uri="{C183D7F6-B498-43B3-948B-1728B52AA6E4}">
+                <adec:decorative xmlns:adec="http://schemas.microsoft.com/office/drawing/2017/decorative" val="1"/>
+              </a:ext>
+            </a:extLst>
+          </p:cNvPr>
+          <p:cNvSpPr>
+            <a:spLocks noGrp="1" noRot="1" noChangeAspect="1" noMove="1" noResize="1" noEditPoints="1" noAdjustHandles="1" noChangeArrowheads="1" noChangeShapeType="1" noTextEdit="1"/>
+          </p:cNvSpPr>
+          <p:nvPr>
+            <p:extLst>
+              <p:ext uri="{386F3935-93C4-4BCD-93E2-E3B085C9AB24}">
+                <p16:designElem xmlns:p16="http://schemas.microsoft.com/office/powerpoint/2015/main" val="1"/>
+              </p:ext>
+            </p:extLst>
+          </p:nvPr>
+        </p:nvSpPr>
+        <p:spPr>
+          <a:xfrm>
+            <a:off x="1" y="1"/>
+            <a:ext cx="5217023" cy="3994777"/>
+          </a:xfrm>
+          <a:custGeom>
+            <a:avLst/>
+            <a:gdLst>
+              <a:gd name="connsiteX0" fmla="*/ 1945461 w 5217023"/>
+              <a:gd name="connsiteY0" fmla="*/ 3787398 h 3994777"/>
+              <a:gd name="connsiteX1" fmla="*/ 1942113 w 5217023"/>
+              <a:gd name="connsiteY1" fmla="*/ 3790053 h 3994777"/>
+              <a:gd name="connsiteX2" fmla="*/ 1946982 w 5217023"/>
+              <a:gd name="connsiteY2" fmla="*/ 3787990 h 3994777"/>
+              <a:gd name="connsiteX3" fmla="*/ 1945461 w 5217023"/>
+              <a:gd name="connsiteY3" fmla="*/ 3787398 h 3994777"/>
+              <a:gd name="connsiteX4" fmla="*/ 0 w 5217023"/>
+              <a:gd name="connsiteY4" fmla="*/ 0 h 3994777"/>
+              <a:gd name="connsiteX5" fmla="*/ 5030958 w 5217023"/>
+              <a:gd name="connsiteY5" fmla="*/ 0 h 3994777"/>
+              <a:gd name="connsiteX6" fmla="*/ 5046198 w 5217023"/>
+              <a:gd name="connsiteY6" fmla="*/ 153449 h 3994777"/>
+              <a:gd name="connsiteX7" fmla="*/ 5055729 w 5217023"/>
+              <a:gd name="connsiteY7" fmla="*/ 415828 h 3994777"/>
+              <a:gd name="connsiteX8" fmla="*/ 4735242 w 5217023"/>
+              <a:gd name="connsiteY8" fmla="*/ 1867130 h 3994777"/>
+              <a:gd name="connsiteX9" fmla="*/ 3907395 w 5217023"/>
+              <a:gd name="connsiteY9" fmla="*/ 2938441 h 3994777"/>
+              <a:gd name="connsiteX10" fmla="*/ 3946497 w 5217023"/>
+              <a:gd name="connsiteY10" fmla="*/ 2908567 h 3994777"/>
+              <a:gd name="connsiteX11" fmla="*/ 4585421 w 5217023"/>
+              <a:gd name="connsiteY11" fmla="*/ 2188401 h 3994777"/>
+              <a:gd name="connsiteX12" fmla="*/ 5142585 w 5217023"/>
+              <a:gd name="connsiteY12" fmla="*/ 276891 h 3994777"/>
+              <a:gd name="connsiteX13" fmla="*/ 5121833 w 5217023"/>
+              <a:gd name="connsiteY13" fmla="*/ 30208 h 3994777"/>
+              <a:gd name="connsiteX14" fmla="*/ 5116229 w 5217023"/>
+              <a:gd name="connsiteY14" fmla="*/ 0 h 3994777"/>
+              <a:gd name="connsiteX15" fmla="*/ 5184724 w 5217023"/>
+              <a:gd name="connsiteY15" fmla="*/ 0 h 3994777"/>
+              <a:gd name="connsiteX16" fmla="*/ 5196265 w 5217023"/>
+              <a:gd name="connsiteY16" fmla="*/ 66113 h 3994777"/>
+              <a:gd name="connsiteX17" fmla="*/ 5058603 w 5217023"/>
+              <a:gd name="connsiteY17" fmla="*/ 1368242 h 3994777"/>
+              <a:gd name="connsiteX18" fmla="*/ 4096624 w 5217023"/>
+              <a:gd name="connsiteY18" fmla="*/ 2870829 h 3994777"/>
+              <a:gd name="connsiteX19" fmla="*/ 3833203 w 5217023"/>
+              <a:gd name="connsiteY19" fmla="*/ 3092190 h 3994777"/>
+              <a:gd name="connsiteX20" fmla="*/ 3536509 w 5217023"/>
+              <a:gd name="connsiteY20" fmla="*/ 3297128 h 3994777"/>
+              <a:gd name="connsiteX21" fmla="*/ 3148966 w 5217023"/>
+              <a:gd name="connsiteY21" fmla="*/ 3485478 h 3994777"/>
+              <a:gd name="connsiteX22" fmla="*/ 1860557 w 5217023"/>
+              <a:gd name="connsiteY22" fmla="*/ 3880910 h 3994777"/>
+              <a:gd name="connsiteX23" fmla="*/ 573715 w 5217023"/>
+              <a:gd name="connsiteY23" fmla="*/ 3983764 h 3994777"/>
+              <a:gd name="connsiteX24" fmla="*/ 108410 w 5217023"/>
+              <a:gd name="connsiteY24" fmla="*/ 3908816 h 3994777"/>
+              <a:gd name="connsiteX25" fmla="*/ 0 w 5217023"/>
+              <a:gd name="connsiteY25" fmla="*/ 3876793 h 3994777"/>
+              <a:gd name="connsiteX26" fmla="*/ 0 w 5217023"/>
+              <a:gd name="connsiteY26" fmla="*/ 3802912 h 3994777"/>
+              <a:gd name="connsiteX27" fmla="*/ 36975 w 5217023"/>
+              <a:gd name="connsiteY27" fmla="*/ 3815954 h 3994777"/>
+              <a:gd name="connsiteX28" fmla="*/ 561628 w 5217023"/>
+              <a:gd name="connsiteY28" fmla="*/ 3912655 h 3994777"/>
+              <a:gd name="connsiteX29" fmla="*/ 1683086 w 5217023"/>
+              <a:gd name="connsiteY29" fmla="*/ 3844334 h 3994777"/>
+              <a:gd name="connsiteX30" fmla="*/ 1806023 w 5217023"/>
+              <a:gd name="connsiteY30" fmla="*/ 3820992 h 3994777"/>
+              <a:gd name="connsiteX31" fmla="*/ 1921817 w 5217023"/>
+              <a:gd name="connsiteY31" fmla="*/ 3795747 h 3994777"/>
+              <a:gd name="connsiteX32" fmla="*/ 1243689 w 5217023"/>
+              <a:gd name="connsiteY32" fmla="*/ 3846539 h 3994777"/>
+              <a:gd name="connsiteX33" fmla="*/ 62875 w 5217023"/>
+              <a:gd name="connsiteY33" fmla="*/ 3668143 h 3994777"/>
+              <a:gd name="connsiteX34" fmla="*/ 0 w 5217023"/>
+              <a:gd name="connsiteY34" fmla="*/ 3644185 h 3994777"/>
+            </a:gdLst>
+            <a:ahLst/>
+            <a:cxnLst>
+              <a:cxn ang="0">
+                <a:pos x="connsiteX0" y="connsiteY0"/>
+              </a:cxn>
+              <a:cxn ang="0">
+                <a:pos x="connsiteX1" y="connsiteY1"/>
+              </a:cxn>
+              <a:cxn ang="0">
+                <a:pos x="connsiteX2" y="connsiteY2"/>
+              </a:cxn>
+              <a:cxn ang="0">
+                <a:pos x="connsiteX3" y="connsiteY3"/>
+              </a:cxn>
+              <a:cxn ang="0">
+                <a:pos x="connsiteX4" y="connsiteY4"/>
+              </a:cxn>
+              <a:cxn ang="0">
+                <a:pos x="connsiteX5" y="connsiteY5"/>
+              </a:cxn>
+              <a:cxn ang="0">
+                <a:pos x="connsiteX6" y="connsiteY6"/>
+              </a:cxn>
+              <a:cxn ang="0">
+                <a:pos x="connsiteX7" y="connsiteY7"/>
+              </a:cxn>
+              <a:cxn ang="0">
+                <a:pos x="connsiteX8" y="connsiteY8"/>
+              </a:cxn>
+              <a:cxn ang="0">
+                <a:pos x="connsiteX9" y="connsiteY9"/>
+              </a:cxn>
+              <a:cxn ang="0">
+                <a:pos x="connsiteX10" y="connsiteY10"/>
+              </a:cxn>
+              <a:cxn ang="0">
+                <a:pos x="connsiteX11" y="connsiteY11"/>
+              </a:cxn>
+              <a:cxn ang="0">
+                <a:pos x="connsiteX12" y="connsiteY12"/>
+              </a:cxn>
+              <a:cxn ang="0">
+                <a:pos x="connsiteX13" y="connsiteY13"/>
+              </a:cxn>
+              <a:cxn ang="0">
+                <a:pos x="connsiteX14" y="connsiteY14"/>
+              </a:cxn>
+              <a:cxn ang="0">
+                <a:pos x="connsiteX15" y="connsiteY15"/>
+              </a:cxn>
+              <a:cxn ang="0">
+                <a:pos x="connsiteX16" y="connsiteY16"/>
+              </a:cxn>
+              <a:cxn ang="0">
+                <a:pos x="connsiteX17" y="connsiteY17"/>
+              </a:cxn>
+              <a:cxn ang="0">
+                <a:pos x="connsiteX18" y="connsiteY18"/>
+              </a:cxn>
+              <a:cxn ang="0">
+                <a:pos x="connsiteX19" y="connsiteY19"/>
+              </a:cxn>
+              <a:cxn ang="0">
+                <a:pos x="connsiteX20" y="connsiteY20"/>
+              </a:cxn>
+              <a:cxn ang="0">
+                <a:pos x="connsiteX21" y="connsiteY21"/>
+              </a:cxn>
+              <a:cxn ang="0">
+                <a:pos x="connsiteX22" y="connsiteY22"/>
+              </a:cxn>
+              <a:cxn ang="0">
+                <a:pos x="connsiteX23" y="connsiteY23"/>
+              </a:cxn>
+              <a:cxn ang="0">
+                <a:pos x="connsiteX24" y="connsiteY24"/>
+              </a:cxn>
+              <a:cxn ang="0">
+                <a:pos x="connsiteX25" y="connsiteY25"/>
+              </a:cxn>
+              <a:cxn ang="0">
+                <a:pos x="connsiteX26" y="connsiteY26"/>
+              </a:cxn>
+              <a:cxn ang="0">
+                <a:pos x="connsiteX27" y="connsiteY27"/>
+              </a:cxn>
+              <a:cxn ang="0">
+                <a:pos x="connsiteX28" y="connsiteY28"/>
+              </a:cxn>
+              <a:cxn ang="0">
+                <a:pos x="connsiteX29" y="connsiteY29"/>
+              </a:cxn>
+              <a:cxn ang="0">
+                <a:pos x="connsiteX30" y="connsiteY30"/>
+              </a:cxn>
+              <a:cxn ang="0">
+                <a:pos x="connsiteX31" y="connsiteY31"/>
+              </a:cxn>
+              <a:cxn ang="0">
+                <a:pos x="connsiteX32" y="connsiteY32"/>
+              </a:cxn>
+              <a:cxn ang="0">
+                <a:pos x="connsiteX33" y="connsiteY33"/>
+              </a:cxn>
+              <a:cxn ang="0">
+                <a:pos x="connsiteX34" y="connsiteY34"/>
+              </a:cxn>
+            </a:cxnLst>
+            <a:rect l="l" t="t" r="r" b="b"/>
+            <a:pathLst>
+              <a:path w="5217023" h="3994777">
+                <a:moveTo>
+                  <a:pt x="1945461" y="3787398"/>
+                </a:moveTo>
+                <a:lnTo>
+                  <a:pt x="1942113" y="3790053"/>
+                </a:lnTo>
+                <a:lnTo>
+                  <a:pt x="1946982" y="3787990"/>
+                </a:lnTo>
+                <a:cubicBezTo>
+                  <a:pt x="1946982" y="3787990"/>
+                  <a:pt x="1946379" y="3787019"/>
+                  <a:pt x="1945461" y="3787398"/>
+                </a:cubicBezTo>
+                <a:close/>
+                <a:moveTo>
+                  <a:pt x="0" y="0"/>
+                </a:moveTo>
+                <a:lnTo>
+                  <a:pt x="5030958" y="0"/>
+                </a:lnTo>
+                <a:lnTo>
+                  <a:pt x="5046198" y="153449"/>
+                </a:lnTo>
+                <a:cubicBezTo>
+                  <a:pt x="5052189" y="240558"/>
+                  <a:pt x="5055458" y="328007"/>
+                  <a:pt x="5055729" y="415828"/>
+                </a:cubicBezTo>
+                <a:cubicBezTo>
+                  <a:pt x="5057604" y="923672"/>
+                  <a:pt x="4959210" y="1409054"/>
+                  <a:pt x="4735242" y="1867130"/>
+                </a:cubicBezTo>
+                <a:cubicBezTo>
+                  <a:pt x="4533284" y="2280198"/>
+                  <a:pt x="4248921" y="2629330"/>
+                  <a:pt x="3907395" y="2938441"/>
+                </a:cubicBezTo>
+                <a:cubicBezTo>
+                  <a:pt x="3922498" y="2931535"/>
+                  <a:pt x="3935859" y="2921330"/>
+                  <a:pt x="3946497" y="2908567"/>
+                </a:cubicBezTo>
+                <a:cubicBezTo>
+                  <a:pt x="4193494" y="2700987"/>
+                  <a:pt x="4408756" y="2458364"/>
+                  <a:pt x="4585421" y="2188401"/>
+                </a:cubicBezTo>
+                <a:cubicBezTo>
+                  <a:pt x="4967641" y="1608533"/>
+                  <a:pt x="5169304" y="975361"/>
+                  <a:pt x="5142585" y="276891"/>
+                </a:cubicBezTo>
+                <a:cubicBezTo>
+                  <a:pt x="5139764" y="194215"/>
+                  <a:pt x="5132824" y="111888"/>
+                  <a:pt x="5121833" y="30208"/>
+                </a:cubicBezTo>
+                <a:lnTo>
+                  <a:pt x="5116229" y="0"/>
+                </a:lnTo>
+                <a:lnTo>
+                  <a:pt x="5184724" y="0"/>
+                </a:lnTo>
+                <a:lnTo>
+                  <a:pt x="5196265" y="66113"/>
+                </a:lnTo>
+                <a:cubicBezTo>
+                  <a:pt x="5249921" y="496647"/>
+                  <a:pt x="5197997" y="931171"/>
+                  <a:pt x="5058603" y="1368242"/>
+                </a:cubicBezTo>
+                <a:cubicBezTo>
+                  <a:pt x="4872414" y="1953929"/>
+                  <a:pt x="4544298" y="2451351"/>
+                  <a:pt x="4096624" y="2870829"/>
+                </a:cubicBezTo>
+                <a:cubicBezTo>
+                  <a:pt x="4012832" y="2949426"/>
+                  <a:pt x="3924415" y="3022439"/>
+                  <a:pt x="3833203" y="3092190"/>
+                </a:cubicBezTo>
+                <a:cubicBezTo>
+                  <a:pt x="3741992" y="3161943"/>
+                  <a:pt x="3648667" y="3225510"/>
+                  <a:pt x="3536509" y="3297128"/>
+                </a:cubicBezTo>
+                <a:cubicBezTo>
+                  <a:pt x="3427215" y="3372735"/>
+                  <a:pt x="3288598" y="3430233"/>
+                  <a:pt x="3148966" y="3485478"/>
+                </a:cubicBezTo>
+                <a:cubicBezTo>
+                  <a:pt x="2729930" y="3651299"/>
+                  <a:pt x="2302194" y="3788890"/>
+                  <a:pt x="1860557" y="3880910"/>
+                </a:cubicBezTo>
+                <a:cubicBezTo>
+                  <a:pt x="1435974" y="3969444"/>
+                  <a:pt x="1008052" y="4017957"/>
+                  <a:pt x="573715" y="3983764"/>
+                </a:cubicBezTo>
+                <a:cubicBezTo>
+                  <a:pt x="415134" y="3971300"/>
+                  <a:pt x="259585" y="3947743"/>
+                  <a:pt x="108410" y="3908816"/>
+                </a:cubicBezTo>
+                <a:lnTo>
+                  <a:pt x="0" y="3876793"/>
+                </a:lnTo>
+                <a:lnTo>
+                  <a:pt x="0" y="3802912"/>
+                </a:lnTo>
+                <a:lnTo>
+                  <a:pt x="36975" y="3815954"/>
+                </a:lnTo>
+                <a:cubicBezTo>
+                  <a:pt x="206404" y="3867475"/>
+                  <a:pt x="382020" y="3897326"/>
+                  <a:pt x="561628" y="3912655"/>
+                </a:cubicBezTo>
+                <a:cubicBezTo>
+                  <a:pt x="938583" y="3944832"/>
+                  <a:pt x="1311814" y="3910697"/>
+                  <a:pt x="1683086" y="3844334"/>
+                </a:cubicBezTo>
+                <a:cubicBezTo>
+                  <a:pt x="1724123" y="3837151"/>
+                  <a:pt x="1765097" y="3829374"/>
+                  <a:pt x="1806023" y="3820992"/>
+                </a:cubicBezTo>
+                <a:cubicBezTo>
+                  <a:pt x="1844740" y="3813079"/>
+                  <a:pt x="1883218" y="3804161"/>
+                  <a:pt x="1921817" y="3795747"/>
+                </a:cubicBezTo>
+                <a:cubicBezTo>
+                  <a:pt x="1697011" y="3826435"/>
+                  <a:pt x="1470551" y="3843387"/>
+                  <a:pt x="1243689" y="3846539"/>
+                </a:cubicBezTo>
+                <a:cubicBezTo>
+                  <a:pt x="839058" y="3849054"/>
+                  <a:pt x="443424" y="3800206"/>
+                  <a:pt x="62875" y="3668143"/>
+                </a:cubicBezTo>
+                <a:lnTo>
+                  <a:pt x="0" y="3644185"/>
+                </a:lnTo>
+                <a:close/>
+              </a:path>
+            </a:pathLst>
+          </a:custGeom>
+          <a:solidFill>
+            <a:schemeClr val="accent2"/>
+          </a:solidFill>
+          <a:ln>
+            <a:noFill/>
+          </a:ln>
+        </p:spPr>
+        <p:style>
+          <a:lnRef idx="2">
+            <a:schemeClr val="accent1">
+              <a:shade val="50000"/>
+            </a:schemeClr>
+          </a:lnRef>
+          <a:fillRef idx="1">
+            <a:schemeClr val="accent1"/>
+          </a:fillRef>
+          <a:effectRef idx="0">
+            <a:schemeClr val="accent1"/>
+          </a:effectRef>
+          <a:fontRef idx="minor">
+            <a:schemeClr val="lt1"/>
+          </a:fontRef>
+        </p:style>
+        <p:txBody>
+          <a:bodyPr wrap="square" rtlCol="0" anchor="ctr">
+            <a:noAutofit/>
+          </a:bodyPr>
+          <a:lstStyle/>
+          <a:p>
+            <a:pPr algn="ctr"/>
+            <a:endParaRPr lang="en-US"/>
+          </a:p>
+        </p:txBody>
+      </p:sp>
       <p:sp>
         <p:nvSpPr>
           <p:cNvPr id="2" name="Title 1"/>
@@ -1143,67 +4943,63 @@
             <p:ph type="title"/>
           </p:nvPr>
         </p:nvSpPr>
-        <p:spPr/>
+        <p:spPr>
+          <a:xfrm>
+            <a:off x="838200" y="673770"/>
+            <a:ext cx="3220329" cy="2027227"/>
+          </a:xfrm>
+        </p:spPr>
         <p:txBody>
-          <a:bodyPr/>
+          <a:bodyPr vert="horz" lIns="91440" tIns="45720" rIns="91440" bIns="45720" rtlCol="0">
+            <a:normAutofit/>
+          </a:bodyPr>
           <a:lstStyle/>
           <a:p>
             <a:r>
-              <a:rPr lang="en-US" dirty="0"/>
+              <a:rPr lang="en-US" sz="3800" kern="1200">
+                <a:solidFill>
+                  <a:srgbClr val="FFFFFF"/>
+                </a:solidFill>
+                <a:latin typeface="+mj-lt"/>
+                <a:ea typeface="+mj-ea"/>
+                <a:cs typeface="+mj-cs"/>
+              </a:rPr>
               <a:t>The Boom-and-Bust Pattern in AI History</a:t>
             </a:r>
           </a:p>
         </p:txBody>
       </p:sp>
-      <p:sp>
-        <p:nvSpPr>
-          <p:cNvPr id="3" name="Content Placeholder 2"/>
-          <p:cNvSpPr>
-            <a:spLocks noGrp="1"/>
-          </p:cNvSpPr>
+      <p:graphicFrame>
+        <p:nvGraphicFramePr>
+          <p:cNvPr id="5" name="Content Placeholder 2">
+            <a:extLst>
+              <a:ext uri="{FF2B5EF4-FFF2-40B4-BE49-F238E27FC236}">
+                <a16:creationId xmlns:a16="http://schemas.microsoft.com/office/drawing/2014/main" id="{211F876E-7314-B580-D494-0D77F83517AE}"/>
+              </a:ext>
+            </a:extLst>
+          </p:cNvPr>
+          <p:cNvGraphicFramePr>
+            <a:graphicFrameLocks noGrp="1"/>
+          </p:cNvGraphicFramePr>
           <p:nvPr>
             <p:ph idx="1"/>
+            <p:extLst>
+              <p:ext uri="{D42A27DB-BD31-4B8C-83A1-F6EECF244321}">
+                <p14:modId xmlns:p14="http://schemas.microsoft.com/office/powerpoint/2010/main" val="968122075"/>
+              </p:ext>
+            </p:extLst>
           </p:nvPr>
-        </p:nvSpPr>
-        <p:spPr/>
-        <p:txBody>
-          <a:bodyPr/>
-          <a:lstStyle/>
-          <a:p>
-            <a:r>
-              <a:rPr lang="en-US" dirty="0"/>
-              <a:t>AI progress is cyclical, not a straight upward line</a:t>
-            </a:r>
-          </a:p>
-          <a:p>
-            <a:r>
-              <a:rPr lang="en-US" dirty="0"/>
-              <a:t>Cycle: breakthrough, hype, overpromise, disappointment, funding collapse</a:t>
-            </a:r>
-          </a:p>
-          <a:p>
-            <a:r>
-              <a:rPr lang="en-US" dirty="0"/>
-              <a:t>'AI winter' means sustained cuts in funding and interest</a:t>
-            </a:r>
-          </a:p>
-          <a:p>
-            <a:r>
-              <a:rPr lang="en-US" dirty="0"/>
-              <a:t>Pattern repeats because expectations outrun technical reality</a:t>
-            </a:r>
-          </a:p>
-          <a:p>
-            <a:r>
-              <a:rPr lang="en-US" dirty="0"/>
-              <a:t>Understanding cycles explains today's field structure and vocabulary</a:t>
-            </a:r>
-          </a:p>
-          <a:p>
-            <a:endParaRPr lang="en-US" dirty="0"/>
-          </a:p>
-        </p:txBody>
-      </p:sp>
+        </p:nvGraphicFramePr>
+        <p:xfrm>
+          <a:off x="5542672" y="541606"/>
+          <a:ext cx="5811128" cy="5678219"/>
+        </p:xfrm>
+        <a:graphic>
+          <a:graphicData uri="http://schemas.openxmlformats.org/drawingml/2006/diagram">
+            <dgm:relIds xmlns:dgm="http://schemas.openxmlformats.org/drawingml/2006/diagram" xmlns:r="http://schemas.openxmlformats.org/officeDocument/2006/relationships" r:dm="rId3" r:lo="rId4" r:qs="rId5" r:cs="rId6"/>
+          </a:graphicData>
+        </a:graphic>
+      </p:graphicFrame>
     </p:spTree>
   </p:cSld>
   <p:clrMapOvr>
@@ -1793,10 +5589,10 @@
   <a:themeElements>
     <a:clrScheme name="Office">
       <a:dk1>
-        <a:sysClr lastClr="000000" val="windowText"/>
+        <a:sysClr val="windowText" lastClr="000000"/>
       </a:dk1>
       <a:lt1>
-        <a:sysClr lastClr="ffffff" val="window"/>
+        <a:sysClr val="window" lastClr="FFFFFF"/>
       </a:lt1>
       <a:dk2>
         <a:srgbClr val="44546A"/>
@@ -1941,6 +5737,8 @@
       </a:bgFillStyleLst>
     </a:fmtScheme>
   </a:themeElements>
+  <a:objectDefaults/>
+  <a:extraClrSchemeLst/>
 </a:theme>
 </file>
 
@@ -1949,10 +5747,10 @@
   <a:themeElements>
     <a:clrScheme name="Office">
       <a:dk1>
-        <a:sysClr lastClr="000000" val="windowText"/>
+        <a:sysClr val="windowText" lastClr="000000"/>
       </a:dk1>
       <a:lt1>
-        <a:sysClr lastClr="ffffff" val="window"/>
+        <a:sysClr val="window" lastClr="FFFFFF"/>
       </a:lt1>
       <a:dk2>
         <a:srgbClr val="44546A"/>
@@ -2097,5 +5895,13 @@
       </a:bgFillStyleLst>
     </a:fmtScheme>
   </a:themeElements>
+  <a:objectDefaults/>
+  <a:extraClrSchemeLst/>
 </a:theme>
+</file>
+
+<file path=docMetadata/LabelInfo.xml><?xml version="1.0" encoding="utf-8"?>
+<clbl:labelList xmlns:clbl="http://schemas.microsoft.com/office/2020/mipLabelMetadata">
+  <clbl:label id="{f8b35114-6079-4276-ac22-ae80d1dfba98}" enabled="0" method="" siteId="{f8b35114-6079-4276-ac22-ae80d1dfba98}" removed="1"/>
+</clbl:labelList>
 </file>
</xml_diff>